<commit_message>
Update Tema 1 and Tema 2 presentation slides.
Co-authored-by: Cursor <cursoragent@cursor.com>
</commit_message>
<xml_diff>
--- a/Tema 1/paper/Tema1.pptx
+++ b/Tema 1/paper/Tema1.pptx
@@ -1890,13 +1890,13 @@
             <a:gsLst>
               <a:gs pos="0">
                 <a:schemeClr val="accent1">
-                  <a:lumMod val="75000"/>
+                  <a:lumMod val="50000"/>
                 </a:schemeClr>
               </a:gs>
               <a:gs pos="88000">
                 <a:schemeClr val="accent1">
-                  <a:lumMod val="40000"/>
-                  <a:lumOff val="60000"/>
+                  <a:lumMod val="60000"/>
+                  <a:lumOff val="40000"/>
                 </a:schemeClr>
               </a:gs>
             </a:gsLst>
@@ -9670,7 +9670,7 @@
                 <a:cs typeface="Arial"/>
                 <a:sym typeface="Arial"/>
               </a:rPr>
-              <a:t>Electrostatic ballooning of spiders</a:t>
+              <a:t>Electrostatic Ballooning of Spiders</a:t>
             </a:r>
           </a:p>
         </p:txBody>
@@ -9986,7 +9986,7 @@
         <p:spPr>
           <a:xfrm>
             <a:off x="1174981" y="1288360"/>
-            <a:ext cx="5046830" cy="2769989"/>
+            <a:ext cx="5046830" cy="4739759"/>
           </a:xfrm>
           <a:prstGeom prst="rect">
             <a:avLst/>
@@ -10013,7 +10013,7 @@
                   </a:schemeClr>
                 </a:solidFill>
               </a:rPr>
-              <a:t>A</a:t>
+              <a:t>A   PHYSICAL MODEL</a:t>
             </a:r>
           </a:p>
           <a:p>
@@ -10064,7 +10064,7 @@
                   </a:schemeClr>
                 </a:solidFill>
               </a:rPr>
-              <a:t>B</a:t>
+              <a:t>B   NEAR SURFACE TURBULENCE</a:t>
             </a:r>
           </a:p>
           <a:p>
@@ -10115,7 +10115,7 @@
                   </a:schemeClr>
                 </a:solidFill>
               </a:rPr>
-              <a:t>C</a:t>
+              <a:t>C   ANALITICAL SOLUTION</a:t>
             </a:r>
           </a:p>
           <a:p>
@@ -10135,6 +10135,113 @@
               </a:rPr>
               <a:t>…</a:t>
             </a:r>
+          </a:p>
+          <a:p>
+            <a:pPr>
+              <a:buClr>
+                <a:srgbClr val="000000"/>
+              </a:buClr>
+              <a:defRPr/>
+            </a:pPr>
+            <a:endParaRPr lang="en-US" sz="2000" kern="0" dirty="0">
+              <a:solidFill>
+                <a:srgbClr val="000000"/>
+              </a:solidFill>
+              <a:latin typeface="Arial"/>
+              <a:cs typeface="Arial"/>
+            </a:endParaRPr>
+          </a:p>
+          <a:p>
+            <a:pPr>
+              <a:buClr>
+                <a:srgbClr val="000000"/>
+              </a:buClr>
+              <a:defRPr/>
+            </a:pPr>
+            <a:r>
+              <a:rPr lang="en-US" sz="2000" b="1" dirty="0">
+                <a:solidFill>
+                  <a:schemeClr val="accent5">
+                    <a:lumMod val="50000"/>
+                  </a:schemeClr>
+                </a:solidFill>
+              </a:rPr>
+              <a:t>D   NUMERICAL METHOD</a:t>
+            </a:r>
+          </a:p>
+          <a:p>
+            <a:pPr>
+              <a:buClr>
+                <a:srgbClr val="000000"/>
+              </a:buClr>
+              <a:defRPr/>
+            </a:pPr>
+            <a:r>
+              <a:rPr lang="en-US" sz="2400" kern="0" dirty="0">
+                <a:solidFill>
+                  <a:srgbClr val="000000"/>
+                </a:solidFill>
+                <a:cs typeface="Arial"/>
+              </a:rPr>
+              <a:t>…</a:t>
+            </a:r>
+          </a:p>
+          <a:p>
+            <a:pPr>
+              <a:buClr>
+                <a:srgbClr val="000000"/>
+              </a:buClr>
+              <a:defRPr/>
+            </a:pPr>
+            <a:endParaRPr lang="en-US" sz="2000" kern="0" dirty="0">
+              <a:solidFill>
+                <a:srgbClr val="000000"/>
+              </a:solidFill>
+              <a:latin typeface="Arial"/>
+              <a:cs typeface="Arial"/>
+            </a:endParaRPr>
+          </a:p>
+          <a:p>
+            <a:pPr>
+              <a:buClr>
+                <a:srgbClr val="000000"/>
+              </a:buClr>
+              <a:defRPr/>
+            </a:pPr>
+            <a:r>
+              <a:rPr lang="en-US" sz="2000" b="1" dirty="0">
+                <a:solidFill>
+                  <a:schemeClr val="accent5">
+                    <a:lumMod val="50000"/>
+                  </a:schemeClr>
+                </a:solidFill>
+              </a:rPr>
+              <a:t>E   RESULTS</a:t>
+            </a:r>
+          </a:p>
+          <a:p>
+            <a:pPr>
+              <a:buClr>
+                <a:srgbClr val="000000"/>
+              </a:buClr>
+              <a:defRPr/>
+            </a:pPr>
+            <a:r>
+              <a:rPr lang="en-US" sz="2400" kern="0" dirty="0">
+                <a:solidFill>
+                  <a:srgbClr val="000000"/>
+                </a:solidFill>
+                <a:cs typeface="Arial"/>
+              </a:rPr>
+              <a:t>…</a:t>
+            </a:r>
+            <a:endParaRPr lang="en-US" sz="2000" kern="0" dirty="0">
+              <a:solidFill>
+                <a:srgbClr val="000000"/>
+              </a:solidFill>
+              <a:latin typeface="Arial"/>
+              <a:cs typeface="Arial"/>
+            </a:endParaRPr>
           </a:p>
           <a:p>
             <a:pPr>
@@ -10242,7 +10349,7 @@
                   <a:schemeClr val="bg1"/>
                 </a:solidFill>
               </a:rPr>
-              <a:t>Graph Neural Networks</a:t>
+              <a:t>Ballooning of Spiders</a:t>
             </a:r>
             <a:endParaRPr lang="ro-RO" dirty="0">
               <a:solidFill>
@@ -10266,8 +10373,8 @@
         </p:nvSpPr>
         <p:spPr>
           <a:xfrm>
-            <a:off x="4295377" y="3200400"/>
-            <a:ext cx="3173689" cy="646331"/>
+            <a:off x="4144651" y="3180303"/>
+            <a:ext cx="3612676" cy="646331"/>
           </a:xfrm>
           <a:prstGeom prst="rect">
             <a:avLst/>
@@ -10282,11 +10389,57 @@
           <a:p>
             <a:r>
               <a:rPr lang="en-US" sz="3600" b="1" dirty="0"/>
-              <a:t>Why Graphs?</a:t>
+              <a:t>Physical Model</a:t>
             </a:r>
           </a:p>
         </p:txBody>
       </p:sp>
+      <p:pic>
+        <p:nvPicPr>
+          <p:cNvPr id="2" name="Picture 1">
+            <a:extLst>
+              <a:ext uri="{FF2B5EF4-FFF2-40B4-BE49-F238E27FC236}">
+                <a16:creationId xmlns:a16="http://schemas.microsoft.com/office/drawing/2014/main" id="{CEE103B0-0EF3-4C4D-553F-486C8D50679E}"/>
+              </a:ext>
+            </a:extLst>
+          </p:cNvPr>
+          <p:cNvPicPr>
+            <a:picLocks noChangeAspect="1"/>
+          </p:cNvPicPr>
+          <p:nvPr/>
+        </p:nvPicPr>
+        <p:blipFill>
+          <a:blip r:embed="rId2">
+            <a:clrChange>
+              <a:clrFrom>
+                <a:srgbClr val="000000"/>
+              </a:clrFrom>
+              <a:clrTo>
+                <a:srgbClr val="000000">
+                  <a:alpha val="0"/>
+                </a:srgbClr>
+              </a:clrTo>
+            </a:clrChange>
+            <a:extLst>
+              <a:ext uri="{28A0092B-C50C-407E-A947-70E740481C1C}">
+                <a14:useLocalDpi xmlns:a14="http://schemas.microsoft.com/office/drawing/2010/main" val="0"/>
+              </a:ext>
+            </a:extLst>
+          </a:blip>
+          <a:stretch>
+            <a:fillRect/>
+          </a:stretch>
+        </p:blipFill>
+        <p:spPr>
+          <a:xfrm>
+            <a:off x="10432471" y="6323329"/>
+            <a:ext cx="1492133" cy="496892"/>
+          </a:xfrm>
+          <a:prstGeom prst="rect">
+            <a:avLst/>
+          </a:prstGeom>
+        </p:spPr>
+      </p:pic>
     </p:spTree>
     <p:extLst>
       <p:ext uri="{BB962C8B-B14F-4D97-AF65-F5344CB8AC3E}">
@@ -10346,7 +10499,7 @@
                   <a:schemeClr val="bg1"/>
                 </a:solidFill>
               </a:rPr>
-              <a:t>Why Graphs?</a:t>
+              <a:t>Physical Model</a:t>
             </a:r>
             <a:endParaRPr lang="ro-RO" dirty="0">
               <a:solidFill>
@@ -10371,7 +10524,7 @@
         <p:spPr>
           <a:xfrm>
             <a:off x="889810" y="1300345"/>
-            <a:ext cx="8388174" cy="707886"/>
+            <a:ext cx="8388174" cy="400110"/>
           </a:xfrm>
           <a:prstGeom prst="rect">
             <a:avLst/>
@@ -10412,7 +10565,7 @@
                 <a:cs typeface="Arial"/>
                 <a:sym typeface="Arial"/>
               </a:rPr>
-              <a:t>Graphs are a general language for describing and analyzing entities </a:t>
+              <a:t>Some text here </a:t>
             </a:r>
             <a:r>
               <a:rPr lang="en-US" sz="2000" kern="0" dirty="0">
@@ -10425,7 +10578,7 @@
                 <a:cs typeface="Arial"/>
                 <a:sym typeface="Arial"/>
               </a:rPr>
-              <a:t>with relations / interactions.</a:t>
+              <a:t>…</a:t>
             </a:r>
             <a:r>
               <a:rPr kumimoji="0" lang="en-US" sz="2000" b="1" i="0" u="none" strike="noStrike" kern="0" cap="none" spc="0" normalizeH="0" baseline="0" noProof="0" dirty="0">
@@ -10461,347 +10614,6 @@
           </a:p>
         </p:txBody>
       </p:sp>
-      <p:pic>
-        <p:nvPicPr>
-          <p:cNvPr id="2" name="Picture 2">
-            <a:extLst>
-              <a:ext uri="{FF2B5EF4-FFF2-40B4-BE49-F238E27FC236}">
-                <a16:creationId xmlns:a16="http://schemas.microsoft.com/office/drawing/2014/main" id="{7FB90733-1E30-2070-4675-66508C611EF1}"/>
-              </a:ext>
-            </a:extLst>
-          </p:cNvPr>
-          <p:cNvPicPr>
-            <a:picLocks noChangeAspect="1" noChangeArrowheads="1"/>
-          </p:cNvPicPr>
-          <p:nvPr/>
-        </p:nvPicPr>
-        <p:blipFill>
-          <a:blip r:embed="rId2">
-            <a:extLst>
-              <a:ext uri="{28A0092B-C50C-407E-A947-70E740481C1C}">
-                <a14:useLocalDpi xmlns:a14="http://schemas.microsoft.com/office/drawing/2010/main" val="0"/>
-              </a:ext>
-            </a:extLst>
-          </a:blip>
-          <a:srcRect/>
-          <a:stretch>
-            <a:fillRect/>
-          </a:stretch>
-        </p:blipFill>
-        <p:spPr bwMode="auto">
-          <a:xfrm>
-            <a:off x="8428037" y="2167238"/>
-            <a:ext cx="3323642" cy="2861896"/>
-          </a:xfrm>
-          <a:prstGeom prst="rect">
-            <a:avLst/>
-          </a:prstGeom>
-          <a:noFill/>
-          <a:extLst>
-            <a:ext uri="{909E8E84-426E-40DD-AFC4-6F175D3DCCD1}">
-              <a14:hiddenFill xmlns:a14="http://schemas.microsoft.com/office/drawing/2010/main">
-                <a:solidFill>
-                  <a:srgbClr val="FFFFFF"/>
-                </a:solidFill>
-              </a14:hiddenFill>
-            </a:ext>
-          </a:extLst>
-        </p:spPr>
-      </p:pic>
-      <p:sp>
-        <p:nvSpPr>
-          <p:cNvPr id="9" name="TextBox 8">
-            <a:extLst>
-              <a:ext uri="{FF2B5EF4-FFF2-40B4-BE49-F238E27FC236}">
-                <a16:creationId xmlns:a16="http://schemas.microsoft.com/office/drawing/2014/main" id="{463892A1-0B3D-B324-49A8-2AED699CE2F9}"/>
-              </a:ext>
-            </a:extLst>
-          </p:cNvPr>
-          <p:cNvSpPr txBox="1"/>
-          <p:nvPr/>
-        </p:nvSpPr>
-        <p:spPr>
-          <a:xfrm>
-            <a:off x="889810" y="2510681"/>
-            <a:ext cx="6373325" cy="369332"/>
-          </a:xfrm>
-          <a:prstGeom prst="rect">
-            <a:avLst/>
-          </a:prstGeom>
-          <a:noFill/>
-        </p:spPr>
-        <p:txBody>
-          <a:bodyPr wrap="square">
-            <a:spAutoFit/>
-          </a:bodyPr>
-          <a:lstStyle/>
-          <a:p>
-            <a:pPr algn="l"/>
-            <a:r>
-              <a:rPr lang="en-US" dirty="0">
-                <a:solidFill>
-                  <a:srgbClr val="000000"/>
-                </a:solidFill>
-                <a:highlight>
-                  <a:srgbClr val="FFFFFF"/>
-                </a:highlight>
-                <a:latin typeface="Lucida Grande"/>
-              </a:rPr>
-              <a:t>G</a:t>
-            </a:r>
-            <a:r>
-              <a:rPr lang="en-US" b="0" i="0" dirty="0">
-                <a:solidFill>
-                  <a:srgbClr val="000000"/>
-                </a:solidFill>
-                <a:effectLst/>
-                <a:highlight>
-                  <a:srgbClr val="FFFFFF"/>
-                </a:highlight>
-                <a:latin typeface="Lucida Grande"/>
-              </a:rPr>
-              <a:t>raphs are the main modality of data we receive from nature.</a:t>
-            </a:r>
-            <a:endParaRPr lang="en-US" b="1" i="0" dirty="0">
-              <a:solidFill>
-                <a:srgbClr val="000000"/>
-              </a:solidFill>
-              <a:effectLst/>
-              <a:highlight>
-                <a:srgbClr val="FFFFFF"/>
-              </a:highlight>
-              <a:latin typeface="Lucida Grande"/>
-            </a:endParaRPr>
-          </a:p>
-        </p:txBody>
-      </p:sp>
-      <p:sp>
-        <p:nvSpPr>
-          <p:cNvPr id="11" name="TextBox 10">
-            <a:extLst>
-              <a:ext uri="{FF2B5EF4-FFF2-40B4-BE49-F238E27FC236}">
-                <a16:creationId xmlns:a16="http://schemas.microsoft.com/office/drawing/2014/main" id="{94FE89DB-5DCE-7391-C0B5-3319C8D10F1C}"/>
-              </a:ext>
-            </a:extLst>
-          </p:cNvPr>
-          <p:cNvSpPr txBox="1"/>
-          <p:nvPr/>
-        </p:nvSpPr>
-        <p:spPr>
-          <a:xfrm>
-            <a:off x="889810" y="3245933"/>
-            <a:ext cx="7148861" cy="1200329"/>
-          </a:xfrm>
-          <a:prstGeom prst="rect">
-            <a:avLst/>
-          </a:prstGeom>
-          <a:noFill/>
-        </p:spPr>
-        <p:txBody>
-          <a:bodyPr wrap="square">
-            <a:spAutoFit/>
-          </a:bodyPr>
-          <a:lstStyle/>
-          <a:p>
-            <a:r>
-              <a:rPr lang="en-US" i="1" u="sng" dirty="0"/>
-              <a:t>Examples</a:t>
-            </a:r>
-            <a:r>
-              <a:rPr lang="en-US" dirty="0"/>
-              <a:t>:</a:t>
-            </a:r>
-          </a:p>
-          <a:p>
-            <a:r>
-              <a:rPr lang="en-US" dirty="0"/>
-              <a:t>	</a:t>
-            </a:r>
-            <a:r>
-              <a:rPr lang="en-US" i="1" dirty="0"/>
-              <a:t>Molecule</a:t>
-            </a:r>
-            <a:r>
-              <a:rPr lang="en-US" dirty="0"/>
-              <a:t> - a graph of atoms connected by chemical bonds.</a:t>
-            </a:r>
-          </a:p>
-          <a:p>
-            <a:r>
-              <a:rPr lang="en-US" dirty="0"/>
-              <a:t>	</a:t>
-            </a:r>
-            <a:r>
-              <a:rPr lang="en-US" i="1" dirty="0"/>
-              <a:t>Brain</a:t>
-            </a:r>
-            <a:r>
-              <a:rPr lang="en-US" dirty="0"/>
-              <a:t> - a graph of neurons connected by synapses.</a:t>
-            </a:r>
-          </a:p>
-          <a:p>
-            <a:r>
-              <a:rPr lang="en-US" dirty="0"/>
-              <a:t>	</a:t>
-            </a:r>
-            <a:r>
-              <a:rPr lang="en-US" i="1" dirty="0"/>
-              <a:t>Food Web </a:t>
-            </a:r>
-            <a:r>
-              <a:rPr lang="en-US" dirty="0"/>
-              <a:t>- feeding relationships within a community.</a:t>
-            </a:r>
-            <a:endParaRPr lang="ro-RO" dirty="0"/>
-          </a:p>
-        </p:txBody>
-      </p:sp>
-      <p:grpSp>
-        <p:nvGrpSpPr>
-          <p:cNvPr id="20" name="Group 19">
-            <a:extLst>
-              <a:ext uri="{FF2B5EF4-FFF2-40B4-BE49-F238E27FC236}">
-                <a16:creationId xmlns:a16="http://schemas.microsoft.com/office/drawing/2014/main" id="{D8B405BC-40CF-6C09-96AC-776E40C9BD46}"/>
-              </a:ext>
-            </a:extLst>
-          </p:cNvPr>
-          <p:cNvGrpSpPr/>
-          <p:nvPr/>
-        </p:nvGrpSpPr>
-        <p:grpSpPr>
-          <a:xfrm>
-            <a:off x="2872494" y="5029134"/>
-            <a:ext cx="3223506" cy="1235409"/>
-            <a:chOff x="540458" y="4535183"/>
-            <a:chExt cx="3223506" cy="1235409"/>
-          </a:xfrm>
-        </p:grpSpPr>
-        <p:sp>
-          <p:nvSpPr>
-            <p:cNvPr id="15" name="Rectangle: Rounded Corners 14">
-              <a:extLst>
-                <a:ext uri="{FF2B5EF4-FFF2-40B4-BE49-F238E27FC236}">
-                  <a16:creationId xmlns:a16="http://schemas.microsoft.com/office/drawing/2014/main" id="{EA962DE9-0FA3-3F8F-A953-8C58FEED8AAD}"/>
-                </a:ext>
-              </a:extLst>
-            </p:cNvPr>
-            <p:cNvSpPr/>
-            <p:nvPr/>
-          </p:nvSpPr>
-          <p:spPr>
-            <a:xfrm>
-              <a:off x="540458" y="4535183"/>
-              <a:ext cx="3223506" cy="1235409"/>
-            </a:xfrm>
-            <a:prstGeom prst="roundRect">
-              <a:avLst/>
-            </a:prstGeom>
-          </p:spPr>
-          <p:style>
-            <a:lnRef idx="2">
-              <a:schemeClr val="accent6"/>
-            </a:lnRef>
-            <a:fillRef idx="1">
-              <a:schemeClr val="lt1"/>
-            </a:fillRef>
-            <a:effectRef idx="0">
-              <a:schemeClr val="accent6"/>
-            </a:effectRef>
-            <a:fontRef idx="minor">
-              <a:schemeClr val="dk1"/>
-            </a:fontRef>
-          </p:style>
-          <p:txBody>
-            <a:bodyPr rtlCol="0" anchor="ctr"/>
-            <a:lstStyle/>
-            <a:p>
-              <a:pPr algn="ctr"/>
-              <a:endParaRPr lang="ro-RO"/>
-            </a:p>
-          </p:txBody>
-        </p:sp>
-        <p:sp>
-          <p:nvSpPr>
-            <p:cNvPr id="16" name="TextBox 15">
-              <a:extLst>
-                <a:ext uri="{FF2B5EF4-FFF2-40B4-BE49-F238E27FC236}">
-                  <a16:creationId xmlns:a16="http://schemas.microsoft.com/office/drawing/2014/main" id="{DC1350AC-F8AA-8E20-7707-D63C719B3D31}"/>
-                </a:ext>
-              </a:extLst>
-            </p:cNvPr>
-            <p:cNvSpPr txBox="1"/>
-            <p:nvPr/>
-          </p:nvSpPr>
-          <p:spPr>
-            <a:xfrm>
-              <a:off x="1757353" y="4807624"/>
-              <a:ext cx="1918628" cy="707886"/>
-            </a:xfrm>
-            <a:prstGeom prst="rect">
-              <a:avLst/>
-            </a:prstGeom>
-            <a:noFill/>
-          </p:spPr>
-          <p:txBody>
-            <a:bodyPr wrap="square" rtlCol="0">
-              <a:spAutoFit/>
-            </a:bodyPr>
-            <a:lstStyle/>
-            <a:p>
-              <a:r>
-                <a:rPr lang="en-US" sz="2000" i="1" dirty="0">
-                  <a:solidFill>
-                    <a:schemeClr val="accent6">
-                      <a:lumMod val="75000"/>
-                    </a:schemeClr>
-                  </a:solidFill>
-                </a:rPr>
-                <a:t>Everything is Connected !</a:t>
-              </a:r>
-            </a:p>
-          </p:txBody>
-        </p:sp>
-        <p:pic>
-          <p:nvPicPr>
-            <p:cNvPr id="19" name="Graphic 18" descr="Radar Chart outline">
-              <a:extLst>
-                <a:ext uri="{FF2B5EF4-FFF2-40B4-BE49-F238E27FC236}">
-                  <a16:creationId xmlns:a16="http://schemas.microsoft.com/office/drawing/2014/main" id="{E1188CB9-883E-E61F-5738-AB907CAA769F}"/>
-                </a:ext>
-              </a:extLst>
-            </p:cNvPr>
-            <p:cNvPicPr>
-              <a:picLocks noChangeAspect="1"/>
-            </p:cNvPicPr>
-            <p:nvPr/>
-          </p:nvPicPr>
-          <p:blipFill>
-            <a:blip>
-              <a:extLst>
-                <a:ext uri="{28A0092B-C50C-407E-A947-70E740481C1C}">
-                  <a14:useLocalDpi xmlns:a14="http://schemas.microsoft.com/office/drawing/2010/main" val="0"/>
-                </a:ext>
-                <a:ext uri="{96DAC541-7B7A-43D3-8B79-37D633B846F1}">
-                  <asvg:svgBlip xmlns:asvg="http://schemas.microsoft.com/office/drawing/2016/SVG/main" r:embed="rId3"/>
-                </a:ext>
-              </a:extLst>
-            </a:blip>
-            <a:stretch>
-              <a:fillRect/>
-            </a:stretch>
-          </p:blipFill>
-          <p:spPr>
-            <a:xfrm>
-              <a:off x="691705" y="4695687"/>
-              <a:ext cx="914400" cy="914400"/>
-            </a:xfrm>
-            <a:prstGeom prst="rect">
-              <a:avLst/>
-            </a:prstGeom>
-          </p:spPr>
-        </p:pic>
-      </p:grpSp>
       <p:pic>
         <p:nvPicPr>
           <p:cNvPr id="5" name="Picture 4">
@@ -10817,7 +10629,7 @@
           <p:nvPr/>
         </p:nvPicPr>
         <p:blipFill>
-          <a:blip r:embed="rId4">
+          <a:blip r:embed="rId2">
             <a:clrChange>
               <a:clrFrom>
                 <a:srgbClr val="000000"/>
@@ -10848,6 +10660,36 @@
           </a:prstGeom>
         </p:spPr>
       </p:pic>
+      <p:pic>
+        <p:nvPicPr>
+          <p:cNvPr id="7" name="Picture 6">
+            <a:extLst>
+              <a:ext uri="{FF2B5EF4-FFF2-40B4-BE49-F238E27FC236}">
+                <a16:creationId xmlns:a16="http://schemas.microsoft.com/office/drawing/2014/main" id="{A85EABDB-53B3-BBA9-DD2E-A404912D054A}"/>
+              </a:ext>
+            </a:extLst>
+          </p:cNvPr>
+          <p:cNvPicPr>
+            <a:picLocks noChangeAspect="1"/>
+          </p:cNvPicPr>
+          <p:nvPr/>
+        </p:nvPicPr>
+        <p:blipFill>
+          <a:blip r:embed="rId3"/>
+          <a:stretch>
+            <a:fillRect/>
+          </a:stretch>
+        </p:blipFill>
+        <p:spPr>
+          <a:xfrm>
+            <a:off x="2128582" y="2473701"/>
+            <a:ext cx="7772400" cy="3083954"/>
+          </a:xfrm>
+          <a:prstGeom prst="rect">
+            <a:avLst/>
+          </a:prstGeom>
+        </p:spPr>
+      </p:pic>
     </p:spTree>
     <p:extLst>
       <p:ext uri="{BB962C8B-B14F-4D97-AF65-F5344CB8AC3E}">
@@ -10858,157 +10700,6 @@
   <p:clrMapOvr>
     <a:masterClrMapping/>
   </p:clrMapOvr>
-  <p:timing>
-    <p:tnLst>
-      <p:par>
-        <p:cTn id="1" dur="indefinite" restart="never" nodeType="tmRoot">
-          <p:childTnLst>
-            <p:seq concurrent="1" nextAc="seek">
-              <p:cTn id="2" dur="indefinite" nodeType="mainSeq">
-                <p:childTnLst>
-                  <p:par>
-                    <p:cTn id="3" fill="hold">
-                      <p:stCondLst>
-                        <p:cond delay="indefinite"/>
-                      </p:stCondLst>
-                      <p:childTnLst>
-                        <p:par>
-                          <p:cTn id="4" fill="hold">
-                            <p:stCondLst>
-                              <p:cond delay="0"/>
-                            </p:stCondLst>
-                            <p:childTnLst>
-                              <p:par>
-                                <p:cTn id="5" presetID="1" presetClass="entr" presetSubtype="0" fill="hold" grpId="0" nodeType="clickEffect">
-                                  <p:stCondLst>
-                                    <p:cond delay="0"/>
-                                  </p:stCondLst>
-                                  <p:childTnLst>
-                                    <p:set>
-                                      <p:cBhvr>
-                                        <p:cTn id="6" dur="1" fill="hold">
-                                          <p:stCondLst>
-                                            <p:cond delay="0"/>
-                                          </p:stCondLst>
-                                        </p:cTn>
-                                        <p:tgtEl>
-                                          <p:spTgt spid="9"/>
-                                        </p:tgtEl>
-                                        <p:attrNameLst>
-                                          <p:attrName>style.visibility</p:attrName>
-                                        </p:attrNameLst>
-                                      </p:cBhvr>
-                                      <p:to>
-                                        <p:strVal val="visible"/>
-                                      </p:to>
-                                    </p:set>
-                                  </p:childTnLst>
-                                </p:cTn>
-                              </p:par>
-                              <p:par>
-                                <p:cTn id="7" presetID="1" presetClass="entr" presetSubtype="0" fill="hold" grpId="0" nodeType="withEffect">
-                                  <p:stCondLst>
-                                    <p:cond delay="0"/>
-                                  </p:stCondLst>
-                                  <p:childTnLst>
-                                    <p:set>
-                                      <p:cBhvr>
-                                        <p:cTn id="8" dur="1" fill="hold">
-                                          <p:stCondLst>
-                                            <p:cond delay="0"/>
-                                          </p:stCondLst>
-                                        </p:cTn>
-                                        <p:tgtEl>
-                                          <p:spTgt spid="11"/>
-                                        </p:tgtEl>
-                                        <p:attrNameLst>
-                                          <p:attrName>style.visibility</p:attrName>
-                                        </p:attrNameLst>
-                                      </p:cBhvr>
-                                      <p:to>
-                                        <p:strVal val="visible"/>
-                                      </p:to>
-                                    </p:set>
-                                  </p:childTnLst>
-                                </p:cTn>
-                              </p:par>
-                            </p:childTnLst>
-                          </p:cTn>
-                        </p:par>
-                      </p:childTnLst>
-                    </p:cTn>
-                  </p:par>
-                  <p:par>
-                    <p:cTn id="9" fill="hold">
-                      <p:stCondLst>
-                        <p:cond delay="indefinite"/>
-                      </p:stCondLst>
-                      <p:childTnLst>
-                        <p:par>
-                          <p:cTn id="10" fill="hold">
-                            <p:stCondLst>
-                              <p:cond delay="0"/>
-                            </p:stCondLst>
-                            <p:childTnLst>
-                              <p:par>
-                                <p:cTn id="11" presetID="1" presetClass="entr" presetSubtype="0" fill="hold" nodeType="clickEffect">
-                                  <p:stCondLst>
-                                    <p:cond delay="0"/>
-                                  </p:stCondLst>
-                                  <p:childTnLst>
-                                    <p:set>
-                                      <p:cBhvr>
-                                        <p:cTn id="12" dur="1" fill="hold">
-                                          <p:stCondLst>
-                                            <p:cond delay="0"/>
-                                          </p:stCondLst>
-                                        </p:cTn>
-                                        <p:tgtEl>
-                                          <p:spTgt spid="20"/>
-                                        </p:tgtEl>
-                                        <p:attrNameLst>
-                                          <p:attrName>style.visibility</p:attrName>
-                                        </p:attrNameLst>
-                                      </p:cBhvr>
-                                      <p:to>
-                                        <p:strVal val="visible"/>
-                                      </p:to>
-                                    </p:set>
-                                  </p:childTnLst>
-                                </p:cTn>
-                              </p:par>
-                            </p:childTnLst>
-                          </p:cTn>
-                        </p:par>
-                      </p:childTnLst>
-                    </p:cTn>
-                  </p:par>
-                </p:childTnLst>
-              </p:cTn>
-              <p:prevCondLst>
-                <p:cond evt="onPrev" delay="0">
-                  <p:tgtEl>
-                    <p:sldTgt/>
-                  </p:tgtEl>
-                </p:cond>
-              </p:prevCondLst>
-              <p:nextCondLst>
-                <p:cond evt="onNext" delay="0">
-                  <p:tgtEl>
-                    <p:sldTgt/>
-                  </p:tgtEl>
-                </p:cond>
-              </p:nextCondLst>
-            </p:seq>
-          </p:childTnLst>
-        </p:cTn>
-      </p:par>
-    </p:tnLst>
-    <p:bldLst>
-      <p:bldP spid="9" grpId="0"/>
-      <p:bldP spid="11" grpId="0"/>
-    </p:bldLst>
-  </p:timing>
 </p:sld>
 </file>
 

</xml_diff>

<commit_message>
Update Tema 1 PowerPoint presentation.
Co-authored-by: Cursor <cursoragent@cursor.com>
</commit_message>
<xml_diff>
--- a/Tema 1/paper/Tema1.pptx
+++ b/Tema 1/paper/Tema1.pptx
@@ -353,7 +353,7 @@
     </p:spTree>
     <p:extLst>
       <p:ext uri="{BB962C8B-B14F-4D97-AF65-F5344CB8AC3E}">
-        <p14:creationId xmlns:p14="http://schemas.microsoft.com/office/powerpoint/2010/main" val="24838625"/>
+        <p14:creationId xmlns:p14="http://schemas.microsoft.com/office/powerpoint/2010/main" val="4096425265"/>
       </p:ext>
     </p:extLst>
   </p:cSld>
@@ -9695,7 +9695,7 @@
         </p:blipFill>
         <p:spPr>
           <a:xfrm>
-            <a:off x="10432471" y="6323329"/>
+            <a:off x="10536865" y="6354373"/>
             <a:ext cx="1492133" cy="496892"/>
           </a:xfrm>
           <a:prstGeom prst="rect">
@@ -9720,7 +9720,7 @@
             <p:spPr>
               <a:xfrm>
                 <a:off x="1318871" y="5202500"/>
-                <a:ext cx="2710422" cy="526683"/>
+                <a:ext cx="2922018" cy="526683"/>
               </a:xfrm>
               <a:prstGeom prst="rect">
                 <a:avLst/>
@@ -9790,6 +9790,27 @@
                           <a:latin typeface="Cambria Math" panose="02040503050406030204" pitchFamily="18" charset="0"/>
                         </a:rPr>
                         <m:t>T</m:t>
+                      </m:r>
+                      <m:r>
+                        <a:rPr lang="en-US" b="0" i="1" smtClean="0">
+                          <a:latin typeface="Cambria Math" panose="02040503050406030204" pitchFamily="18" charset="0"/>
+                        </a:rPr>
+                        <m:t>(</m:t>
+                      </m:r>
+                      <m:r>
+                        <m:rPr>
+                          <m:sty m:val="p"/>
+                        </m:rPr>
+                        <a:rPr lang="en-US" b="0" i="1" smtClean="0">
+                          <a:latin typeface="Cambria Math" panose="02040503050406030204" pitchFamily="18" charset="0"/>
+                        </a:rPr>
+                        <m:t>s</m:t>
+                      </m:r>
+                      <m:r>
+                        <a:rPr lang="en-US" b="0" i="1" smtClean="0">
+                          <a:latin typeface="Cambria Math" panose="02040503050406030204" pitchFamily="18" charset="0"/>
+                        </a:rPr>
+                        <m:t>)</m:t>
                       </m:r>
                       <m:acc>
                         <m:accPr>
@@ -10010,7 +10031,7 @@
             <p:spPr>
               <a:xfrm>
                 <a:off x="1318871" y="5202500"/>
-                <a:ext cx="2710422" cy="526683"/>
+                <a:ext cx="2922018" cy="526683"/>
               </a:xfrm>
               <a:prstGeom prst="rect">
                 <a:avLst/>
@@ -10018,7 +10039,7 @@
               <a:blipFill>
                 <a:blip r:embed="rId3"/>
                 <a:stretch>
-                  <a:fillRect t="-2326" b="-13953"/>
+                  <a:fillRect l="-1293" t="-2326" r="-862" b="-13953"/>
                 </a:stretch>
               </a:blipFill>
             </p:spPr>
@@ -10052,7 +10073,7 @@
         <p:spPr>
           <a:xfrm>
             <a:off x="5316279" y="4614530"/>
-            <a:ext cx="4805916" cy="1957245"/>
+            <a:ext cx="5220586" cy="1988289"/>
           </a:xfrm>
           <a:prstGeom prst="roundRect">
             <a:avLst/>
@@ -10130,8 +10151,8 @@
         </p:nvSpPr>
         <p:spPr>
           <a:xfrm>
-            <a:off x="5452729" y="5202500"/>
-            <a:ext cx="2213345" cy="307777"/>
+            <a:off x="5452729" y="5363614"/>
+            <a:ext cx="1671400" cy="307777"/>
           </a:xfrm>
           <a:prstGeom prst="rect">
             <a:avLst/>
@@ -10165,8 +10186,8 @@
         </p:nvSpPr>
         <p:spPr>
           <a:xfrm>
-            <a:off x="5452729" y="5790470"/>
-            <a:ext cx="2213345" cy="307777"/>
+            <a:off x="5452729" y="6015552"/>
+            <a:ext cx="1394638" cy="307777"/>
           </a:xfrm>
           <a:prstGeom prst="rect">
             <a:avLst/>
@@ -10216,6 +10237,1218 @@
           </a:prstGeom>
         </p:spPr>
       </p:pic>
+      <mc:AlternateContent xmlns:mc="http://schemas.openxmlformats.org/markup-compatibility/2006">
+        <mc:Choice xmlns:a14="http://schemas.microsoft.com/office/drawing/2010/main" Requires="a14">
+          <p:sp>
+            <p:nvSpPr>
+              <p:cNvPr id="12" name="TextBox 11">
+                <a:extLst>
+                  <a:ext uri="{FF2B5EF4-FFF2-40B4-BE49-F238E27FC236}">
+                    <a16:creationId xmlns:a16="http://schemas.microsoft.com/office/drawing/2014/main" id="{C6BAD141-779B-579E-06CE-1D769AEB18DD}"/>
+                  </a:ext>
+                </a:extLst>
+              </p:cNvPr>
+              <p:cNvSpPr txBox="1"/>
+              <p:nvPr/>
+            </p:nvSpPr>
+            <p:spPr>
+              <a:xfrm>
+                <a:off x="7124129" y="5202500"/>
+                <a:ext cx="3308342" cy="637162"/>
+              </a:xfrm>
+              <a:prstGeom prst="rect">
+                <a:avLst/>
+              </a:prstGeom>
+              <a:noFill/>
+            </p:spPr>
+            <p:txBody>
+              <a:bodyPr wrap="none" lIns="0" tIns="0" rIns="0" bIns="0" rtlCol="0">
+                <a:spAutoFit/>
+              </a:bodyPr>
+              <a:lstStyle/>
+              <a:p>
+                <a14:m>
+                  <m:oMathPara xmlns:m="http://schemas.openxmlformats.org/officeDocument/2006/math">
+                    <m:oMathParaPr>
+                      <m:jc m:val="centerGroup"/>
+                    </m:oMathParaPr>
+                    <m:oMath xmlns:m="http://schemas.openxmlformats.org/officeDocument/2006/math">
+                      <m:nary>
+                        <m:naryPr>
+                          <m:chr m:val="∑"/>
+                          <m:ctrlPr>
+                            <a:rPr lang="en-US" sz="1400" i="1" smtClean="0">
+                              <a:latin typeface="Cambria Math" panose="02040503050406030204" pitchFamily="18" charset="0"/>
+                            </a:rPr>
+                          </m:ctrlPr>
+                        </m:naryPr>
+                        <m:sub>
+                          <m:r>
+                            <m:rPr>
+                              <m:sty m:val="p"/>
+                              <m:brk m:alnAt="23"/>
+                            </m:rPr>
+                            <a:rPr lang="en-US" sz="1400" b="0" i="1" smtClean="0">
+                              <a:latin typeface="Cambria Math" panose="02040503050406030204" pitchFamily="18" charset="0"/>
+                            </a:rPr>
+                            <m:t>j</m:t>
+                          </m:r>
+                          <m:r>
+                            <a:rPr lang="en-US" sz="1400" b="0" i="1" smtClean="0">
+                              <a:latin typeface="Cambria Math" panose="02040503050406030204" pitchFamily="18" charset="0"/>
+                            </a:rPr>
+                            <m:t>=1</m:t>
+                          </m:r>
+                        </m:sub>
+                        <m:sup>
+                          <m:r>
+                            <m:rPr>
+                              <m:sty m:val="p"/>
+                            </m:rPr>
+                            <a:rPr lang="en-US" sz="1400" b="0" i="1" smtClean="0">
+                              <a:latin typeface="Cambria Math" panose="02040503050406030204" pitchFamily="18" charset="0"/>
+                            </a:rPr>
+                            <m:t>N</m:t>
+                          </m:r>
+                        </m:sup>
+                        <m:e>
+                          <m:sSub>
+                            <m:sSubPr>
+                              <m:ctrlPr>
+                                <a:rPr lang="en-US" sz="1400" i="1" smtClean="0">
+                                  <a:latin typeface="Cambria Math" panose="02040503050406030204" pitchFamily="18" charset="0"/>
+                                </a:rPr>
+                              </m:ctrlPr>
+                            </m:sSubPr>
+                            <m:e>
+                              <m:r>
+                                <m:rPr>
+                                  <m:sty m:val="p"/>
+                                </m:rPr>
+                                <a:rPr lang="en-US" sz="1400" b="0" i="1" smtClean="0">
+                                  <a:latin typeface="Cambria Math" panose="02040503050406030204" pitchFamily="18" charset="0"/>
+                                </a:rPr>
+                                <m:t>T</m:t>
+                              </m:r>
+                            </m:e>
+                            <m:sub>
+                              <m:r>
+                                <m:rPr>
+                                  <m:sty m:val="p"/>
+                                </m:rPr>
+                                <a:rPr lang="en-US" sz="1400" b="0" i="1" smtClean="0">
+                                  <a:latin typeface="Cambria Math" panose="02040503050406030204" pitchFamily="18" charset="0"/>
+                                </a:rPr>
+                                <m:t>j</m:t>
+                              </m:r>
+                            </m:sub>
+                          </m:sSub>
+                          <m:r>
+                            <a:rPr lang="en-US" sz="1400" b="0" i="1" smtClean="0">
+                              <a:latin typeface="Cambria Math" panose="02040503050406030204" pitchFamily="18" charset="0"/>
+                            </a:rPr>
+                            <m:t>(0)</m:t>
+                          </m:r>
+                          <m:acc>
+                            <m:accPr>
+                              <m:chr m:val="⃗"/>
+                              <m:ctrlPr>
+                                <a:rPr lang="en-US" sz="1400" b="0" i="1" smtClean="0">
+                                  <a:latin typeface="Cambria Math" panose="02040503050406030204" pitchFamily="18" charset="0"/>
+                                </a:rPr>
+                              </m:ctrlPr>
+                            </m:accPr>
+                            <m:e>
+                              <m:sSub>
+                                <m:sSubPr>
+                                  <m:ctrlPr>
+                                    <a:rPr lang="en-US" sz="1400" b="0" i="1" smtClean="0">
+                                      <a:latin typeface="Cambria Math" panose="02040503050406030204" pitchFamily="18" charset="0"/>
+                                    </a:rPr>
+                                  </m:ctrlPr>
+                                </m:sSubPr>
+                                <m:e>
+                                  <m:r>
+                                    <a:rPr lang="en-US" sz="1400" b="0" i="1" smtClean="0">
+                                      <a:latin typeface="Cambria Math" panose="02040503050406030204" pitchFamily="18" charset="0"/>
+                                    </a:rPr>
+                                    <m:t>1</m:t>
+                                  </m:r>
+                                </m:e>
+                                <m:sub>
+                                  <m:r>
+                                    <m:rPr>
+                                      <m:sty m:val="p"/>
+                                    </m:rPr>
+                                    <a:rPr lang="en-US" sz="1400" b="0" i="1" smtClean="0">
+                                      <a:latin typeface="Cambria Math" panose="02040503050406030204" pitchFamily="18" charset="0"/>
+                                    </a:rPr>
+                                    <m:t>tj</m:t>
+                                  </m:r>
+                                </m:sub>
+                              </m:sSub>
+                            </m:e>
+                          </m:acc>
+                          <m:r>
+                            <m:rPr>
+                              <m:brk m:alnAt="23"/>
+                            </m:rPr>
+                            <a:rPr lang="en-US" sz="1400" b="0" i="1" smtClean="0">
+                              <a:latin typeface="Cambria Math" panose="02040503050406030204" pitchFamily="18" charset="0"/>
+                            </a:rPr>
+                            <m:t>(0)+(</m:t>
+                          </m:r>
+                          <m:sSub>
+                            <m:sSubPr>
+                              <m:ctrlPr>
+                                <a:rPr lang="en-US" sz="1400" b="0" i="1" smtClean="0">
+                                  <a:latin typeface="Cambria Math" panose="02040503050406030204" pitchFamily="18" charset="0"/>
+                                </a:rPr>
+                              </m:ctrlPr>
+                            </m:sSubPr>
+                            <m:e>
+                              <m:r>
+                                <m:rPr>
+                                  <m:sty m:val="p"/>
+                                </m:rPr>
+                                <a:rPr lang="en-US" sz="1400" b="0" i="1" smtClean="0">
+                                  <a:latin typeface="Cambria Math" panose="02040503050406030204" pitchFamily="18" charset="0"/>
+                                </a:rPr>
+                                <m:t>Q</m:t>
+                              </m:r>
+                            </m:e>
+                            <m:sub>
+                              <m:r>
+                                <m:rPr>
+                                  <m:sty m:val="p"/>
+                                </m:rPr>
+                                <a:rPr lang="en-US" sz="1400" b="0" i="1" smtClean="0">
+                                  <a:latin typeface="Cambria Math" panose="02040503050406030204" pitchFamily="18" charset="0"/>
+                                </a:rPr>
+                                <m:t>s</m:t>
+                              </m:r>
+                            </m:sub>
+                          </m:sSub>
+                          <m:r>
+                            <m:rPr>
+                              <m:sty m:val="p"/>
+                              <m:brk m:alnAt="23"/>
+                            </m:rPr>
+                            <a:rPr lang="en-US" sz="1400" b="0" i="1" smtClean="0">
+                              <a:latin typeface="Cambria Math" panose="02040503050406030204" pitchFamily="18" charset="0"/>
+                            </a:rPr>
+                            <m:t>E</m:t>
+                          </m:r>
+                          <m:r>
+                            <a:rPr lang="en-US" sz="1400" b="0" i="1" smtClean="0">
+                              <a:latin typeface="Cambria Math" panose="02040503050406030204" pitchFamily="18" charset="0"/>
+                            </a:rPr>
+                            <m:t>-</m:t>
+                          </m:r>
+                          <m:r>
+                            <m:rPr>
+                              <m:sty m:val="p"/>
+                            </m:rPr>
+                            <a:rPr lang="en-US" sz="1400" b="0" i="1" smtClean="0">
+                              <a:latin typeface="Cambria Math" panose="02040503050406030204" pitchFamily="18" charset="0"/>
+                            </a:rPr>
+                            <m:t>mg</m:t>
+                          </m:r>
+                          <m:r>
+                            <a:rPr lang="en-US" sz="1400" b="0" i="1" smtClean="0">
+                              <a:latin typeface="Cambria Math" panose="02040503050406030204" pitchFamily="18" charset="0"/>
+                            </a:rPr>
+                            <m:t>)</m:t>
+                          </m:r>
+                          <m:acc>
+                            <m:accPr>
+                              <m:chr m:val="⃗"/>
+                              <m:ctrlPr>
+                                <a:rPr lang="en-US" sz="1400" b="0" i="1" smtClean="0">
+                                  <a:latin typeface="Cambria Math" panose="02040503050406030204" pitchFamily="18" charset="0"/>
+                                </a:rPr>
+                              </m:ctrlPr>
+                            </m:accPr>
+                            <m:e>
+                              <m:sSub>
+                                <m:sSubPr>
+                                  <m:ctrlPr>
+                                    <a:rPr lang="en-US" sz="1400" b="0" i="1" smtClean="0">
+                                      <a:latin typeface="Cambria Math" panose="02040503050406030204" pitchFamily="18" charset="0"/>
+                                    </a:rPr>
+                                  </m:ctrlPr>
+                                </m:sSubPr>
+                                <m:e>
+                                  <m:r>
+                                    <a:rPr lang="en-US" sz="1400" b="0" i="1" smtClean="0">
+                                      <a:latin typeface="Cambria Math" panose="02040503050406030204" pitchFamily="18" charset="0"/>
+                                    </a:rPr>
+                                    <m:t>1</m:t>
+                                  </m:r>
+                                </m:e>
+                                <m:sub>
+                                  <m:r>
+                                    <m:rPr>
+                                      <m:sty m:val="p"/>
+                                    </m:rPr>
+                                    <a:rPr lang="en-US" sz="1400" b="0" i="1" smtClean="0">
+                                      <a:latin typeface="Cambria Math" panose="02040503050406030204" pitchFamily="18" charset="0"/>
+                                    </a:rPr>
+                                    <m:t>z</m:t>
+                                  </m:r>
+                                </m:sub>
+                              </m:sSub>
+                            </m:e>
+                          </m:acc>
+                          <m:r>
+                            <m:rPr>
+                              <m:brk m:alnAt="23"/>
+                            </m:rPr>
+                            <a:rPr lang="en-US" sz="1400" b="0" i="1" smtClean="0">
+                              <a:latin typeface="Cambria Math" panose="02040503050406030204" pitchFamily="18" charset="0"/>
+                            </a:rPr>
+                            <m:t>+</m:t>
+                          </m:r>
+                          <m:acc>
+                            <m:accPr>
+                              <m:chr m:val="⃗"/>
+                              <m:ctrlPr>
+                                <a:rPr lang="en-US" sz="1400" b="0" i="1" smtClean="0">
+                                  <a:latin typeface="Cambria Math" panose="02040503050406030204" pitchFamily="18" charset="0"/>
+                                </a:rPr>
+                              </m:ctrlPr>
+                            </m:accPr>
+                            <m:e>
+                              <m:sSub>
+                                <m:sSubPr>
+                                  <m:ctrlPr>
+                                    <a:rPr lang="en-US" sz="1400" b="0" i="1" smtClean="0">
+                                      <a:latin typeface="Cambria Math" panose="02040503050406030204" pitchFamily="18" charset="0"/>
+                                    </a:rPr>
+                                  </m:ctrlPr>
+                                </m:sSubPr>
+                                <m:e>
+                                  <m:r>
+                                    <m:rPr>
+                                      <m:sty m:val="p"/>
+                                    </m:rPr>
+                                    <a:rPr lang="en-US" sz="1400" b="0" i="1" smtClean="0">
+                                      <a:latin typeface="Cambria Math" panose="02040503050406030204" pitchFamily="18" charset="0"/>
+                                    </a:rPr>
+                                    <m:t>F</m:t>
+                                  </m:r>
+                                </m:e>
+                                <m:sub>
+                                  <m:r>
+                                    <m:rPr>
+                                      <m:sty m:val="p"/>
+                                    </m:rPr>
+                                    <a:rPr lang="en-US" sz="1400" b="0" i="1" smtClean="0">
+                                      <a:latin typeface="Cambria Math" panose="02040503050406030204" pitchFamily="18" charset="0"/>
+                                    </a:rPr>
+                                    <m:t>v</m:t>
+                                  </m:r>
+                                  <m:r>
+                                    <a:rPr lang="en-US" sz="1400" b="0" i="1" smtClean="0">
+                                      <a:latin typeface="Cambria Math" panose="02040503050406030204" pitchFamily="18" charset="0"/>
+                                    </a:rPr>
+                                    <m:t>,</m:t>
+                                  </m:r>
+                                  <m:r>
+                                    <m:rPr>
+                                      <m:sty m:val="p"/>
+                                    </m:rPr>
+                                    <a:rPr lang="en-US" sz="1400" b="0" i="1" smtClean="0">
+                                      <a:latin typeface="Cambria Math" panose="02040503050406030204" pitchFamily="18" charset="0"/>
+                                    </a:rPr>
+                                    <m:t>s</m:t>
+                                  </m:r>
+                                </m:sub>
+                              </m:sSub>
+                            </m:e>
+                          </m:acc>
+                          <m:r>
+                            <m:rPr>
+                              <m:brk m:alnAt="23"/>
+                            </m:rPr>
+                            <a:rPr lang="en-US" sz="1400" b="0" i="1" smtClean="0">
+                              <a:latin typeface="Cambria Math" panose="02040503050406030204" pitchFamily="18" charset="0"/>
+                            </a:rPr>
+                            <m:t>=</m:t>
+                          </m:r>
+                          <m:r>
+                            <m:rPr>
+                              <m:sty m:val="p"/>
+                            </m:rPr>
+                            <a:rPr lang="en-US" sz="1400" b="0" i="1" smtClean="0">
+                              <a:latin typeface="Cambria Math" panose="02040503050406030204" pitchFamily="18" charset="0"/>
+                            </a:rPr>
+                            <m:t>m</m:t>
+                          </m:r>
+                          <m:acc>
+                            <m:accPr>
+                              <m:chr m:val="̇"/>
+                              <m:ctrlPr>
+                                <a:rPr lang="en-US" sz="1400" b="0" i="1" smtClean="0">
+                                  <a:latin typeface="Cambria Math" panose="02040503050406030204" pitchFamily="18" charset="0"/>
+                                </a:rPr>
+                              </m:ctrlPr>
+                            </m:accPr>
+                            <m:e>
+                              <m:acc>
+                                <m:accPr>
+                                  <m:chr m:val="⃗"/>
+                                  <m:ctrlPr>
+                                    <a:rPr lang="en-US" sz="1400" b="0" i="1" smtClean="0">
+                                      <a:latin typeface="Cambria Math" panose="02040503050406030204" pitchFamily="18" charset="0"/>
+                                    </a:rPr>
+                                  </m:ctrlPr>
+                                </m:accPr>
+                                <m:e>
+                                  <m:sSub>
+                                    <m:sSubPr>
+                                      <m:ctrlPr>
+                                        <a:rPr lang="en-US" sz="1400" b="0" i="1" smtClean="0">
+                                          <a:latin typeface="Cambria Math" panose="02040503050406030204" pitchFamily="18" charset="0"/>
+                                        </a:rPr>
+                                      </m:ctrlPr>
+                                    </m:sSubPr>
+                                    <m:e>
+                                      <m:r>
+                                        <m:rPr>
+                                          <m:sty m:val="p"/>
+                                        </m:rPr>
+                                        <a:rPr lang="en-US" sz="1400" b="0" i="1" smtClean="0">
+                                          <a:latin typeface="Cambria Math" panose="02040503050406030204" pitchFamily="18" charset="0"/>
+                                        </a:rPr>
+                                        <m:t>v</m:t>
+                                      </m:r>
+                                    </m:e>
+                                    <m:sub>
+                                      <m:r>
+                                        <m:rPr>
+                                          <m:sty m:val="p"/>
+                                        </m:rPr>
+                                        <a:rPr lang="en-US" sz="1400" b="0" i="1" smtClean="0">
+                                          <a:latin typeface="Cambria Math" panose="02040503050406030204" pitchFamily="18" charset="0"/>
+                                        </a:rPr>
+                                        <m:t>s</m:t>
+                                      </m:r>
+                                    </m:sub>
+                                  </m:sSub>
+                                </m:e>
+                              </m:acc>
+                            </m:e>
+                          </m:acc>
+                        </m:e>
+                      </m:nary>
+                    </m:oMath>
+                  </m:oMathPara>
+                </a14:m>
+                <a:endParaRPr lang="en-US" sz="1400" dirty="0"/>
+              </a:p>
+            </p:txBody>
+          </p:sp>
+        </mc:Choice>
+        <mc:Fallback>
+          <p:sp>
+            <p:nvSpPr>
+              <p:cNvPr id="12" name="TextBox 11">
+                <a:extLst>
+                  <a:ext uri="{FF2B5EF4-FFF2-40B4-BE49-F238E27FC236}">
+                    <a16:creationId xmlns:a16="http://schemas.microsoft.com/office/drawing/2014/main" id="{C6BAD141-779B-579E-06CE-1D769AEB18DD}"/>
+                  </a:ext>
+                </a:extLst>
+              </p:cNvPr>
+              <p:cNvSpPr txBox="1">
+                <a:spLocks noRot="1" noChangeAspect="1" noMove="1" noResize="1" noEditPoints="1" noAdjustHandles="1" noChangeArrowheads="1" noChangeShapeType="1" noTextEdit="1"/>
+              </p:cNvSpPr>
+              <p:nvPr/>
+            </p:nvSpPr>
+            <p:spPr>
+              <a:xfrm>
+                <a:off x="7124129" y="5202500"/>
+                <a:ext cx="3308342" cy="637162"/>
+              </a:xfrm>
+              <a:prstGeom prst="rect">
+                <a:avLst/>
+              </a:prstGeom>
+              <a:blipFill>
+                <a:blip r:embed="rId5"/>
+                <a:stretch>
+                  <a:fillRect l="-19923" t="-105882" b="-166667"/>
+                </a:stretch>
+              </a:blipFill>
+            </p:spPr>
+            <p:txBody>
+              <a:bodyPr/>
+              <a:lstStyle/>
+              <a:p>
+                <a:r>
+                  <a:rPr lang="en-US">
+                    <a:noFill/>
+                  </a:rPr>
+                  <a:t> </a:t>
+                </a:r>
+              </a:p>
+            </p:txBody>
+          </p:sp>
+        </mc:Fallback>
+      </mc:AlternateContent>
+      <mc:AlternateContent xmlns:mc="http://schemas.openxmlformats.org/markup-compatibility/2006">
+        <mc:Choice xmlns:a14="http://schemas.microsoft.com/office/drawing/2010/main" Requires="a14">
+          <p:sp>
+            <p:nvSpPr>
+              <p:cNvPr id="13" name="TextBox 12">
+                <a:extLst>
+                  <a:ext uri="{FF2B5EF4-FFF2-40B4-BE49-F238E27FC236}">
+                    <a16:creationId xmlns:a16="http://schemas.microsoft.com/office/drawing/2014/main" id="{279E26C5-8FA7-EBE0-9054-B607523ADE5C}"/>
+                  </a:ext>
+                </a:extLst>
+              </p:cNvPr>
+              <p:cNvSpPr txBox="1"/>
+              <p:nvPr/>
+            </p:nvSpPr>
+            <p:spPr>
+              <a:xfrm>
+                <a:off x="7124129" y="6013861"/>
+                <a:ext cx="2097113" cy="215444"/>
+              </a:xfrm>
+              <a:prstGeom prst="rect">
+                <a:avLst/>
+              </a:prstGeom>
+              <a:noFill/>
+            </p:spPr>
+            <p:txBody>
+              <a:bodyPr wrap="none" lIns="0" tIns="0" rIns="0" bIns="0" rtlCol="0">
+                <a:spAutoFit/>
+              </a:bodyPr>
+              <a:lstStyle/>
+              <a:p>
+                <a14:m>
+                  <m:oMathPara xmlns:m="http://schemas.openxmlformats.org/officeDocument/2006/math">
+                    <m:oMathParaPr>
+                      <m:jc m:val="centerGroup"/>
+                    </m:oMathParaPr>
+                    <m:oMath xmlns:m="http://schemas.openxmlformats.org/officeDocument/2006/math">
+                      <m:r>
+                        <m:rPr>
+                          <m:sty m:val="p"/>
+                        </m:rPr>
+                        <a:rPr lang="en-US" sz="1400" b="0" i="1" smtClean="0">
+                          <a:latin typeface="Cambria Math" panose="02040503050406030204" pitchFamily="18" charset="0"/>
+                        </a:rPr>
+                        <m:t>T</m:t>
+                      </m:r>
+                      <m:r>
+                        <a:rPr lang="en-US" sz="1400" b="0" i="1" smtClean="0">
+                          <a:latin typeface="Cambria Math" panose="02040503050406030204" pitchFamily="18" charset="0"/>
+                        </a:rPr>
+                        <m:t>(</m:t>
+                      </m:r>
+                      <m:r>
+                        <m:rPr>
+                          <m:sty m:val="p"/>
+                        </m:rPr>
+                        <a:rPr lang="en-US" sz="1400" b="0" i="1" smtClean="0">
+                          <a:latin typeface="Cambria Math" panose="02040503050406030204" pitchFamily="18" charset="0"/>
+                        </a:rPr>
+                        <m:t>L</m:t>
+                      </m:r>
+                      <m:r>
+                        <a:rPr lang="en-US" sz="1400" b="0" i="1" smtClean="0">
+                          <a:latin typeface="Cambria Math" panose="02040503050406030204" pitchFamily="18" charset="0"/>
+                        </a:rPr>
+                        <m:t>)=0 (</m:t>
+                      </m:r>
+                      <m:r>
+                        <m:rPr>
+                          <m:sty m:val="p"/>
+                        </m:rPr>
+                        <a:rPr lang="en-US" sz="1400" b="0" i="1" smtClean="0">
+                          <a:latin typeface="Cambria Math" panose="02040503050406030204" pitchFamily="18" charset="0"/>
+                        </a:rPr>
+                        <m:t>uniform</m:t>
+                      </m:r>
+                      <m:r>
+                        <a:rPr lang="en-US" sz="1400" b="0" i="1" smtClean="0">
+                          <a:latin typeface="Cambria Math" panose="02040503050406030204" pitchFamily="18" charset="0"/>
+                        </a:rPr>
+                        <m:t> </m:t>
+                      </m:r>
+                      <m:r>
+                        <m:rPr>
+                          <m:sty m:val="p"/>
+                        </m:rPr>
+                        <a:rPr lang="en-US" sz="1400" b="0" i="1" smtClean="0">
+                          <a:latin typeface="Cambria Math" panose="02040503050406030204" pitchFamily="18" charset="0"/>
+                        </a:rPr>
+                        <m:t>charge</m:t>
+                      </m:r>
+                      <m:r>
+                        <a:rPr lang="en-US" sz="1400" b="0" i="1" smtClean="0">
+                          <a:latin typeface="Cambria Math" panose="02040503050406030204" pitchFamily="18" charset="0"/>
+                        </a:rPr>
+                        <m:t>)</m:t>
+                      </m:r>
+                    </m:oMath>
+                  </m:oMathPara>
+                </a14:m>
+                <a:endParaRPr lang="en-US" sz="1400" dirty="0"/>
+              </a:p>
+            </p:txBody>
+          </p:sp>
+        </mc:Choice>
+        <mc:Fallback>
+          <p:sp>
+            <p:nvSpPr>
+              <p:cNvPr id="13" name="TextBox 12">
+                <a:extLst>
+                  <a:ext uri="{FF2B5EF4-FFF2-40B4-BE49-F238E27FC236}">
+                    <a16:creationId xmlns:a16="http://schemas.microsoft.com/office/drawing/2014/main" id="{279E26C5-8FA7-EBE0-9054-B607523ADE5C}"/>
+                  </a:ext>
+                </a:extLst>
+              </p:cNvPr>
+              <p:cNvSpPr txBox="1">
+                <a:spLocks noRot="1" noChangeAspect="1" noMove="1" noResize="1" noEditPoints="1" noAdjustHandles="1" noChangeArrowheads="1" noChangeShapeType="1" noTextEdit="1"/>
+              </p:cNvSpPr>
+              <p:nvPr/>
+            </p:nvSpPr>
+            <p:spPr>
+              <a:xfrm>
+                <a:off x="7124129" y="6013861"/>
+                <a:ext cx="2097113" cy="215444"/>
+              </a:xfrm>
+              <a:prstGeom prst="rect">
+                <a:avLst/>
+              </a:prstGeom>
+              <a:blipFill>
+                <a:blip r:embed="rId6"/>
+                <a:stretch>
+                  <a:fillRect l="-1807" t="-5556" r="-2410" b="-38889"/>
+                </a:stretch>
+              </a:blipFill>
+            </p:spPr>
+            <p:txBody>
+              <a:bodyPr/>
+              <a:lstStyle/>
+              <a:p>
+                <a:r>
+                  <a:rPr lang="en-US">
+                    <a:noFill/>
+                  </a:rPr>
+                  <a:t> </a:t>
+                </a:r>
+              </a:p>
+            </p:txBody>
+          </p:sp>
+        </mc:Fallback>
+      </mc:AlternateContent>
+      <mc:AlternateContent xmlns:mc="http://schemas.openxmlformats.org/markup-compatibility/2006">
+        <mc:Choice xmlns:a14="http://schemas.microsoft.com/office/drawing/2010/main" Requires="a14">
+          <p:sp>
+            <p:nvSpPr>
+              <p:cNvPr id="14" name="TextBox 13">
+                <a:extLst>
+                  <a:ext uri="{FF2B5EF4-FFF2-40B4-BE49-F238E27FC236}">
+                    <a16:creationId xmlns:a16="http://schemas.microsoft.com/office/drawing/2014/main" id="{10470150-A12B-3C63-07B3-EC07EF172445}"/>
+                  </a:ext>
+                </a:extLst>
+              </p:cNvPr>
+              <p:cNvSpPr txBox="1"/>
+              <p:nvPr/>
+            </p:nvSpPr>
+            <p:spPr>
+              <a:xfrm>
+                <a:off x="7124129" y="6279032"/>
+                <a:ext cx="2744213" cy="243015"/>
+              </a:xfrm>
+              <a:prstGeom prst="rect">
+                <a:avLst/>
+              </a:prstGeom>
+              <a:noFill/>
+            </p:spPr>
+            <p:txBody>
+              <a:bodyPr wrap="none" lIns="0" tIns="0" rIns="0" bIns="0" rtlCol="0">
+                <a:spAutoFit/>
+              </a:bodyPr>
+              <a:lstStyle/>
+              <a:p>
+                <a14:m>
+                  <m:oMathPara xmlns:m="http://schemas.openxmlformats.org/officeDocument/2006/math">
+                    <m:oMathParaPr>
+                      <m:jc m:val="centerGroup"/>
+                    </m:oMathParaPr>
+                    <m:oMath xmlns:m="http://schemas.openxmlformats.org/officeDocument/2006/math">
+                      <m:r>
+                        <m:rPr>
+                          <m:sty m:val="p"/>
+                        </m:rPr>
+                        <a:rPr lang="en-US" sz="1400" b="0" i="1" smtClean="0">
+                          <a:latin typeface="Cambria Math" panose="02040503050406030204" pitchFamily="18" charset="0"/>
+                        </a:rPr>
+                        <m:t>T</m:t>
+                      </m:r>
+                      <m:r>
+                        <a:rPr lang="en-US" sz="1400" b="0" i="1" smtClean="0">
+                          <a:latin typeface="Cambria Math" panose="02040503050406030204" pitchFamily="18" charset="0"/>
+                        </a:rPr>
+                        <m:t>(</m:t>
+                      </m:r>
+                      <m:r>
+                        <m:rPr>
+                          <m:sty m:val="p"/>
+                        </m:rPr>
+                        <a:rPr lang="en-US" sz="1400" b="0" i="1" smtClean="0">
+                          <a:latin typeface="Cambria Math" panose="02040503050406030204" pitchFamily="18" charset="0"/>
+                        </a:rPr>
+                        <m:t>L</m:t>
+                      </m:r>
+                      <m:r>
+                        <a:rPr lang="en-US" sz="1400" b="0" i="1" smtClean="0">
+                          <a:latin typeface="Cambria Math" panose="02040503050406030204" pitchFamily="18" charset="0"/>
+                        </a:rPr>
+                        <m:t>)</m:t>
+                      </m:r>
+                      <m:acc>
+                        <m:accPr>
+                          <m:chr m:val="⃗"/>
+                          <m:ctrlPr>
+                            <a:rPr lang="en-US" sz="1400" b="0" i="1" smtClean="0">
+                              <a:latin typeface="Cambria Math" panose="02040503050406030204" pitchFamily="18" charset="0"/>
+                            </a:rPr>
+                          </m:ctrlPr>
+                        </m:accPr>
+                        <m:e>
+                          <m:sSub>
+                            <m:sSubPr>
+                              <m:ctrlPr>
+                                <a:rPr lang="en-US" sz="1400" b="0" i="1" smtClean="0">
+                                  <a:latin typeface="Cambria Math" panose="02040503050406030204" pitchFamily="18" charset="0"/>
+                                </a:rPr>
+                              </m:ctrlPr>
+                            </m:sSubPr>
+                            <m:e>
+                              <m:r>
+                                <a:rPr lang="en-US" sz="1400" b="0" i="1" smtClean="0">
+                                  <a:latin typeface="Cambria Math" panose="02040503050406030204" pitchFamily="18" charset="0"/>
+                                </a:rPr>
+                                <m:t>1</m:t>
+                              </m:r>
+                            </m:e>
+                            <m:sub>
+                              <m:r>
+                                <m:rPr>
+                                  <m:sty m:val="p"/>
+                                </m:rPr>
+                                <a:rPr lang="en-US" sz="1400" b="0" i="1" smtClean="0">
+                                  <a:latin typeface="Cambria Math" panose="02040503050406030204" pitchFamily="18" charset="0"/>
+                                </a:rPr>
+                                <m:t>t</m:t>
+                              </m:r>
+                            </m:sub>
+                          </m:sSub>
+                        </m:e>
+                      </m:acc>
+                      <m:r>
+                        <a:rPr lang="en-US" sz="1400" b="0" i="1" smtClean="0">
+                          <a:latin typeface="Cambria Math" panose="02040503050406030204" pitchFamily="18" charset="0"/>
+                        </a:rPr>
+                        <m:t>(</m:t>
+                      </m:r>
+                      <m:r>
+                        <m:rPr>
+                          <m:sty m:val="p"/>
+                        </m:rPr>
+                        <a:rPr lang="en-US" sz="1400" b="0" i="1" smtClean="0">
+                          <a:latin typeface="Cambria Math" panose="02040503050406030204" pitchFamily="18" charset="0"/>
+                        </a:rPr>
+                        <m:t>L</m:t>
+                      </m:r>
+                      <m:r>
+                        <a:rPr lang="en-US" sz="1400" b="0" i="1" smtClean="0">
+                          <a:latin typeface="Cambria Math" panose="02040503050406030204" pitchFamily="18" charset="0"/>
+                        </a:rPr>
+                        <m:t>)=</m:t>
+                      </m:r>
+                      <m:r>
+                        <m:rPr>
+                          <m:sty m:val="p"/>
+                        </m:rPr>
+                        <a:rPr lang="en-US" sz="1400" b="0" i="1" smtClean="0">
+                          <a:latin typeface="Cambria Math" panose="02040503050406030204" pitchFamily="18" charset="0"/>
+                        </a:rPr>
+                        <m:t>qE</m:t>
+                      </m:r>
+                      <m:acc>
+                        <m:accPr>
+                          <m:chr m:val="⃗"/>
+                          <m:ctrlPr>
+                            <a:rPr lang="en-US" sz="1400" b="0" i="1" smtClean="0">
+                              <a:latin typeface="Cambria Math" panose="02040503050406030204" pitchFamily="18" charset="0"/>
+                            </a:rPr>
+                          </m:ctrlPr>
+                        </m:accPr>
+                        <m:e>
+                          <m:sSub>
+                            <m:sSubPr>
+                              <m:ctrlPr>
+                                <a:rPr lang="en-US" sz="1400" b="0" i="1" smtClean="0">
+                                  <a:latin typeface="Cambria Math" panose="02040503050406030204" pitchFamily="18" charset="0"/>
+                                </a:rPr>
+                              </m:ctrlPr>
+                            </m:sSubPr>
+                            <m:e>
+                              <m:r>
+                                <a:rPr lang="en-US" sz="1400" b="0" i="1" smtClean="0">
+                                  <a:latin typeface="Cambria Math" panose="02040503050406030204" pitchFamily="18" charset="0"/>
+                                </a:rPr>
+                                <m:t>1</m:t>
+                              </m:r>
+                            </m:e>
+                            <m:sub>
+                              <m:r>
+                                <m:rPr>
+                                  <m:sty m:val="p"/>
+                                </m:rPr>
+                                <a:rPr lang="en-US" sz="1400" b="0" i="1" smtClean="0">
+                                  <a:latin typeface="Cambria Math" panose="02040503050406030204" pitchFamily="18" charset="0"/>
+                                </a:rPr>
+                                <m:t>z</m:t>
+                              </m:r>
+                            </m:sub>
+                          </m:sSub>
+                        </m:e>
+                      </m:acc>
+                      <m:r>
+                        <a:rPr lang="en-US" sz="1400" b="0" i="1" smtClean="0">
+                          <a:latin typeface="Cambria Math" panose="02040503050406030204" pitchFamily="18" charset="0"/>
+                        </a:rPr>
+                        <m:t>+</m:t>
+                      </m:r>
+                      <m:acc>
+                        <m:accPr>
+                          <m:chr m:val="⃗"/>
+                          <m:ctrlPr>
+                            <a:rPr lang="en-US" sz="1400" b="0" i="1" smtClean="0">
+                              <a:latin typeface="Cambria Math" panose="02040503050406030204" pitchFamily="18" charset="0"/>
+                            </a:rPr>
+                          </m:ctrlPr>
+                        </m:accPr>
+                        <m:e>
+                          <m:sSub>
+                            <m:sSubPr>
+                              <m:ctrlPr>
+                                <a:rPr lang="en-US" sz="1400" b="0" i="1" smtClean="0">
+                                  <a:latin typeface="Cambria Math" panose="02040503050406030204" pitchFamily="18" charset="0"/>
+                                </a:rPr>
+                              </m:ctrlPr>
+                            </m:sSubPr>
+                            <m:e>
+                              <m:r>
+                                <m:rPr>
+                                  <m:sty m:val="p"/>
+                                </m:rPr>
+                                <a:rPr lang="en-US" sz="1400" b="0" i="1" smtClean="0">
+                                  <a:latin typeface="Cambria Math" panose="02040503050406030204" pitchFamily="18" charset="0"/>
+                                </a:rPr>
+                                <m:t>F</m:t>
+                              </m:r>
+                            </m:e>
+                            <m:sub>
+                              <m:r>
+                                <m:rPr>
+                                  <m:sty m:val="p"/>
+                                </m:rPr>
+                                <a:rPr lang="en-US" sz="1400" b="0" i="1" smtClean="0">
+                                  <a:latin typeface="Cambria Math" panose="02040503050406030204" pitchFamily="18" charset="0"/>
+                                </a:rPr>
+                                <m:t>r</m:t>
+                              </m:r>
+                            </m:sub>
+                          </m:sSub>
+                        </m:e>
+                      </m:acc>
+                      <m:r>
+                        <a:rPr lang="en-US" sz="1400" b="0" i="1" smtClean="0">
+                          <a:latin typeface="Cambria Math" panose="02040503050406030204" pitchFamily="18" charset="0"/>
+                        </a:rPr>
+                        <m:t> (</m:t>
+                      </m:r>
+                      <m:r>
+                        <m:rPr>
+                          <m:sty m:val="p"/>
+                        </m:rPr>
+                        <a:rPr lang="en-US" sz="1400" b="0" i="1" smtClean="0">
+                          <a:latin typeface="Cambria Math" panose="02040503050406030204" pitchFamily="18" charset="0"/>
+                        </a:rPr>
+                        <m:t>tip</m:t>
+                      </m:r>
+                      <m:r>
+                        <a:rPr lang="en-US" sz="1400" b="0" i="1" smtClean="0">
+                          <a:latin typeface="Cambria Math" panose="02040503050406030204" pitchFamily="18" charset="0"/>
+                        </a:rPr>
+                        <m:t> </m:t>
+                      </m:r>
+                      <m:r>
+                        <m:rPr>
+                          <m:sty m:val="p"/>
+                        </m:rPr>
+                        <a:rPr lang="en-US" sz="1400" b="0" i="1" smtClean="0">
+                          <a:latin typeface="Cambria Math" panose="02040503050406030204" pitchFamily="18" charset="0"/>
+                        </a:rPr>
+                        <m:t>charge</m:t>
+                      </m:r>
+                      <m:r>
+                        <a:rPr lang="en-US" sz="1400" b="0" i="1" smtClean="0">
+                          <a:latin typeface="Cambria Math" panose="02040503050406030204" pitchFamily="18" charset="0"/>
+                        </a:rPr>
+                        <m:t>)</m:t>
+                      </m:r>
+                    </m:oMath>
+                  </m:oMathPara>
+                </a14:m>
+                <a:endParaRPr lang="en-US" sz="1400" dirty="0"/>
+              </a:p>
+            </p:txBody>
+          </p:sp>
+        </mc:Choice>
+        <mc:Fallback>
+          <p:sp>
+            <p:nvSpPr>
+              <p:cNvPr id="14" name="TextBox 13">
+                <a:extLst>
+                  <a:ext uri="{FF2B5EF4-FFF2-40B4-BE49-F238E27FC236}">
+                    <a16:creationId xmlns:a16="http://schemas.microsoft.com/office/drawing/2014/main" id="{10470150-A12B-3C63-07B3-EC07EF172445}"/>
+                  </a:ext>
+                </a:extLst>
+              </p:cNvPr>
+              <p:cNvSpPr txBox="1">
+                <a:spLocks noRot="1" noChangeAspect="1" noMove="1" noResize="1" noEditPoints="1" noAdjustHandles="1" noChangeArrowheads="1" noChangeShapeType="1" noTextEdit="1"/>
+              </p:cNvSpPr>
+              <p:nvPr/>
+            </p:nvSpPr>
+            <p:spPr>
+              <a:xfrm>
+                <a:off x="7124129" y="6279032"/>
+                <a:ext cx="2744213" cy="243015"/>
+              </a:xfrm>
+              <a:prstGeom prst="rect">
+                <a:avLst/>
+              </a:prstGeom>
+              <a:blipFill>
+                <a:blip r:embed="rId7"/>
+                <a:stretch>
+                  <a:fillRect l="-922" r="-1382" b="-35000"/>
+                </a:stretch>
+              </a:blipFill>
+            </p:spPr>
+            <p:txBody>
+              <a:bodyPr/>
+              <a:lstStyle/>
+              <a:p>
+                <a:r>
+                  <a:rPr lang="en-US">
+                    <a:noFill/>
+                  </a:rPr>
+                  <a:t> </a:t>
+                </a:r>
+              </a:p>
+            </p:txBody>
+          </p:sp>
+        </mc:Fallback>
+      </mc:AlternateContent>
+      <mc:AlternateContent xmlns:mc="http://schemas.openxmlformats.org/markup-compatibility/2006">
+        <mc:Choice xmlns:a14="http://schemas.microsoft.com/office/drawing/2010/main" Requires="a14">
+          <p:sp>
+            <p:nvSpPr>
+              <p:cNvPr id="15" name="TextBox 14">
+                <a:extLst>
+                  <a:ext uri="{FF2B5EF4-FFF2-40B4-BE49-F238E27FC236}">
+                    <a16:creationId xmlns:a16="http://schemas.microsoft.com/office/drawing/2014/main" id="{7A2C9ACA-5C17-A788-F6AE-968814F4924B}"/>
+                  </a:ext>
+                </a:extLst>
+              </p:cNvPr>
+              <p:cNvSpPr txBox="1"/>
+              <p:nvPr/>
+            </p:nvSpPr>
+            <p:spPr>
+              <a:xfrm>
+                <a:off x="9482275" y="1402679"/>
+                <a:ext cx="1900392" cy="215444"/>
+              </a:xfrm>
+              <a:prstGeom prst="rect">
+                <a:avLst/>
+              </a:prstGeom>
+              <a:noFill/>
+            </p:spPr>
+            <p:txBody>
+              <a:bodyPr wrap="none" lIns="0" tIns="0" rIns="0" bIns="0" rtlCol="0">
+                <a:spAutoFit/>
+              </a:bodyPr>
+              <a:lstStyle/>
+              <a:p>
+                <a14:m>
+                  <m:oMathPara xmlns:m="http://schemas.openxmlformats.org/officeDocument/2006/math">
+                    <m:oMathParaPr>
+                      <m:jc m:val="centerGroup"/>
+                    </m:oMathParaPr>
+                    <m:oMath xmlns:m="http://schemas.openxmlformats.org/officeDocument/2006/math">
+                      <m:r>
+                        <m:rPr>
+                          <m:sty m:val="p"/>
+                        </m:rPr>
+                        <a:rPr lang="en-US" sz="1400" b="0" i="1" smtClean="0">
+                          <a:latin typeface="Cambria Math" panose="02040503050406030204" pitchFamily="18" charset="0"/>
+                        </a:rPr>
+                        <m:t>N</m:t>
+                      </m:r>
+                      <m:sSub>
+                        <m:sSubPr>
+                          <m:ctrlPr>
+                            <a:rPr lang="en-US" sz="1400" b="0" i="1" smtClean="0">
+                              <a:latin typeface="Cambria Math" panose="02040503050406030204" pitchFamily="18" charset="0"/>
+                            </a:rPr>
+                          </m:ctrlPr>
+                        </m:sSubPr>
+                        <m:e>
+                          <m:r>
+                            <m:rPr>
+                              <m:sty m:val="p"/>
+                            </m:rPr>
+                            <a:rPr lang="en-US" sz="1400" b="0" i="1" smtClean="0">
+                              <a:latin typeface="Cambria Math" panose="02040503050406030204" pitchFamily="18" charset="0"/>
+                            </a:rPr>
+                            <m:t>ρ</m:t>
+                          </m:r>
+                        </m:e>
+                        <m:sub>
+                          <m:r>
+                            <m:rPr>
+                              <m:sty m:val="p"/>
+                            </m:rPr>
+                            <a:rPr lang="en-US" sz="1400" b="0" i="1" smtClean="0">
+                              <a:latin typeface="Cambria Math" panose="02040503050406030204" pitchFamily="18" charset="0"/>
+                            </a:rPr>
+                            <m:t>t</m:t>
+                          </m:r>
+                        </m:sub>
+                      </m:sSub>
+                      <m:r>
+                        <m:rPr>
+                          <m:sty m:val="p"/>
+                        </m:rPr>
+                        <a:rPr lang="en-US" sz="1400" b="0" i="1" smtClean="0">
+                          <a:latin typeface="Cambria Math" panose="02040503050406030204" pitchFamily="18" charset="0"/>
+                        </a:rPr>
+                        <m:t>π</m:t>
+                      </m:r>
+                      <m:sSup>
+                        <m:sSupPr>
+                          <m:ctrlPr>
+                            <a:rPr lang="en-US" sz="1400" b="0" i="1" smtClean="0">
+                              <a:latin typeface="Cambria Math" panose="02040503050406030204" pitchFamily="18" charset="0"/>
+                            </a:rPr>
+                          </m:ctrlPr>
+                        </m:sSupPr>
+                        <m:e>
+                          <m:r>
+                            <m:rPr>
+                              <m:sty m:val="p"/>
+                            </m:rPr>
+                            <a:rPr lang="en-US" sz="1400" b="0" i="1" smtClean="0">
+                              <a:latin typeface="Cambria Math" panose="02040503050406030204" pitchFamily="18" charset="0"/>
+                            </a:rPr>
+                            <m:t>r</m:t>
+                          </m:r>
+                        </m:e>
+                        <m:sup>
+                          <m:r>
+                            <a:rPr lang="en-US" sz="1400" b="0" i="1" smtClean="0">
+                              <a:latin typeface="Cambria Math" panose="02040503050406030204" pitchFamily="18" charset="0"/>
+                            </a:rPr>
+                            <m:t>2</m:t>
+                          </m:r>
+                        </m:sup>
+                      </m:sSup>
+                      <m:r>
+                        <m:rPr>
+                          <m:sty m:val="p"/>
+                        </m:rPr>
+                        <a:rPr lang="en-US" sz="1400" b="0" i="1" smtClean="0">
+                          <a:latin typeface="Cambria Math" panose="02040503050406030204" pitchFamily="18" charset="0"/>
+                        </a:rPr>
+                        <m:t>Lg</m:t>
+                      </m:r>
+                      <m:r>
+                        <a:rPr lang="en-US" sz="1400" b="0" i="1" smtClean="0">
+                          <a:latin typeface="Cambria Math" panose="02040503050406030204" pitchFamily="18" charset="0"/>
+                        </a:rPr>
+                        <m:t> ≈1.7×</m:t>
+                      </m:r>
+                      <m:sSup>
+                        <m:sSupPr>
+                          <m:ctrlPr>
+                            <a:rPr lang="en-US" sz="1400" b="0" i="1" smtClean="0">
+                              <a:latin typeface="Cambria Math" panose="02040503050406030204" pitchFamily="18" charset="0"/>
+                            </a:rPr>
+                          </m:ctrlPr>
+                        </m:sSupPr>
+                        <m:e>
+                          <m:r>
+                            <a:rPr lang="en-US" sz="1400" b="0" i="1" smtClean="0">
+                              <a:latin typeface="Cambria Math" panose="02040503050406030204" pitchFamily="18" charset="0"/>
+                            </a:rPr>
+                            <m:t>10</m:t>
+                          </m:r>
+                        </m:e>
+                        <m:sup>
+                          <m:r>
+                            <a:rPr lang="en-US" sz="1400" b="0" i="1" smtClean="0">
+                              <a:latin typeface="Cambria Math" panose="02040503050406030204" pitchFamily="18" charset="0"/>
+                            </a:rPr>
+                            <m:t>-9</m:t>
+                          </m:r>
+                        </m:sup>
+                      </m:sSup>
+                      <m:r>
+                        <a:rPr lang="en-US" sz="1400" b="0" i="1" smtClean="0">
+                          <a:latin typeface="Cambria Math" panose="02040503050406030204" pitchFamily="18" charset="0"/>
+                        </a:rPr>
+                        <m:t> </m:t>
+                      </m:r>
+                      <m:r>
+                        <m:rPr>
+                          <m:sty m:val="p"/>
+                        </m:rPr>
+                        <a:rPr lang="en-US" sz="1400" b="0" i="1" smtClean="0">
+                          <a:latin typeface="Cambria Math" panose="02040503050406030204" pitchFamily="18" charset="0"/>
+                        </a:rPr>
+                        <m:t>N</m:t>
+                      </m:r>
+                    </m:oMath>
+                  </m:oMathPara>
+                </a14:m>
+                <a:endParaRPr lang="en-US" sz="1400" dirty="0"/>
+              </a:p>
+            </p:txBody>
+          </p:sp>
+        </mc:Choice>
+        <mc:Fallback>
+          <p:sp>
+            <p:nvSpPr>
+              <p:cNvPr id="15" name="TextBox 14">
+                <a:extLst>
+                  <a:ext uri="{FF2B5EF4-FFF2-40B4-BE49-F238E27FC236}">
+                    <a16:creationId xmlns:a16="http://schemas.microsoft.com/office/drawing/2014/main" id="{7A2C9ACA-5C17-A788-F6AE-968814F4924B}"/>
+                  </a:ext>
+                </a:extLst>
+              </p:cNvPr>
+              <p:cNvSpPr txBox="1">
+                <a:spLocks noRot="1" noChangeAspect="1" noMove="1" noResize="1" noEditPoints="1" noAdjustHandles="1" noChangeArrowheads="1" noChangeShapeType="1" noTextEdit="1"/>
+              </p:cNvSpPr>
+              <p:nvPr/>
+            </p:nvSpPr>
+            <p:spPr>
+              <a:xfrm>
+                <a:off x="9482275" y="1402679"/>
+                <a:ext cx="1900392" cy="215444"/>
+              </a:xfrm>
+              <a:prstGeom prst="rect">
+                <a:avLst/>
+              </a:prstGeom>
+              <a:blipFill>
+                <a:blip r:embed="rId8"/>
+                <a:stretch>
+                  <a:fillRect l="-1325" t="-5556" r="-1325" b="-38889"/>
+                </a:stretch>
+              </a:blipFill>
+            </p:spPr>
+            <p:txBody>
+              <a:bodyPr/>
+              <a:lstStyle/>
+              <a:p>
+                <a:r>
+                  <a:rPr lang="en-US">
+                    <a:noFill/>
+                  </a:rPr>
+                  <a:t> </a:t>
+                </a:r>
+              </a:p>
+            </p:txBody>
+          </p:sp>
+        </mc:Fallback>
+      </mc:AlternateContent>
+      <p:sp>
+        <p:nvSpPr>
+          <p:cNvPr id="16" name="TextBox 15">
+            <a:extLst>
+              <a:ext uri="{FF2B5EF4-FFF2-40B4-BE49-F238E27FC236}">
+                <a16:creationId xmlns:a16="http://schemas.microsoft.com/office/drawing/2014/main" id="{29F90F5C-216B-1954-722A-137F792EAAF2}"/>
+              </a:ext>
+            </a:extLst>
+          </p:cNvPr>
+          <p:cNvSpPr txBox="1"/>
+          <p:nvPr/>
+        </p:nvSpPr>
+        <p:spPr>
+          <a:xfrm>
+            <a:off x="9611531" y="1056620"/>
+            <a:ext cx="1671400" cy="307777"/>
+          </a:xfrm>
+          <a:prstGeom prst="rect">
+            <a:avLst/>
+          </a:prstGeom>
+          <a:noFill/>
+        </p:spPr>
+        <p:txBody>
+          <a:bodyPr wrap="square" rtlCol="0">
+            <a:spAutoFit/>
+          </a:bodyPr>
+          <a:lstStyle/>
+          <a:p>
+            <a:r>
+              <a:rPr lang="en-US" sz="1400" dirty="0"/>
+              <a:t>Thread weight</a:t>
+            </a:r>
+          </a:p>
+        </p:txBody>
+      </p:sp>
+      <p:sp>
+        <p:nvSpPr>
+          <p:cNvPr id="17" name="TextBox 16">
+            <a:extLst>
+              <a:ext uri="{FF2B5EF4-FFF2-40B4-BE49-F238E27FC236}">
+                <a16:creationId xmlns:a16="http://schemas.microsoft.com/office/drawing/2014/main" id="{DDE9B377-CA09-891B-2102-C0FAA670753F}"/>
+              </a:ext>
+            </a:extLst>
+          </p:cNvPr>
+          <p:cNvSpPr txBox="1"/>
+          <p:nvPr/>
+        </p:nvSpPr>
+        <p:spPr>
+          <a:xfrm>
+            <a:off x="9456677" y="1694687"/>
+            <a:ext cx="2160376" cy="523220"/>
+          </a:xfrm>
+          <a:prstGeom prst="rect">
+            <a:avLst/>
+          </a:prstGeom>
+          <a:noFill/>
+        </p:spPr>
+        <p:txBody>
+          <a:bodyPr wrap="square" rtlCol="0">
+            <a:spAutoFit/>
+          </a:bodyPr>
+          <a:lstStyle/>
+          <a:p>
+            <a:r>
+              <a:rPr lang="en-US" sz="1400" dirty="0"/>
+              <a:t>neglected here but kept in simulations.</a:t>
+            </a:r>
+          </a:p>
+        </p:txBody>
+      </p:sp>
     </p:spTree>
     <p:extLst>
       <p:ext uri="{BB962C8B-B14F-4D97-AF65-F5344CB8AC3E}">
@@ -17658,6 +18891,1762 @@
           </a:prstGeom>
         </p:spPr>
       </p:pic>
+      <p:sp>
+        <p:nvSpPr>
+          <p:cNvPr id="7" name="TextBox 6">
+            <a:extLst>
+              <a:ext uri="{FF2B5EF4-FFF2-40B4-BE49-F238E27FC236}">
+                <a16:creationId xmlns:a16="http://schemas.microsoft.com/office/drawing/2014/main" id="{4A506484-1792-FAF3-DA8A-76EC27C8456D}"/>
+              </a:ext>
+            </a:extLst>
+          </p:cNvPr>
+          <p:cNvSpPr txBox="1"/>
+          <p:nvPr/>
+        </p:nvSpPr>
+        <p:spPr>
+          <a:xfrm>
+            <a:off x="820894" y="1755732"/>
+            <a:ext cx="4744779" cy="369332"/>
+          </a:xfrm>
+          <a:prstGeom prst="rect">
+            <a:avLst/>
+          </a:prstGeom>
+          <a:noFill/>
+        </p:spPr>
+        <p:txBody>
+          <a:bodyPr wrap="square">
+            <a:spAutoFit/>
+          </a:bodyPr>
+          <a:lstStyle/>
+          <a:p>
+            <a:pPr>
+              <a:buNone/>
+            </a:pPr>
+            <a:r>
+              <a:rPr lang="en-US" dirty="0">
+                <a:effectLst/>
+                <a:latin typeface="Helvetica" pitchFamily="2" charset="0"/>
+              </a:rPr>
+              <a:t>Over flat ground we use Gorham’s profile:</a:t>
+            </a:r>
+          </a:p>
+        </p:txBody>
+      </p:sp>
+      <mc:AlternateContent xmlns:mc="http://schemas.openxmlformats.org/markup-compatibility/2006">
+        <mc:Choice xmlns:a14="http://schemas.microsoft.com/office/drawing/2010/main" Requires="a14">
+          <p:sp>
+            <p:nvSpPr>
+              <p:cNvPr id="9" name="TextBox 8">
+                <a:extLst>
+                  <a:ext uri="{FF2B5EF4-FFF2-40B4-BE49-F238E27FC236}">
+                    <a16:creationId xmlns:a16="http://schemas.microsoft.com/office/drawing/2014/main" id="{5B8428E3-BAFA-C70E-6655-D8944AF8414E}"/>
+                  </a:ext>
+                </a:extLst>
+              </p:cNvPr>
+              <p:cNvSpPr txBox="1"/>
+              <p:nvPr/>
+            </p:nvSpPr>
+            <p:spPr>
+              <a:xfrm>
+                <a:off x="844276" y="2381679"/>
+                <a:ext cx="4454425" cy="276999"/>
+              </a:xfrm>
+              <a:prstGeom prst="rect">
+                <a:avLst/>
+              </a:prstGeom>
+              <a:noFill/>
+            </p:spPr>
+            <p:txBody>
+              <a:bodyPr wrap="none" lIns="0" tIns="0" rIns="0" bIns="0" rtlCol="0">
+                <a:spAutoFit/>
+              </a:bodyPr>
+              <a:lstStyle/>
+              <a:p>
+                <a14:m>
+                  <m:oMathPara xmlns:m="http://schemas.openxmlformats.org/officeDocument/2006/math">
+                    <m:oMathParaPr>
+                      <m:jc m:val="centerGroup"/>
+                    </m:oMathParaPr>
+                    <m:oMath xmlns:m="http://schemas.openxmlformats.org/officeDocument/2006/math">
+                      <m:r>
+                        <m:rPr>
+                          <m:sty m:val="p"/>
+                        </m:rPr>
+                        <a:rPr lang="en-US" b="0" i="1" smtClean="0">
+                          <a:latin typeface="Cambria Math" panose="02040503050406030204" pitchFamily="18" charset="0"/>
+                        </a:rPr>
+                        <m:t>E</m:t>
+                      </m:r>
+                      <m:r>
+                        <a:rPr lang="en-US" b="0" i="1" smtClean="0">
+                          <a:latin typeface="Cambria Math" panose="02040503050406030204" pitchFamily="18" charset="0"/>
+                        </a:rPr>
+                        <m:t>(</m:t>
+                      </m:r>
+                      <m:r>
+                        <m:rPr>
+                          <m:sty m:val="p"/>
+                        </m:rPr>
+                        <a:rPr lang="en-US" b="0" i="1" smtClean="0">
+                          <a:latin typeface="Cambria Math" panose="02040503050406030204" pitchFamily="18" charset="0"/>
+                        </a:rPr>
+                        <m:t>z</m:t>
+                      </m:r>
+                      <m:r>
+                        <a:rPr lang="en-US" b="0" i="1" smtClean="0">
+                          <a:latin typeface="Cambria Math" panose="02040503050406030204" pitchFamily="18" charset="0"/>
+                        </a:rPr>
+                        <m:t>)=</m:t>
+                      </m:r>
+                      <m:sSub>
+                        <m:sSubPr>
+                          <m:ctrlPr>
+                            <a:rPr lang="en-US" b="0" i="1" smtClean="0">
+                              <a:latin typeface="Cambria Math" panose="02040503050406030204" pitchFamily="18" charset="0"/>
+                            </a:rPr>
+                          </m:ctrlPr>
+                        </m:sSubPr>
+                        <m:e>
+                          <m:r>
+                            <m:rPr>
+                              <m:sty m:val="p"/>
+                            </m:rPr>
+                            <a:rPr lang="en-US" b="0" i="1" smtClean="0">
+                              <a:latin typeface="Cambria Math" panose="02040503050406030204" pitchFamily="18" charset="0"/>
+                            </a:rPr>
+                            <m:t>E</m:t>
+                          </m:r>
+                        </m:e>
+                        <m:sub>
+                          <m:r>
+                            <a:rPr lang="en-US" b="0" i="1" smtClean="0">
+                              <a:latin typeface="Cambria Math" panose="02040503050406030204" pitchFamily="18" charset="0"/>
+                            </a:rPr>
+                            <m:t>0</m:t>
+                          </m:r>
+                        </m:sub>
+                      </m:sSub>
+                      <m:sSup>
+                        <m:sSupPr>
+                          <m:ctrlPr>
+                            <a:rPr lang="en-US" b="0" i="1" smtClean="0">
+                              <a:latin typeface="Cambria Math" panose="02040503050406030204" pitchFamily="18" charset="0"/>
+                            </a:rPr>
+                          </m:ctrlPr>
+                        </m:sSupPr>
+                        <m:e>
+                          <m:r>
+                            <m:rPr>
+                              <m:sty m:val="p"/>
+                            </m:rPr>
+                            <a:rPr lang="en-US" b="0" i="1" smtClean="0">
+                              <a:latin typeface="Cambria Math" panose="02040503050406030204" pitchFamily="18" charset="0"/>
+                            </a:rPr>
+                            <m:t>e</m:t>
+                          </m:r>
+                        </m:e>
+                        <m:sup>
+                          <m:r>
+                            <a:rPr lang="en-US" b="0" i="1" smtClean="0">
+                              <a:latin typeface="Cambria Math" panose="02040503050406030204" pitchFamily="18" charset="0"/>
+                            </a:rPr>
+                            <m:t>-</m:t>
+                          </m:r>
+                          <m:r>
+                            <m:rPr>
+                              <m:sty m:val="p"/>
+                            </m:rPr>
+                            <a:rPr lang="en-US" b="0" i="1" smtClean="0">
+                              <a:latin typeface="Cambria Math" panose="02040503050406030204" pitchFamily="18" charset="0"/>
+                            </a:rPr>
+                            <m:t>αz</m:t>
+                          </m:r>
+                        </m:sup>
+                      </m:sSup>
+                      <m:r>
+                        <a:rPr lang="en-US" b="0" i="1" smtClean="0">
+                          <a:latin typeface="Cambria Math" panose="02040503050406030204" pitchFamily="18" charset="0"/>
+                        </a:rPr>
+                        <m:t>,</m:t>
+                      </m:r>
+                      <m:sSub>
+                        <m:sSubPr>
+                          <m:ctrlPr>
+                            <a:rPr lang="en-US" i="1">
+                              <a:latin typeface="Cambria Math" panose="02040503050406030204" pitchFamily="18" charset="0"/>
+                            </a:rPr>
+                          </m:ctrlPr>
+                        </m:sSubPr>
+                        <m:e>
+                          <m:r>
+                            <m:rPr>
+                              <m:sty m:val="p"/>
+                            </m:rPr>
+                            <a:rPr lang="en-US" i="1">
+                              <a:latin typeface="Cambria Math" panose="02040503050406030204" pitchFamily="18" charset="0"/>
+                            </a:rPr>
+                            <m:t>E</m:t>
+                          </m:r>
+                        </m:e>
+                        <m:sub>
+                          <m:r>
+                            <a:rPr lang="en-US" i="1">
+                              <a:latin typeface="Cambria Math" panose="02040503050406030204" pitchFamily="18" charset="0"/>
+                            </a:rPr>
+                            <m:t>0</m:t>
+                          </m:r>
+                        </m:sub>
+                      </m:sSub>
+                      <m:r>
+                        <a:rPr lang="en-US" b="0" i="1" smtClean="0">
+                          <a:latin typeface="Cambria Math" panose="02040503050406030204" pitchFamily="18" charset="0"/>
+                        </a:rPr>
+                        <m:t>=120 </m:t>
+                      </m:r>
+                      <m:r>
+                        <m:rPr>
+                          <m:sty m:val="p"/>
+                        </m:rPr>
+                        <a:rPr lang="en-US" b="0" i="1" smtClean="0">
+                          <a:latin typeface="Cambria Math" panose="02040503050406030204" pitchFamily="18" charset="0"/>
+                        </a:rPr>
+                        <m:t>V</m:t>
+                      </m:r>
+                      <m:r>
+                        <a:rPr lang="en-US" b="0" i="1" smtClean="0">
+                          <a:latin typeface="Cambria Math" panose="02040503050406030204" pitchFamily="18" charset="0"/>
+                        </a:rPr>
+                        <m:t>/</m:t>
+                      </m:r>
+                      <m:r>
+                        <m:rPr>
+                          <m:sty m:val="p"/>
+                        </m:rPr>
+                        <a:rPr lang="en-US" b="0" i="1" smtClean="0">
+                          <a:latin typeface="Cambria Math" panose="02040503050406030204" pitchFamily="18" charset="0"/>
+                        </a:rPr>
+                        <m:t>m</m:t>
+                      </m:r>
+                      <m:r>
+                        <a:rPr lang="en-US" b="0" i="1" smtClean="0">
+                          <a:latin typeface="Cambria Math" panose="02040503050406030204" pitchFamily="18" charset="0"/>
+                        </a:rPr>
+                        <m:t>, </m:t>
+                      </m:r>
+                      <m:r>
+                        <m:rPr>
+                          <m:sty m:val="p"/>
+                        </m:rPr>
+                        <a:rPr lang="en-US" b="0" i="1" smtClean="0">
+                          <a:latin typeface="Cambria Math" panose="02040503050406030204" pitchFamily="18" charset="0"/>
+                        </a:rPr>
+                        <m:t>α</m:t>
+                      </m:r>
+                      <m:r>
+                        <a:rPr lang="en-US" b="0" i="1" smtClean="0">
+                          <a:latin typeface="Cambria Math" panose="02040503050406030204" pitchFamily="18" charset="0"/>
+                        </a:rPr>
+                        <m:t>=3×1</m:t>
+                      </m:r>
+                      <m:sSup>
+                        <m:sSupPr>
+                          <m:ctrlPr>
+                            <a:rPr lang="en-US" b="0" i="1" smtClean="0">
+                              <a:latin typeface="Cambria Math" panose="02040503050406030204" pitchFamily="18" charset="0"/>
+                            </a:rPr>
+                          </m:ctrlPr>
+                        </m:sSupPr>
+                        <m:e>
+                          <m:r>
+                            <a:rPr lang="en-US" b="0" i="1" smtClean="0">
+                              <a:latin typeface="Cambria Math" panose="02040503050406030204" pitchFamily="18" charset="0"/>
+                            </a:rPr>
+                            <m:t>0</m:t>
+                          </m:r>
+                        </m:e>
+                        <m:sup>
+                          <m:r>
+                            <a:rPr lang="en-US" b="0" i="1" smtClean="0">
+                              <a:latin typeface="Cambria Math" panose="02040503050406030204" pitchFamily="18" charset="0"/>
+                            </a:rPr>
+                            <m:t>4</m:t>
+                          </m:r>
+                        </m:sup>
+                      </m:sSup>
+                      <m:sSup>
+                        <m:sSupPr>
+                          <m:ctrlPr>
+                            <a:rPr lang="en-US" b="0" i="1" smtClean="0">
+                              <a:latin typeface="Cambria Math" panose="02040503050406030204" pitchFamily="18" charset="0"/>
+                            </a:rPr>
+                          </m:ctrlPr>
+                        </m:sSupPr>
+                        <m:e>
+                          <m:r>
+                            <m:rPr>
+                              <m:sty m:val="p"/>
+                            </m:rPr>
+                            <a:rPr lang="en-US" b="0" i="1" smtClean="0">
+                              <a:latin typeface="Cambria Math" panose="02040503050406030204" pitchFamily="18" charset="0"/>
+                            </a:rPr>
+                            <m:t>m</m:t>
+                          </m:r>
+                        </m:e>
+                        <m:sup>
+                          <m:r>
+                            <a:rPr lang="en-US" b="0" i="1" smtClean="0">
+                              <a:latin typeface="Cambria Math" panose="02040503050406030204" pitchFamily="18" charset="0"/>
+                            </a:rPr>
+                            <m:t>-1</m:t>
+                          </m:r>
+                        </m:sup>
+                      </m:sSup>
+                    </m:oMath>
+                  </m:oMathPara>
+                </a14:m>
+                <a:endParaRPr lang="en-US" dirty="0"/>
+              </a:p>
+            </p:txBody>
+          </p:sp>
+        </mc:Choice>
+        <mc:Fallback>
+          <p:sp>
+            <p:nvSpPr>
+              <p:cNvPr id="9" name="TextBox 8">
+                <a:extLst>
+                  <a:ext uri="{FF2B5EF4-FFF2-40B4-BE49-F238E27FC236}">
+                    <a16:creationId xmlns:a16="http://schemas.microsoft.com/office/drawing/2014/main" id="{5B8428E3-BAFA-C70E-6655-D8944AF8414E}"/>
+                  </a:ext>
+                </a:extLst>
+              </p:cNvPr>
+              <p:cNvSpPr txBox="1">
+                <a:spLocks noRot="1" noChangeAspect="1" noMove="1" noResize="1" noEditPoints="1" noAdjustHandles="1" noChangeArrowheads="1" noChangeShapeType="1" noTextEdit="1"/>
+              </p:cNvSpPr>
+              <p:nvPr/>
+            </p:nvSpPr>
+            <p:spPr>
+              <a:xfrm>
+                <a:off x="844276" y="2381679"/>
+                <a:ext cx="4454425" cy="276999"/>
+              </a:xfrm>
+              <a:prstGeom prst="rect">
+                <a:avLst/>
+              </a:prstGeom>
+              <a:blipFill>
+                <a:blip r:embed="rId3"/>
+                <a:stretch>
+                  <a:fillRect l="-568" t="-4348" b="-39130"/>
+                </a:stretch>
+              </a:blipFill>
+            </p:spPr>
+            <p:txBody>
+              <a:bodyPr/>
+              <a:lstStyle/>
+              <a:p>
+                <a:r>
+                  <a:rPr lang="en-US">
+                    <a:noFill/>
+                  </a:rPr>
+                  <a:t> </a:t>
+                </a:r>
+              </a:p>
+            </p:txBody>
+          </p:sp>
+        </mc:Fallback>
+      </mc:AlternateContent>
+      <p:grpSp>
+        <p:nvGrpSpPr>
+          <p:cNvPr id="36" name="Group 35">
+            <a:extLst>
+              <a:ext uri="{FF2B5EF4-FFF2-40B4-BE49-F238E27FC236}">
+                <a16:creationId xmlns:a16="http://schemas.microsoft.com/office/drawing/2014/main" id="{59DBFC61-863A-2378-6F1E-BE20A73D0FA9}"/>
+              </a:ext>
+            </a:extLst>
+          </p:cNvPr>
+          <p:cNvGrpSpPr/>
+          <p:nvPr/>
+        </p:nvGrpSpPr>
+        <p:grpSpPr>
+          <a:xfrm>
+            <a:off x="7121369" y="0"/>
+            <a:ext cx="3437752" cy="3668555"/>
+            <a:chOff x="6622093" y="1037292"/>
+            <a:chExt cx="3437752" cy="3668555"/>
+          </a:xfrm>
+        </p:grpSpPr>
+        <p:sp>
+          <p:nvSpPr>
+            <p:cNvPr id="19" name="Arc 18">
+              <a:extLst>
+                <a:ext uri="{FF2B5EF4-FFF2-40B4-BE49-F238E27FC236}">
+                  <a16:creationId xmlns:a16="http://schemas.microsoft.com/office/drawing/2014/main" id="{C99D533C-47F2-0DF1-2C11-E72642AF0B03}"/>
+                </a:ext>
+              </a:extLst>
+            </p:cNvPr>
+            <p:cNvSpPr/>
+            <p:nvPr/>
+          </p:nvSpPr>
+          <p:spPr>
+            <a:xfrm rot="6171526">
+              <a:off x="6506691" y="1152694"/>
+              <a:ext cx="3668555" cy="3437752"/>
+            </a:xfrm>
+            <a:prstGeom prst="arc">
+              <a:avLst/>
+            </a:prstGeom>
+            <a:ln w="15875"/>
+          </p:spPr>
+          <p:style>
+            <a:lnRef idx="2">
+              <a:schemeClr val="dk1"/>
+            </a:lnRef>
+            <a:fillRef idx="0">
+              <a:schemeClr val="dk1"/>
+            </a:fillRef>
+            <a:effectRef idx="1">
+              <a:schemeClr val="dk1"/>
+            </a:effectRef>
+            <a:fontRef idx="minor">
+              <a:schemeClr val="tx1"/>
+            </a:fontRef>
+          </p:style>
+          <p:txBody>
+            <a:bodyPr rtlCol="0" anchor="ctr"/>
+            <a:lstStyle/>
+            <a:p>
+              <a:pPr algn="ctr"/>
+              <a:endParaRPr lang="en-US"/>
+            </a:p>
+          </p:txBody>
+        </p:sp>
+        <p:cxnSp>
+          <p:nvCxnSpPr>
+            <p:cNvPr id="28" name="Straight Arrow Connector 27">
+              <a:extLst>
+                <a:ext uri="{FF2B5EF4-FFF2-40B4-BE49-F238E27FC236}">
+                  <a16:creationId xmlns:a16="http://schemas.microsoft.com/office/drawing/2014/main" id="{160941A8-5409-0EA4-33EF-7B6EC58029C2}"/>
+                </a:ext>
+              </a:extLst>
+            </p:cNvPr>
+            <p:cNvCxnSpPr>
+              <a:cxnSpLocks/>
+            </p:cNvCxnSpPr>
+            <p:nvPr/>
+          </p:nvCxnSpPr>
+          <p:spPr>
+            <a:xfrm flipV="1">
+              <a:off x="9457393" y="3429000"/>
+              <a:ext cx="0" cy="816675"/>
+            </a:xfrm>
+            <a:prstGeom prst="straightConnector1">
+              <a:avLst/>
+            </a:prstGeom>
+            <a:ln>
+              <a:tailEnd type="triangle"/>
+            </a:ln>
+          </p:spPr>
+          <p:style>
+            <a:lnRef idx="2">
+              <a:schemeClr val="accent3"/>
+            </a:lnRef>
+            <a:fillRef idx="0">
+              <a:schemeClr val="accent3"/>
+            </a:fillRef>
+            <a:effectRef idx="1">
+              <a:schemeClr val="accent3"/>
+            </a:effectRef>
+            <a:fontRef idx="minor">
+              <a:schemeClr val="tx1"/>
+            </a:fontRef>
+          </p:style>
+        </p:cxnSp>
+        <mc:AlternateContent xmlns:mc="http://schemas.openxmlformats.org/markup-compatibility/2006">
+          <mc:Choice xmlns:a14="http://schemas.microsoft.com/office/drawing/2010/main" Requires="a14">
+            <p:sp>
+              <p:nvSpPr>
+                <p:cNvPr id="29" name="TextBox 28">
+                  <a:extLst>
+                    <a:ext uri="{FF2B5EF4-FFF2-40B4-BE49-F238E27FC236}">
+                      <a16:creationId xmlns:a16="http://schemas.microsoft.com/office/drawing/2014/main" id="{B35B191B-37BD-38CC-73EC-C675CF8018F1}"/>
+                    </a:ext>
+                  </a:extLst>
+                </p:cNvPr>
+                <p:cNvSpPr txBox="1"/>
+                <p:nvPr/>
+              </p:nvSpPr>
+              <p:spPr>
+                <a:xfrm>
+                  <a:off x="9172099" y="3369635"/>
+                  <a:ext cx="237180" cy="318613"/>
+                </a:xfrm>
+                <a:prstGeom prst="rect">
+                  <a:avLst/>
+                </a:prstGeom>
+                <a:noFill/>
+              </p:spPr>
+              <p:txBody>
+                <a:bodyPr wrap="none" lIns="0" tIns="0" rIns="0" bIns="0" rtlCol="0">
+                  <a:spAutoFit/>
+                </a:bodyPr>
+                <a:lstStyle/>
+                <a:p>
+                  <a14:m>
+                    <m:oMathPara xmlns:m="http://schemas.openxmlformats.org/officeDocument/2006/math">
+                      <m:oMathParaPr>
+                        <m:jc m:val="centerGroup"/>
+                      </m:oMathParaPr>
+                      <m:oMath xmlns:m="http://schemas.openxmlformats.org/officeDocument/2006/math">
+                        <m:acc>
+                          <m:accPr>
+                            <m:chr m:val="⃗"/>
+                            <m:ctrlPr>
+                              <a:rPr lang="en-US" i="1" smtClean="0">
+                                <a:latin typeface="Cambria Math" panose="02040503050406030204" pitchFamily="18" charset="0"/>
+                              </a:rPr>
+                            </m:ctrlPr>
+                          </m:accPr>
+                          <m:e>
+                            <m:sSub>
+                              <m:sSubPr>
+                                <m:ctrlPr>
+                                  <a:rPr lang="en-US" i="1">
+                                    <a:latin typeface="Cambria Math" panose="02040503050406030204" pitchFamily="18" charset="0"/>
+                                  </a:rPr>
+                                </m:ctrlPr>
+                              </m:sSubPr>
+                              <m:e>
+                                <m:r>
+                                  <m:rPr>
+                                    <m:sty m:val="p"/>
+                                  </m:rPr>
+                                  <a:rPr lang="en-US" b="0" i="1" smtClean="0">
+                                    <a:latin typeface="Cambria Math" panose="02040503050406030204" pitchFamily="18" charset="0"/>
+                                  </a:rPr>
+                                  <m:t>f</m:t>
+                                </m:r>
+                              </m:e>
+                              <m:sub>
+                                <m:r>
+                                  <m:rPr>
+                                    <m:sty m:val="p"/>
+                                  </m:rPr>
+                                  <a:rPr lang="en-US" b="0" i="1" smtClean="0">
+                                    <a:latin typeface="Cambria Math" panose="02040503050406030204" pitchFamily="18" charset="0"/>
+                                  </a:rPr>
+                                  <m:t>e</m:t>
+                                </m:r>
+                              </m:sub>
+                            </m:sSub>
+                          </m:e>
+                        </m:acc>
+                      </m:oMath>
+                    </m:oMathPara>
+                  </a14:m>
+                  <a:endParaRPr lang="en-US" dirty="0"/>
+                </a:p>
+              </p:txBody>
+            </p:sp>
+          </mc:Choice>
+          <mc:Fallback>
+            <p:sp>
+              <p:nvSpPr>
+                <p:cNvPr id="29" name="TextBox 28">
+                  <a:extLst>
+                    <a:ext uri="{FF2B5EF4-FFF2-40B4-BE49-F238E27FC236}">
+                      <a16:creationId xmlns:a16="http://schemas.microsoft.com/office/drawing/2014/main" id="{B35B191B-37BD-38CC-73EC-C675CF8018F1}"/>
+                    </a:ext>
+                  </a:extLst>
+                </p:cNvPr>
+                <p:cNvSpPr txBox="1">
+                  <a:spLocks noRot="1" noChangeAspect="1" noMove="1" noResize="1" noEditPoints="1" noAdjustHandles="1" noChangeArrowheads="1" noChangeShapeType="1" noTextEdit="1"/>
+                </p:cNvSpPr>
+                <p:nvPr/>
+              </p:nvSpPr>
+              <p:spPr>
+                <a:xfrm>
+                  <a:off x="9172099" y="3369635"/>
+                  <a:ext cx="237180" cy="318613"/>
+                </a:xfrm>
+                <a:prstGeom prst="rect">
+                  <a:avLst/>
+                </a:prstGeom>
+                <a:blipFill>
+                  <a:blip r:embed="rId4"/>
+                  <a:stretch>
+                    <a:fillRect l="-21053" b="-11538"/>
+                  </a:stretch>
+                </a:blipFill>
+              </p:spPr>
+              <p:txBody>
+                <a:bodyPr/>
+                <a:lstStyle/>
+                <a:p>
+                  <a:r>
+                    <a:rPr lang="en-US">
+                      <a:noFill/>
+                    </a:rPr>
+                    <a:t> </a:t>
+                  </a:r>
+                </a:p>
+              </p:txBody>
+            </p:sp>
+          </mc:Fallback>
+        </mc:AlternateContent>
+        <p:cxnSp>
+          <p:nvCxnSpPr>
+            <p:cNvPr id="33" name="Straight Connector 32">
+              <a:extLst>
+                <a:ext uri="{FF2B5EF4-FFF2-40B4-BE49-F238E27FC236}">
+                  <a16:creationId xmlns:a16="http://schemas.microsoft.com/office/drawing/2014/main" id="{8330F4FF-FF9C-DC0B-8311-8CBA6014EB2D}"/>
+                </a:ext>
+              </a:extLst>
+            </p:cNvPr>
+            <p:cNvCxnSpPr>
+              <a:cxnSpLocks/>
+            </p:cNvCxnSpPr>
+            <p:nvPr/>
+          </p:nvCxnSpPr>
+          <p:spPr>
+            <a:xfrm flipV="1">
+              <a:off x="9409279" y="4188282"/>
+              <a:ext cx="133174" cy="124473"/>
+            </a:xfrm>
+            <a:prstGeom prst="line">
+              <a:avLst/>
+            </a:prstGeom>
+            <a:ln w="38100">
+              <a:solidFill>
+                <a:srgbClr val="00B050"/>
+              </a:solidFill>
+            </a:ln>
+          </p:spPr>
+          <p:style>
+            <a:lnRef idx="1">
+              <a:schemeClr val="accent1"/>
+            </a:lnRef>
+            <a:fillRef idx="0">
+              <a:schemeClr val="accent1"/>
+            </a:fillRef>
+            <a:effectRef idx="0">
+              <a:schemeClr val="accent1"/>
+            </a:effectRef>
+            <a:fontRef idx="minor">
+              <a:schemeClr val="tx1"/>
+            </a:fontRef>
+          </p:style>
+        </p:cxnSp>
+      </p:grpSp>
+      <mc:AlternateContent xmlns:mc="http://schemas.openxmlformats.org/markup-compatibility/2006">
+        <mc:Choice xmlns:a14="http://schemas.microsoft.com/office/drawing/2010/main" Requires="a14">
+          <p:sp>
+            <p:nvSpPr>
+              <p:cNvPr id="35" name="TextBox 34">
+                <a:extLst>
+                  <a:ext uri="{FF2B5EF4-FFF2-40B4-BE49-F238E27FC236}">
+                    <a16:creationId xmlns:a16="http://schemas.microsoft.com/office/drawing/2014/main" id="{A5B9690F-4E69-29C7-D1F7-86F2C2D5C06B}"/>
+                  </a:ext>
+                </a:extLst>
+              </p:cNvPr>
+              <p:cNvSpPr txBox="1"/>
+              <p:nvPr/>
+            </p:nvSpPr>
+            <p:spPr>
+              <a:xfrm>
+                <a:off x="7975538" y="2071422"/>
+                <a:ext cx="1304716" cy="318613"/>
+              </a:xfrm>
+              <a:prstGeom prst="rect">
+                <a:avLst/>
+              </a:prstGeom>
+              <a:noFill/>
+            </p:spPr>
+            <p:txBody>
+              <a:bodyPr wrap="none" lIns="0" tIns="0" rIns="0" bIns="0" rtlCol="0">
+                <a:spAutoFit/>
+              </a:bodyPr>
+              <a:lstStyle/>
+              <a:p>
+                <a14:m>
+                  <m:oMathPara xmlns:m="http://schemas.openxmlformats.org/officeDocument/2006/math">
+                    <m:oMathParaPr>
+                      <m:jc m:val="centerGroup"/>
+                    </m:oMathParaPr>
+                    <m:oMath xmlns:m="http://schemas.openxmlformats.org/officeDocument/2006/math">
+                      <m:acc>
+                        <m:accPr>
+                          <m:chr m:val="⃗"/>
+                          <m:ctrlPr>
+                            <a:rPr lang="en-US" i="1" smtClean="0">
+                              <a:latin typeface="Cambria Math" panose="02040503050406030204" pitchFamily="18" charset="0"/>
+                            </a:rPr>
+                          </m:ctrlPr>
+                        </m:accPr>
+                        <m:e>
+                          <m:sSub>
+                            <m:sSubPr>
+                              <m:ctrlPr>
+                                <a:rPr lang="en-US" i="1" smtClean="0">
+                                  <a:latin typeface="Cambria Math" panose="02040503050406030204" pitchFamily="18" charset="0"/>
+                                </a:rPr>
+                              </m:ctrlPr>
+                            </m:sSubPr>
+                            <m:e>
+                              <m:r>
+                                <m:rPr>
+                                  <m:sty m:val="p"/>
+                                </m:rPr>
+                                <a:rPr lang="en-US" b="0" i="1" smtClean="0">
+                                  <a:latin typeface="Cambria Math" panose="02040503050406030204" pitchFamily="18" charset="0"/>
+                                </a:rPr>
+                                <m:t>f</m:t>
+                              </m:r>
+                            </m:e>
+                            <m:sub>
+                              <m:r>
+                                <m:rPr>
+                                  <m:sty m:val="p"/>
+                                </m:rPr>
+                                <a:rPr lang="en-US" b="0" i="1" smtClean="0">
+                                  <a:latin typeface="Cambria Math" panose="02040503050406030204" pitchFamily="18" charset="0"/>
+                                </a:rPr>
+                                <m:t>e</m:t>
+                              </m:r>
+                            </m:sub>
+                          </m:sSub>
+                        </m:e>
+                      </m:acc>
+                      <m:r>
+                        <a:rPr lang="en-US" b="0" i="1" smtClean="0">
+                          <a:latin typeface="Cambria Math" panose="02040503050406030204" pitchFamily="18" charset="0"/>
+                        </a:rPr>
+                        <m:t>=</m:t>
+                      </m:r>
+                      <m:r>
+                        <m:rPr>
+                          <m:sty m:val="p"/>
+                        </m:rPr>
+                        <a:rPr lang="en-US" b="0" i="1" smtClean="0">
+                          <a:latin typeface="Cambria Math" panose="02040503050406030204" pitchFamily="18" charset="0"/>
+                        </a:rPr>
+                        <m:t>λE</m:t>
+                      </m:r>
+                      <m:r>
+                        <a:rPr lang="en-US" b="0" i="1" smtClean="0">
+                          <a:latin typeface="Cambria Math" panose="02040503050406030204" pitchFamily="18" charset="0"/>
+                        </a:rPr>
+                        <m:t>(</m:t>
+                      </m:r>
+                      <m:r>
+                        <m:rPr>
+                          <m:sty m:val="p"/>
+                        </m:rPr>
+                        <a:rPr lang="en-US" b="0" i="1" smtClean="0">
+                          <a:latin typeface="Cambria Math" panose="02040503050406030204" pitchFamily="18" charset="0"/>
+                        </a:rPr>
+                        <m:t>z</m:t>
+                      </m:r>
+                      <m:r>
+                        <a:rPr lang="en-US" b="0" i="1" smtClean="0">
+                          <a:latin typeface="Cambria Math" panose="02040503050406030204" pitchFamily="18" charset="0"/>
+                        </a:rPr>
+                        <m:t>)</m:t>
+                      </m:r>
+                      <m:acc>
+                        <m:accPr>
+                          <m:chr m:val="⃗"/>
+                          <m:ctrlPr>
+                            <a:rPr lang="en-US" b="0" i="1" smtClean="0">
+                              <a:latin typeface="Cambria Math" panose="02040503050406030204" pitchFamily="18" charset="0"/>
+                            </a:rPr>
+                          </m:ctrlPr>
+                        </m:accPr>
+                        <m:e>
+                          <m:sSub>
+                            <m:sSubPr>
+                              <m:ctrlPr>
+                                <a:rPr lang="en-US" b="0" i="1" smtClean="0">
+                                  <a:latin typeface="Cambria Math" panose="02040503050406030204" pitchFamily="18" charset="0"/>
+                                </a:rPr>
+                              </m:ctrlPr>
+                            </m:sSubPr>
+                            <m:e>
+                              <m:r>
+                                <a:rPr lang="en-US" b="0" i="1" smtClean="0">
+                                  <a:latin typeface="Cambria Math" panose="02040503050406030204" pitchFamily="18" charset="0"/>
+                                </a:rPr>
+                                <m:t>1</m:t>
+                              </m:r>
+                            </m:e>
+                            <m:sub>
+                              <m:r>
+                                <m:rPr>
+                                  <m:sty m:val="p"/>
+                                </m:rPr>
+                                <a:rPr lang="en-US" b="0" i="1" smtClean="0">
+                                  <a:latin typeface="Cambria Math" panose="02040503050406030204" pitchFamily="18" charset="0"/>
+                                </a:rPr>
+                                <m:t>z</m:t>
+                              </m:r>
+                            </m:sub>
+                          </m:sSub>
+                        </m:e>
+                      </m:acc>
+                    </m:oMath>
+                  </m:oMathPara>
+                </a14:m>
+                <a:endParaRPr lang="en-US" dirty="0"/>
+              </a:p>
+            </p:txBody>
+          </p:sp>
+        </mc:Choice>
+        <mc:Fallback>
+          <p:sp>
+            <p:nvSpPr>
+              <p:cNvPr id="35" name="TextBox 34">
+                <a:extLst>
+                  <a:ext uri="{FF2B5EF4-FFF2-40B4-BE49-F238E27FC236}">
+                    <a16:creationId xmlns:a16="http://schemas.microsoft.com/office/drawing/2014/main" id="{A5B9690F-4E69-29C7-D1F7-86F2C2D5C06B}"/>
+                  </a:ext>
+                </a:extLst>
+              </p:cNvPr>
+              <p:cNvSpPr txBox="1">
+                <a:spLocks noRot="1" noChangeAspect="1" noMove="1" noResize="1" noEditPoints="1" noAdjustHandles="1" noChangeArrowheads="1" noChangeShapeType="1" noTextEdit="1"/>
+              </p:cNvSpPr>
+              <p:nvPr/>
+            </p:nvSpPr>
+            <p:spPr>
+              <a:xfrm>
+                <a:off x="7975538" y="2071422"/>
+                <a:ext cx="1304716" cy="318613"/>
+              </a:xfrm>
+              <a:prstGeom prst="rect">
+                <a:avLst/>
+              </a:prstGeom>
+              <a:blipFill>
+                <a:blip r:embed="rId5"/>
+                <a:stretch>
+                  <a:fillRect l="-2885" b="-30769"/>
+                </a:stretch>
+              </a:blipFill>
+            </p:spPr>
+            <p:txBody>
+              <a:bodyPr/>
+              <a:lstStyle/>
+              <a:p>
+                <a:r>
+                  <a:rPr lang="en-US">
+                    <a:noFill/>
+                  </a:rPr>
+                  <a:t> </a:t>
+                </a:r>
+              </a:p>
+            </p:txBody>
+          </p:sp>
+        </mc:Fallback>
+      </mc:AlternateContent>
+      <p:sp>
+        <p:nvSpPr>
+          <p:cNvPr id="37" name="TextBox 36">
+            <a:extLst>
+              <a:ext uri="{FF2B5EF4-FFF2-40B4-BE49-F238E27FC236}">
+                <a16:creationId xmlns:a16="http://schemas.microsoft.com/office/drawing/2014/main" id="{3F88AAC4-C776-7EAE-9701-AEFD236C1528}"/>
+              </a:ext>
+            </a:extLst>
+          </p:cNvPr>
+          <p:cNvSpPr txBox="1"/>
+          <p:nvPr/>
+        </p:nvSpPr>
+        <p:spPr>
+          <a:xfrm>
+            <a:off x="6789953" y="1725358"/>
+            <a:ext cx="2881422" cy="307777"/>
+          </a:xfrm>
+          <a:prstGeom prst="rect">
+            <a:avLst/>
+          </a:prstGeom>
+          <a:noFill/>
+        </p:spPr>
+        <p:txBody>
+          <a:bodyPr wrap="square" rtlCol="0">
+            <a:spAutoFit/>
+          </a:bodyPr>
+          <a:lstStyle/>
+          <a:p>
+            <a:r>
+              <a:rPr lang="en-US" sz="1400" i="1" dirty="0"/>
+              <a:t>Electrostatic force per unit length</a:t>
+            </a:r>
+          </a:p>
+        </p:txBody>
+      </p:sp>
+      <p:sp>
+        <p:nvSpPr>
+          <p:cNvPr id="38" name="TextBox 37">
+            <a:extLst>
+              <a:ext uri="{FF2B5EF4-FFF2-40B4-BE49-F238E27FC236}">
+                <a16:creationId xmlns:a16="http://schemas.microsoft.com/office/drawing/2014/main" id="{B0E18159-8962-6D91-4B13-72C56BF3D218}"/>
+              </a:ext>
+            </a:extLst>
+          </p:cNvPr>
+          <p:cNvSpPr txBox="1"/>
+          <p:nvPr/>
+        </p:nvSpPr>
+        <p:spPr>
+          <a:xfrm>
+            <a:off x="820894" y="2915293"/>
+            <a:ext cx="4869712" cy="646331"/>
+          </a:xfrm>
+          <a:prstGeom prst="rect">
+            <a:avLst/>
+          </a:prstGeom>
+          <a:noFill/>
+        </p:spPr>
+        <p:txBody>
+          <a:bodyPr wrap="square" rtlCol="0">
+            <a:spAutoFit/>
+          </a:bodyPr>
+          <a:lstStyle/>
+          <a:p>
+            <a:r>
+              <a:rPr lang="en-US" dirty="0">
+                <a:latin typeface="Helvetica" pitchFamily="2" charset="0"/>
+              </a:rPr>
+              <a:t>For the experiment of Morley and Gorham, the fit is given by:</a:t>
+            </a:r>
+          </a:p>
+        </p:txBody>
+      </p:sp>
+      <mc:AlternateContent xmlns:mc="http://schemas.openxmlformats.org/markup-compatibility/2006">
+        <mc:Choice xmlns:a14="http://schemas.microsoft.com/office/drawing/2010/main" Requires="a14">
+          <p:sp>
+            <p:nvSpPr>
+              <p:cNvPr id="39" name="TextBox 38">
+                <a:extLst>
+                  <a:ext uri="{FF2B5EF4-FFF2-40B4-BE49-F238E27FC236}">
+                    <a16:creationId xmlns:a16="http://schemas.microsoft.com/office/drawing/2014/main" id="{36363F44-C2D5-D23B-0942-2817D704FB54}"/>
+                  </a:ext>
+                </a:extLst>
+              </p:cNvPr>
+              <p:cNvSpPr txBox="1"/>
+              <p:nvPr/>
+            </p:nvSpPr>
+            <p:spPr>
+              <a:xfrm>
+                <a:off x="1553251" y="3725130"/>
+                <a:ext cx="3280064" cy="287323"/>
+              </a:xfrm>
+              <a:prstGeom prst="rect">
+                <a:avLst/>
+              </a:prstGeom>
+              <a:noFill/>
+            </p:spPr>
+            <p:txBody>
+              <a:bodyPr wrap="none" lIns="0" tIns="0" rIns="0" bIns="0" rtlCol="0">
+                <a:spAutoFit/>
+              </a:bodyPr>
+              <a:lstStyle/>
+              <a:p>
+                <a14:m>
+                  <m:oMathPara xmlns:m="http://schemas.openxmlformats.org/officeDocument/2006/math">
+                    <m:oMathParaPr>
+                      <m:jc m:val="centerGroup"/>
+                    </m:oMathParaPr>
+                    <m:oMath xmlns:m="http://schemas.openxmlformats.org/officeDocument/2006/math">
+                      <m:r>
+                        <m:rPr>
+                          <m:sty m:val="p"/>
+                        </m:rPr>
+                        <a:rPr lang="en-US" b="0" i="1" smtClean="0">
+                          <a:latin typeface="Cambria Math" panose="02040503050406030204" pitchFamily="18" charset="0"/>
+                        </a:rPr>
+                        <m:t>E</m:t>
+                      </m:r>
+                      <m:r>
+                        <a:rPr lang="en-US" b="0" i="1" smtClean="0">
+                          <a:latin typeface="Cambria Math" panose="02040503050406030204" pitchFamily="18" charset="0"/>
+                        </a:rPr>
+                        <m:t>(</m:t>
+                      </m:r>
+                      <m:r>
+                        <m:rPr>
+                          <m:sty m:val="p"/>
+                        </m:rPr>
+                        <a:rPr lang="en-US" b="0" i="1" smtClean="0">
+                          <a:latin typeface="Cambria Math" panose="02040503050406030204" pitchFamily="18" charset="0"/>
+                        </a:rPr>
+                        <m:t>z</m:t>
+                      </m:r>
+                      <m:r>
+                        <a:rPr lang="en-US" b="0" i="1" smtClean="0">
+                          <a:latin typeface="Cambria Math" panose="02040503050406030204" pitchFamily="18" charset="0"/>
+                        </a:rPr>
+                        <m:t>)=</m:t>
+                      </m:r>
+                      <m:sSub>
+                        <m:sSubPr>
+                          <m:ctrlPr>
+                            <a:rPr lang="en-US" b="0" i="1" smtClean="0">
+                              <a:latin typeface="Cambria Math" panose="02040503050406030204" pitchFamily="18" charset="0"/>
+                            </a:rPr>
+                          </m:ctrlPr>
+                        </m:sSubPr>
+                        <m:e>
+                          <m:r>
+                            <m:rPr>
+                              <m:sty m:val="p"/>
+                            </m:rPr>
+                            <a:rPr lang="en-US" b="0" i="1" smtClean="0">
+                              <a:latin typeface="Cambria Math" panose="02040503050406030204" pitchFamily="18" charset="0"/>
+                            </a:rPr>
+                            <m:t>E</m:t>
+                          </m:r>
+                        </m:e>
+                        <m:sub>
+                          <m:r>
+                            <a:rPr lang="en-US" b="0" i="1" smtClean="0">
+                              <a:latin typeface="Cambria Math" panose="02040503050406030204" pitchFamily="18" charset="0"/>
+                            </a:rPr>
+                            <m:t>1</m:t>
+                          </m:r>
+                        </m:sub>
+                      </m:sSub>
+                      <m:sSup>
+                        <m:sSupPr>
+                          <m:ctrlPr>
+                            <a:rPr lang="en-US" b="0" i="1" smtClean="0">
+                              <a:latin typeface="Cambria Math" panose="02040503050406030204" pitchFamily="18" charset="0"/>
+                            </a:rPr>
+                          </m:ctrlPr>
+                        </m:sSupPr>
+                        <m:e>
+                          <m:r>
+                            <m:rPr>
+                              <m:sty m:val="p"/>
+                            </m:rPr>
+                            <a:rPr lang="en-US" b="0" i="1" smtClean="0">
+                              <a:latin typeface="Cambria Math" panose="02040503050406030204" pitchFamily="18" charset="0"/>
+                            </a:rPr>
+                            <m:t>e</m:t>
+                          </m:r>
+                        </m:e>
+                        <m:sup>
+                          <m:r>
+                            <a:rPr lang="en-US" b="0" i="1" smtClean="0">
+                              <a:latin typeface="Cambria Math" panose="02040503050406030204" pitchFamily="18" charset="0"/>
+                            </a:rPr>
+                            <m:t>-</m:t>
+                          </m:r>
+                          <m:r>
+                            <m:rPr>
+                              <m:sty m:val="p"/>
+                            </m:rPr>
+                            <a:rPr lang="en-US" b="0" i="1" smtClean="0">
+                              <a:latin typeface="Cambria Math" panose="02040503050406030204" pitchFamily="18" charset="0"/>
+                            </a:rPr>
+                            <m:t>z</m:t>
+                          </m:r>
+                          <m:r>
+                            <a:rPr lang="en-US" b="0" i="1" smtClean="0">
+                              <a:latin typeface="Cambria Math" panose="02040503050406030204" pitchFamily="18" charset="0"/>
+                            </a:rPr>
+                            <m:t>/</m:t>
+                          </m:r>
+                          <m:sSub>
+                            <m:sSubPr>
+                              <m:ctrlPr>
+                                <a:rPr lang="en-US" b="0" i="1" smtClean="0">
+                                  <a:latin typeface="Cambria Math" panose="02040503050406030204" pitchFamily="18" charset="0"/>
+                                </a:rPr>
+                              </m:ctrlPr>
+                            </m:sSubPr>
+                            <m:e>
+                              <m:r>
+                                <m:rPr>
+                                  <m:sty m:val="p"/>
+                                </m:rPr>
+                                <a:rPr lang="en-US" b="0" i="1" smtClean="0">
+                                  <a:latin typeface="Cambria Math" panose="02040503050406030204" pitchFamily="18" charset="0"/>
+                                </a:rPr>
+                                <m:t>z</m:t>
+                              </m:r>
+                            </m:e>
+                            <m:sub>
+                              <m:r>
+                                <a:rPr lang="en-US" b="0" i="1" smtClean="0">
+                                  <a:latin typeface="Cambria Math" panose="02040503050406030204" pitchFamily="18" charset="0"/>
+                                </a:rPr>
+                                <m:t>1</m:t>
+                              </m:r>
+                            </m:sub>
+                          </m:sSub>
+                        </m:sup>
+                      </m:sSup>
+                      <m:r>
+                        <a:rPr lang="en-US" b="0" i="1" smtClean="0">
+                          <a:latin typeface="Cambria Math" panose="02040503050406030204" pitchFamily="18" charset="0"/>
+                        </a:rPr>
+                        <m:t>+</m:t>
+                      </m:r>
+                      <m:sSub>
+                        <m:sSubPr>
+                          <m:ctrlPr>
+                            <a:rPr lang="en-US" i="1">
+                              <a:latin typeface="Cambria Math" panose="02040503050406030204" pitchFamily="18" charset="0"/>
+                            </a:rPr>
+                          </m:ctrlPr>
+                        </m:sSubPr>
+                        <m:e>
+                          <m:r>
+                            <m:rPr>
+                              <m:sty m:val="p"/>
+                            </m:rPr>
+                            <a:rPr lang="en-US" i="1">
+                              <a:latin typeface="Cambria Math" panose="02040503050406030204" pitchFamily="18" charset="0"/>
+                            </a:rPr>
+                            <m:t>E</m:t>
+                          </m:r>
+                        </m:e>
+                        <m:sub>
+                          <m:r>
+                            <a:rPr lang="en-US" b="0" i="1" smtClean="0">
+                              <a:latin typeface="Cambria Math" panose="02040503050406030204" pitchFamily="18" charset="0"/>
+                            </a:rPr>
+                            <m:t>2</m:t>
+                          </m:r>
+                        </m:sub>
+                      </m:sSub>
+                      <m:sSup>
+                        <m:sSupPr>
+                          <m:ctrlPr>
+                            <a:rPr lang="en-US" i="1">
+                              <a:latin typeface="Cambria Math" panose="02040503050406030204" pitchFamily="18" charset="0"/>
+                            </a:rPr>
+                          </m:ctrlPr>
+                        </m:sSupPr>
+                        <m:e>
+                          <m:r>
+                            <m:rPr>
+                              <m:sty m:val="p"/>
+                            </m:rPr>
+                            <a:rPr lang="en-US" i="1">
+                              <a:latin typeface="Cambria Math" panose="02040503050406030204" pitchFamily="18" charset="0"/>
+                            </a:rPr>
+                            <m:t>e</m:t>
+                          </m:r>
+                        </m:e>
+                        <m:sup>
+                          <m:r>
+                            <a:rPr lang="en-US" i="1">
+                              <a:latin typeface="Cambria Math" panose="02040503050406030204" pitchFamily="18" charset="0"/>
+                            </a:rPr>
+                            <m:t>−</m:t>
+                          </m:r>
+                          <m:r>
+                            <m:rPr>
+                              <m:sty m:val="p"/>
+                            </m:rPr>
+                            <a:rPr lang="en-US" i="1">
+                              <a:latin typeface="Cambria Math" panose="02040503050406030204" pitchFamily="18" charset="0"/>
+                            </a:rPr>
+                            <m:t>z</m:t>
+                          </m:r>
+                          <m:r>
+                            <a:rPr lang="en-US" i="1">
+                              <a:latin typeface="Cambria Math" panose="02040503050406030204" pitchFamily="18" charset="0"/>
+                            </a:rPr>
+                            <m:t>/</m:t>
+                          </m:r>
+                          <m:sSub>
+                            <m:sSubPr>
+                              <m:ctrlPr>
+                                <a:rPr lang="en-US" i="1">
+                                  <a:latin typeface="Cambria Math" panose="02040503050406030204" pitchFamily="18" charset="0"/>
+                                </a:rPr>
+                              </m:ctrlPr>
+                            </m:sSubPr>
+                            <m:e>
+                              <m:r>
+                                <m:rPr>
+                                  <m:sty m:val="p"/>
+                                </m:rPr>
+                                <a:rPr lang="en-US" i="1">
+                                  <a:latin typeface="Cambria Math" panose="02040503050406030204" pitchFamily="18" charset="0"/>
+                                </a:rPr>
+                                <m:t>z</m:t>
+                              </m:r>
+                            </m:e>
+                            <m:sub>
+                              <m:r>
+                                <a:rPr lang="en-US" b="0" i="1" smtClean="0">
+                                  <a:latin typeface="Cambria Math" panose="02040503050406030204" pitchFamily="18" charset="0"/>
+                                </a:rPr>
+                                <m:t>2</m:t>
+                              </m:r>
+                            </m:sub>
+                          </m:sSub>
+                        </m:sup>
+                      </m:sSup>
+                      <m:r>
+                        <a:rPr lang="en-US" b="0" i="1" smtClean="0">
+                          <a:latin typeface="Cambria Math" panose="02040503050406030204" pitchFamily="18" charset="0"/>
+                        </a:rPr>
+                        <m:t>+</m:t>
+                      </m:r>
+                      <m:sSub>
+                        <m:sSubPr>
+                          <m:ctrlPr>
+                            <a:rPr lang="en-US" b="0" i="1" smtClean="0">
+                              <a:latin typeface="Cambria Math" panose="02040503050406030204" pitchFamily="18" charset="0"/>
+                            </a:rPr>
+                          </m:ctrlPr>
+                        </m:sSubPr>
+                        <m:e>
+                          <m:r>
+                            <m:rPr>
+                              <m:sty m:val="p"/>
+                            </m:rPr>
+                            <a:rPr lang="en-US" b="0" i="1" smtClean="0">
+                              <a:latin typeface="Cambria Math" panose="02040503050406030204" pitchFamily="18" charset="0"/>
+                            </a:rPr>
+                            <m:t>E</m:t>
+                          </m:r>
+                        </m:e>
+                        <m:sub>
+                          <m:r>
+                            <a:rPr lang="en-US" i="1">
+                              <a:latin typeface="Cambria Math" panose="02040503050406030204" pitchFamily="18" charset="0"/>
+                              <a:ea typeface="Cambria Math" panose="02040503050406030204" pitchFamily="18" charset="0"/>
+                            </a:rPr>
+                            <m:t>∞</m:t>
+                          </m:r>
+                        </m:sub>
+                      </m:sSub>
+                    </m:oMath>
+                  </m:oMathPara>
+                </a14:m>
+                <a:endParaRPr lang="en-US" dirty="0"/>
+              </a:p>
+            </p:txBody>
+          </p:sp>
+        </mc:Choice>
+        <mc:Fallback>
+          <p:sp>
+            <p:nvSpPr>
+              <p:cNvPr id="39" name="TextBox 38">
+                <a:extLst>
+                  <a:ext uri="{FF2B5EF4-FFF2-40B4-BE49-F238E27FC236}">
+                    <a16:creationId xmlns:a16="http://schemas.microsoft.com/office/drawing/2014/main" id="{36363F44-C2D5-D23B-0942-2817D704FB54}"/>
+                  </a:ext>
+                </a:extLst>
+              </p:cNvPr>
+              <p:cNvSpPr txBox="1">
+                <a:spLocks noRot="1" noChangeAspect="1" noMove="1" noResize="1" noEditPoints="1" noAdjustHandles="1" noChangeArrowheads="1" noChangeShapeType="1" noTextEdit="1"/>
+              </p:cNvSpPr>
+              <p:nvPr/>
+            </p:nvSpPr>
+            <p:spPr>
+              <a:xfrm>
+                <a:off x="1553251" y="3725130"/>
+                <a:ext cx="3280064" cy="287323"/>
+              </a:xfrm>
+              <a:prstGeom prst="rect">
+                <a:avLst/>
+              </a:prstGeom>
+              <a:blipFill>
+                <a:blip r:embed="rId6"/>
+                <a:stretch>
+                  <a:fillRect l="-386" t="-8696" b="-34783"/>
+                </a:stretch>
+              </a:blipFill>
+            </p:spPr>
+            <p:txBody>
+              <a:bodyPr/>
+              <a:lstStyle/>
+              <a:p>
+                <a:r>
+                  <a:rPr lang="en-US">
+                    <a:noFill/>
+                  </a:rPr>
+                  <a:t> </a:t>
+                </a:r>
+              </a:p>
+            </p:txBody>
+          </p:sp>
+        </mc:Fallback>
+      </mc:AlternateContent>
+      <mc:AlternateContent xmlns:mc="http://schemas.openxmlformats.org/markup-compatibility/2006">
+        <mc:Choice xmlns:a14="http://schemas.microsoft.com/office/drawing/2010/main" Requires="a14">
+          <p:sp>
+            <p:nvSpPr>
+              <p:cNvPr id="41" name="TextBox 40">
+                <a:extLst>
+                  <a:ext uri="{FF2B5EF4-FFF2-40B4-BE49-F238E27FC236}">
+                    <a16:creationId xmlns:a16="http://schemas.microsoft.com/office/drawing/2014/main" id="{1C9A2AB6-34FF-C04B-3E4A-D6114B70786B}"/>
+                  </a:ext>
+                </a:extLst>
+              </p:cNvPr>
+              <p:cNvSpPr txBox="1"/>
+              <p:nvPr/>
+            </p:nvSpPr>
+            <p:spPr>
+              <a:xfrm>
+                <a:off x="844276" y="4260094"/>
+                <a:ext cx="7262757" cy="217817"/>
+              </a:xfrm>
+              <a:prstGeom prst="rect">
+                <a:avLst/>
+              </a:prstGeom>
+              <a:noFill/>
+            </p:spPr>
+            <p:txBody>
+              <a:bodyPr wrap="none" lIns="0" tIns="0" rIns="0" bIns="0" rtlCol="0">
+                <a:spAutoFit/>
+              </a:bodyPr>
+              <a:lstStyle/>
+              <a:p>
+                <a14:m>
+                  <m:oMathPara xmlns:m="http://schemas.openxmlformats.org/officeDocument/2006/math">
+                    <m:oMathParaPr>
+                      <m:jc m:val="centerGroup"/>
+                    </m:oMathParaPr>
+                    <m:oMath xmlns:m="http://schemas.openxmlformats.org/officeDocument/2006/math">
+                      <m:sSub>
+                        <m:sSubPr>
+                          <m:ctrlPr>
+                            <a:rPr lang="en-US" sz="1400" i="1">
+                              <a:latin typeface="Cambria Math" panose="02040503050406030204" pitchFamily="18" charset="0"/>
+                            </a:rPr>
+                          </m:ctrlPr>
+                        </m:sSubPr>
+                        <m:e>
+                          <m:r>
+                            <m:rPr>
+                              <m:sty m:val="p"/>
+                            </m:rPr>
+                            <a:rPr lang="en-US" sz="1400" i="1">
+                              <a:latin typeface="Cambria Math" panose="02040503050406030204" pitchFamily="18" charset="0"/>
+                            </a:rPr>
+                            <m:t>E</m:t>
+                          </m:r>
+                        </m:e>
+                        <m:sub>
+                          <m:r>
+                            <a:rPr lang="en-US" sz="1400" i="1">
+                              <a:latin typeface="Cambria Math" panose="02040503050406030204" pitchFamily="18" charset="0"/>
+                            </a:rPr>
+                            <m:t>1</m:t>
+                          </m:r>
+                        </m:sub>
+                      </m:sSub>
+                      <m:r>
+                        <a:rPr lang="en-US" sz="1400" b="0" i="1" smtClean="0">
+                          <a:latin typeface="Cambria Math" panose="02040503050406030204" pitchFamily="18" charset="0"/>
+                        </a:rPr>
+                        <m:t>=2.52×</m:t>
+                      </m:r>
+                      <m:sSup>
+                        <m:sSupPr>
+                          <m:ctrlPr>
+                            <a:rPr lang="en-US" sz="1400" b="0" i="1" smtClean="0">
+                              <a:latin typeface="Cambria Math" panose="02040503050406030204" pitchFamily="18" charset="0"/>
+                            </a:rPr>
+                          </m:ctrlPr>
+                        </m:sSupPr>
+                        <m:e>
+                          <m:r>
+                            <a:rPr lang="en-US" sz="1400" b="0" i="1" smtClean="0">
+                              <a:latin typeface="Cambria Math" panose="02040503050406030204" pitchFamily="18" charset="0"/>
+                            </a:rPr>
+                            <m:t>10</m:t>
+                          </m:r>
+                        </m:e>
+                        <m:sup>
+                          <m:r>
+                            <a:rPr lang="en-US" sz="1400" b="0" i="1" smtClean="0">
+                              <a:latin typeface="Cambria Math" panose="02040503050406030204" pitchFamily="18" charset="0"/>
+                            </a:rPr>
+                            <m:t>5</m:t>
+                          </m:r>
+                        </m:sup>
+                      </m:sSup>
+                      <m:r>
+                        <a:rPr lang="en-US" sz="1400" b="0" i="1" smtClean="0">
+                          <a:latin typeface="Cambria Math" panose="02040503050406030204" pitchFamily="18" charset="0"/>
+                        </a:rPr>
+                        <m:t> </m:t>
+                      </m:r>
+                      <m:r>
+                        <m:rPr>
+                          <m:sty m:val="p"/>
+                        </m:rPr>
+                        <a:rPr lang="en-US" sz="1400" b="0" i="1" smtClean="0">
+                          <a:latin typeface="Cambria Math" panose="02040503050406030204" pitchFamily="18" charset="0"/>
+                        </a:rPr>
+                        <m:t>V</m:t>
+                      </m:r>
+                      <m:r>
+                        <a:rPr lang="en-US" sz="1400" b="0" i="1" smtClean="0">
+                          <a:latin typeface="Cambria Math" panose="02040503050406030204" pitchFamily="18" charset="0"/>
+                        </a:rPr>
+                        <m:t>/</m:t>
+                      </m:r>
+                      <m:r>
+                        <m:rPr>
+                          <m:sty m:val="p"/>
+                        </m:rPr>
+                        <a:rPr lang="en-US" sz="1400" b="0" i="1" smtClean="0">
+                          <a:latin typeface="Cambria Math" panose="02040503050406030204" pitchFamily="18" charset="0"/>
+                        </a:rPr>
+                        <m:t>m</m:t>
+                      </m:r>
+                      <m:r>
+                        <a:rPr lang="en-US" sz="1400" b="0" i="1" smtClean="0">
+                          <a:latin typeface="Cambria Math" panose="02040503050406030204" pitchFamily="18" charset="0"/>
+                        </a:rPr>
+                        <m:t>, </m:t>
+                      </m:r>
+                      <m:sSub>
+                        <m:sSubPr>
+                          <m:ctrlPr>
+                            <a:rPr lang="en-US" sz="1400" i="1">
+                              <a:latin typeface="Cambria Math" panose="02040503050406030204" pitchFamily="18" charset="0"/>
+                            </a:rPr>
+                          </m:ctrlPr>
+                        </m:sSubPr>
+                        <m:e>
+                          <m:r>
+                            <a:rPr lang="en-US" sz="1400" b="0" i="1" smtClean="0">
+                              <a:latin typeface="Cambria Math" panose="02040503050406030204" pitchFamily="18" charset="0"/>
+                            </a:rPr>
+                            <m:t> </m:t>
+                          </m:r>
+                          <m:r>
+                            <m:rPr>
+                              <m:sty m:val="p"/>
+                            </m:rPr>
+                            <a:rPr lang="en-US" sz="1400" b="0" i="1" smtClean="0">
+                              <a:latin typeface="Cambria Math" panose="02040503050406030204" pitchFamily="18" charset="0"/>
+                            </a:rPr>
+                            <m:t>z</m:t>
+                          </m:r>
+                        </m:e>
+                        <m:sub>
+                          <m:r>
+                            <a:rPr lang="en-US" sz="1400" i="1">
+                              <a:latin typeface="Cambria Math" panose="02040503050406030204" pitchFamily="18" charset="0"/>
+                            </a:rPr>
+                            <m:t>1</m:t>
+                          </m:r>
+                        </m:sub>
+                      </m:sSub>
+                      <m:r>
+                        <a:rPr lang="en-US" sz="1400" b="0" i="1" smtClean="0">
+                          <a:latin typeface="Cambria Math" panose="02040503050406030204" pitchFamily="18" charset="0"/>
+                        </a:rPr>
+                        <m:t>= 1.51</m:t>
+                      </m:r>
+                      <m:r>
+                        <m:rPr>
+                          <m:sty m:val="p"/>
+                        </m:rPr>
+                        <a:rPr lang="en-US" sz="1400" b="0" i="1" smtClean="0">
+                          <a:latin typeface="Cambria Math" panose="02040503050406030204" pitchFamily="18" charset="0"/>
+                        </a:rPr>
+                        <m:t>mm</m:t>
+                      </m:r>
+                      <m:r>
+                        <a:rPr lang="en-US" sz="1400" b="0" i="1" smtClean="0">
+                          <a:latin typeface="Cambria Math" panose="02040503050406030204" pitchFamily="18" charset="0"/>
+                        </a:rPr>
+                        <m:t>, </m:t>
+                      </m:r>
+                      <m:sSub>
+                        <m:sSubPr>
+                          <m:ctrlPr>
+                            <a:rPr lang="en-US" sz="1400" i="1">
+                              <a:latin typeface="Cambria Math" panose="02040503050406030204" pitchFamily="18" charset="0"/>
+                            </a:rPr>
+                          </m:ctrlPr>
+                        </m:sSubPr>
+                        <m:e>
+                          <m:r>
+                            <m:rPr>
+                              <m:sty m:val="p"/>
+                            </m:rPr>
+                            <a:rPr lang="en-US" sz="1400" i="1">
+                              <a:latin typeface="Cambria Math" panose="02040503050406030204" pitchFamily="18" charset="0"/>
+                            </a:rPr>
+                            <m:t>E</m:t>
+                          </m:r>
+                        </m:e>
+                        <m:sub>
+                          <m:r>
+                            <a:rPr lang="en-US" sz="1400" b="0" i="1" smtClean="0">
+                              <a:latin typeface="Cambria Math" panose="02040503050406030204" pitchFamily="18" charset="0"/>
+                            </a:rPr>
+                            <m:t>2</m:t>
+                          </m:r>
+                        </m:sub>
+                      </m:sSub>
+                      <m:r>
+                        <a:rPr lang="en-US" sz="1400" b="0" i="1" smtClean="0">
+                          <a:latin typeface="Cambria Math" panose="02040503050406030204" pitchFamily="18" charset="0"/>
+                        </a:rPr>
+                        <m:t>= 5.07×</m:t>
+                      </m:r>
+                      <m:sSup>
+                        <m:sSupPr>
+                          <m:ctrlPr>
+                            <a:rPr lang="en-US" sz="1400" b="0" i="1" smtClean="0">
+                              <a:latin typeface="Cambria Math" panose="02040503050406030204" pitchFamily="18" charset="0"/>
+                            </a:rPr>
+                          </m:ctrlPr>
+                        </m:sSupPr>
+                        <m:e>
+                          <m:r>
+                            <a:rPr lang="en-US" sz="1400" b="0" i="1" smtClean="0">
+                              <a:latin typeface="Cambria Math" panose="02040503050406030204" pitchFamily="18" charset="0"/>
+                            </a:rPr>
+                            <m:t>10</m:t>
+                          </m:r>
+                        </m:e>
+                        <m:sup>
+                          <m:r>
+                            <a:rPr lang="en-US" sz="1400" b="0" i="1" smtClean="0">
+                              <a:latin typeface="Cambria Math" panose="02040503050406030204" pitchFamily="18" charset="0"/>
+                            </a:rPr>
+                            <m:t>4</m:t>
+                          </m:r>
+                        </m:sup>
+                      </m:sSup>
+                      <m:r>
+                        <a:rPr lang="en-US" sz="1400" b="0" i="1" smtClean="0">
+                          <a:latin typeface="Cambria Math" panose="02040503050406030204" pitchFamily="18" charset="0"/>
+                        </a:rPr>
+                        <m:t> </m:t>
+                      </m:r>
+                      <m:r>
+                        <m:rPr>
+                          <m:sty m:val="p"/>
+                        </m:rPr>
+                        <a:rPr lang="en-US" sz="1400" b="0" i="1" smtClean="0">
+                          <a:latin typeface="Cambria Math" panose="02040503050406030204" pitchFamily="18" charset="0"/>
+                        </a:rPr>
+                        <m:t>V</m:t>
+                      </m:r>
+                      <m:r>
+                        <a:rPr lang="en-US" sz="1400" b="0" i="1" smtClean="0">
+                          <a:latin typeface="Cambria Math" panose="02040503050406030204" pitchFamily="18" charset="0"/>
+                        </a:rPr>
+                        <m:t>/</m:t>
+                      </m:r>
+                      <m:r>
+                        <m:rPr>
+                          <m:sty m:val="p"/>
+                        </m:rPr>
+                        <a:rPr lang="en-US" sz="1400" b="0" i="1" smtClean="0">
+                          <a:latin typeface="Cambria Math" panose="02040503050406030204" pitchFamily="18" charset="0"/>
+                        </a:rPr>
+                        <m:t>m</m:t>
+                      </m:r>
+                      <m:r>
+                        <a:rPr lang="en-US" sz="1400" b="0" i="1" smtClean="0">
+                          <a:latin typeface="Cambria Math" panose="02040503050406030204" pitchFamily="18" charset="0"/>
+                        </a:rPr>
+                        <m:t>,</m:t>
+                      </m:r>
+                      <m:sSub>
+                        <m:sSubPr>
+                          <m:ctrlPr>
+                            <a:rPr lang="en-US" sz="1400" i="1">
+                              <a:latin typeface="Cambria Math" panose="02040503050406030204" pitchFamily="18" charset="0"/>
+                            </a:rPr>
+                          </m:ctrlPr>
+                        </m:sSubPr>
+                        <m:e>
+                          <m:r>
+                            <m:rPr>
+                              <m:sty m:val="p"/>
+                            </m:rPr>
+                            <a:rPr lang="en-US" sz="1400" b="0" i="1" smtClean="0">
+                              <a:latin typeface="Cambria Math" panose="02040503050406030204" pitchFamily="18" charset="0"/>
+                            </a:rPr>
+                            <m:t>z</m:t>
+                          </m:r>
+                        </m:e>
+                        <m:sub>
+                          <m:r>
+                            <a:rPr lang="en-US" sz="1400" b="0" i="1" smtClean="0">
+                              <a:latin typeface="Cambria Math" panose="02040503050406030204" pitchFamily="18" charset="0"/>
+                            </a:rPr>
+                            <m:t>2</m:t>
+                          </m:r>
+                        </m:sub>
+                      </m:sSub>
+                      <m:r>
+                        <a:rPr lang="en-US" sz="1400" b="0" i="1" smtClean="0">
+                          <a:latin typeface="Cambria Math" panose="02040503050406030204" pitchFamily="18" charset="0"/>
+                        </a:rPr>
+                        <m:t>= 7.93 </m:t>
+                      </m:r>
+                      <m:r>
+                        <m:rPr>
+                          <m:sty m:val="p"/>
+                        </m:rPr>
+                        <a:rPr lang="en-US" sz="1400" b="0" i="1" smtClean="0">
+                          <a:latin typeface="Cambria Math" panose="02040503050406030204" pitchFamily="18" charset="0"/>
+                        </a:rPr>
+                        <m:t>mm</m:t>
+                      </m:r>
+                      <m:r>
+                        <a:rPr lang="en-US" sz="1400" b="0" i="1" smtClean="0">
+                          <a:latin typeface="Cambria Math" panose="02040503050406030204" pitchFamily="18" charset="0"/>
+                        </a:rPr>
+                        <m:t>, </m:t>
+                      </m:r>
+                      <m:sSub>
+                        <m:sSubPr>
+                          <m:ctrlPr>
+                            <a:rPr lang="en-US" sz="1400" i="1">
+                              <a:latin typeface="Cambria Math" panose="02040503050406030204" pitchFamily="18" charset="0"/>
+                            </a:rPr>
+                          </m:ctrlPr>
+                        </m:sSubPr>
+                        <m:e>
+                          <m:r>
+                            <m:rPr>
+                              <m:sty m:val="p"/>
+                            </m:rPr>
+                            <a:rPr lang="en-US" sz="1400" i="1">
+                              <a:latin typeface="Cambria Math" panose="02040503050406030204" pitchFamily="18" charset="0"/>
+                            </a:rPr>
+                            <m:t>E</m:t>
+                          </m:r>
+                        </m:e>
+                        <m:sub>
+                          <m:r>
+                            <a:rPr lang="en-US" sz="1400" i="1" smtClean="0">
+                              <a:latin typeface="Cambria Math" panose="02040503050406030204" pitchFamily="18" charset="0"/>
+                              <a:ea typeface="Cambria Math" panose="02040503050406030204" pitchFamily="18" charset="0"/>
+                            </a:rPr>
+                            <m:t>∞</m:t>
+                          </m:r>
+                        </m:sub>
+                      </m:sSub>
+                      <m:r>
+                        <a:rPr lang="en-US" sz="1400" b="0" i="1" smtClean="0">
+                          <a:latin typeface="Cambria Math" panose="02040503050406030204" pitchFamily="18" charset="0"/>
+                        </a:rPr>
+                        <m:t>= 7.41×</m:t>
+                      </m:r>
+                      <m:sSup>
+                        <m:sSupPr>
+                          <m:ctrlPr>
+                            <a:rPr lang="en-US" sz="1400" b="0" i="1" smtClean="0">
+                              <a:latin typeface="Cambria Math" panose="02040503050406030204" pitchFamily="18" charset="0"/>
+                            </a:rPr>
+                          </m:ctrlPr>
+                        </m:sSupPr>
+                        <m:e>
+                          <m:r>
+                            <a:rPr lang="en-US" sz="1400" b="0" i="1" smtClean="0">
+                              <a:latin typeface="Cambria Math" panose="02040503050406030204" pitchFamily="18" charset="0"/>
+                            </a:rPr>
+                            <m:t>10</m:t>
+                          </m:r>
+                        </m:e>
+                        <m:sup>
+                          <m:r>
+                            <a:rPr lang="en-US" sz="1400" b="0" i="1" smtClean="0">
+                              <a:latin typeface="Cambria Math" panose="02040503050406030204" pitchFamily="18" charset="0"/>
+                            </a:rPr>
+                            <m:t>3</m:t>
+                          </m:r>
+                        </m:sup>
+                      </m:sSup>
+                      <m:r>
+                        <a:rPr lang="en-US" sz="1400" b="0" i="1" smtClean="0">
+                          <a:latin typeface="Cambria Math" panose="02040503050406030204" pitchFamily="18" charset="0"/>
+                        </a:rPr>
+                        <m:t> </m:t>
+                      </m:r>
+                      <m:r>
+                        <m:rPr>
+                          <m:sty m:val="p"/>
+                        </m:rPr>
+                        <a:rPr lang="en-US" sz="1400" b="0" i="1" smtClean="0">
+                          <a:latin typeface="Cambria Math" panose="02040503050406030204" pitchFamily="18" charset="0"/>
+                        </a:rPr>
+                        <m:t>V</m:t>
+                      </m:r>
+                      <m:r>
+                        <a:rPr lang="en-US" sz="1400" b="0" i="1" smtClean="0">
+                          <a:latin typeface="Cambria Math" panose="02040503050406030204" pitchFamily="18" charset="0"/>
+                        </a:rPr>
+                        <m:t>/</m:t>
+                      </m:r>
+                      <m:r>
+                        <m:rPr>
+                          <m:sty m:val="p"/>
+                        </m:rPr>
+                        <a:rPr lang="en-US" sz="1400" b="0" i="1" smtClean="0">
+                          <a:latin typeface="Cambria Math" panose="02040503050406030204" pitchFamily="18" charset="0"/>
+                        </a:rPr>
+                        <m:t>m</m:t>
+                      </m:r>
+                    </m:oMath>
+                  </m:oMathPara>
+                </a14:m>
+                <a:endParaRPr lang="en-US" sz="1400" dirty="0"/>
+              </a:p>
+            </p:txBody>
+          </p:sp>
+        </mc:Choice>
+        <mc:Fallback>
+          <p:sp>
+            <p:nvSpPr>
+              <p:cNvPr id="41" name="TextBox 40">
+                <a:extLst>
+                  <a:ext uri="{FF2B5EF4-FFF2-40B4-BE49-F238E27FC236}">
+                    <a16:creationId xmlns:a16="http://schemas.microsoft.com/office/drawing/2014/main" id="{1C9A2AB6-34FF-C04B-3E4A-D6114B70786B}"/>
+                  </a:ext>
+                </a:extLst>
+              </p:cNvPr>
+              <p:cNvSpPr txBox="1">
+                <a:spLocks noRot="1" noChangeAspect="1" noMove="1" noResize="1" noEditPoints="1" noAdjustHandles="1" noChangeArrowheads="1" noChangeShapeType="1" noTextEdit="1"/>
+              </p:cNvSpPr>
+              <p:nvPr/>
+            </p:nvSpPr>
+            <p:spPr>
+              <a:xfrm>
+                <a:off x="844276" y="4260094"/>
+                <a:ext cx="7262757" cy="217817"/>
+              </a:xfrm>
+              <a:prstGeom prst="rect">
+                <a:avLst/>
+              </a:prstGeom>
+              <a:blipFill>
+                <a:blip r:embed="rId7"/>
+                <a:stretch>
+                  <a:fillRect b="-38889"/>
+                </a:stretch>
+              </a:blipFill>
+            </p:spPr>
+            <p:txBody>
+              <a:bodyPr/>
+              <a:lstStyle/>
+              <a:p>
+                <a:r>
+                  <a:rPr lang="en-US">
+                    <a:noFill/>
+                  </a:rPr>
+                  <a:t> </a:t>
+                </a:r>
+              </a:p>
+            </p:txBody>
+          </p:sp>
+        </mc:Fallback>
+      </mc:AlternateContent>
     </p:spTree>
     <p:extLst>
       <p:ext uri="{BB962C8B-B14F-4D97-AF65-F5344CB8AC3E}">
@@ -17773,6 +20762,1283 @@
           <a:xfrm>
             <a:off x="10432471" y="6323329"/>
             <a:ext cx="1492133" cy="496892"/>
+          </a:xfrm>
+          <a:prstGeom prst="rect">
+            <a:avLst/>
+          </a:prstGeom>
+        </p:spPr>
+      </p:pic>
+      <p:sp>
+        <p:nvSpPr>
+          <p:cNvPr id="2" name="TextBox 1">
+            <a:extLst>
+              <a:ext uri="{FF2B5EF4-FFF2-40B4-BE49-F238E27FC236}">
+                <a16:creationId xmlns:a16="http://schemas.microsoft.com/office/drawing/2014/main" id="{63840A7C-B266-394F-8E44-FE49E600FCB9}"/>
+              </a:ext>
+            </a:extLst>
+          </p:cNvPr>
+          <p:cNvSpPr txBox="1"/>
+          <p:nvPr/>
+        </p:nvSpPr>
+        <p:spPr>
+          <a:xfrm>
+            <a:off x="1105786" y="1765005"/>
+            <a:ext cx="2466754" cy="369332"/>
+          </a:xfrm>
+          <a:prstGeom prst="rect">
+            <a:avLst/>
+          </a:prstGeom>
+          <a:noFill/>
+        </p:spPr>
+        <p:txBody>
+          <a:bodyPr wrap="square" rtlCol="0">
+            <a:spAutoFit/>
+          </a:bodyPr>
+          <a:lstStyle/>
+          <a:p>
+            <a:r>
+              <a:rPr lang="en-US" dirty="0"/>
+              <a:t>Tip-charged threads</a:t>
+            </a:r>
+          </a:p>
+        </p:txBody>
+      </p:sp>
+      <p:sp>
+        <p:nvSpPr>
+          <p:cNvPr id="3" name="TextBox 2">
+            <a:extLst>
+              <a:ext uri="{FF2B5EF4-FFF2-40B4-BE49-F238E27FC236}">
+                <a16:creationId xmlns:a16="http://schemas.microsoft.com/office/drawing/2014/main" id="{010A5F86-AA61-3AAB-E90B-C5E53D6771EE}"/>
+              </a:ext>
+            </a:extLst>
+          </p:cNvPr>
+          <p:cNvSpPr txBox="1"/>
+          <p:nvPr/>
+        </p:nvSpPr>
+        <p:spPr>
+          <a:xfrm>
+            <a:off x="7159255" y="1765005"/>
+            <a:ext cx="3273216" cy="369332"/>
+          </a:xfrm>
+          <a:prstGeom prst="rect">
+            <a:avLst/>
+          </a:prstGeom>
+          <a:noFill/>
+        </p:spPr>
+        <p:txBody>
+          <a:bodyPr wrap="square" rtlCol="0">
+            <a:spAutoFit/>
+          </a:bodyPr>
+          <a:lstStyle/>
+          <a:p>
+            <a:r>
+              <a:rPr lang="en-US" dirty="0"/>
+              <a:t>Uniformly distributed charges</a:t>
+            </a:r>
+          </a:p>
+        </p:txBody>
+      </p:sp>
+      <mc:AlternateContent xmlns:mc="http://schemas.openxmlformats.org/markup-compatibility/2006">
+        <mc:Choice xmlns:a14="http://schemas.microsoft.com/office/drawing/2010/main" Requires="a14">
+          <p:sp>
+            <p:nvSpPr>
+              <p:cNvPr id="6" name="TextBox 5">
+                <a:extLst>
+                  <a:ext uri="{FF2B5EF4-FFF2-40B4-BE49-F238E27FC236}">
+                    <a16:creationId xmlns:a16="http://schemas.microsoft.com/office/drawing/2014/main" id="{12BBBF84-F22D-2E38-4D45-4B3908865412}"/>
+                  </a:ext>
+                </a:extLst>
+              </p:cNvPr>
+              <p:cNvSpPr txBox="1"/>
+              <p:nvPr/>
+            </p:nvSpPr>
+            <p:spPr>
+              <a:xfrm>
+                <a:off x="1105786" y="2524516"/>
+                <a:ext cx="3591689" cy="693844"/>
+              </a:xfrm>
+              <a:prstGeom prst="rect">
+                <a:avLst/>
+              </a:prstGeom>
+              <a:noFill/>
+            </p:spPr>
+            <p:txBody>
+              <a:bodyPr wrap="none" lIns="0" tIns="0" rIns="0" bIns="0" rtlCol="0">
+                <a:spAutoFit/>
+              </a:bodyPr>
+              <a:lstStyle/>
+              <a:p>
+                <a14:m>
+                  <m:oMathPara xmlns:m="http://schemas.openxmlformats.org/officeDocument/2006/math">
+                    <m:oMathParaPr>
+                      <m:jc m:val="centerGroup"/>
+                    </m:oMathParaPr>
+                    <m:oMath xmlns:m="http://schemas.openxmlformats.org/officeDocument/2006/math">
+                      <m:acc>
+                        <m:accPr>
+                          <m:chr m:val="⃗"/>
+                          <m:ctrlPr>
+                            <a:rPr lang="en-US" b="0" i="1" smtClean="0">
+                              <a:latin typeface="Cambria Math" panose="02040503050406030204" pitchFamily="18" charset="0"/>
+                            </a:rPr>
+                          </m:ctrlPr>
+                        </m:accPr>
+                        <m:e>
+                          <m:sSub>
+                            <m:sSubPr>
+                              <m:ctrlPr>
+                                <a:rPr lang="en-US" b="0" i="1" smtClean="0">
+                                  <a:latin typeface="Cambria Math" panose="02040503050406030204" pitchFamily="18" charset="0"/>
+                                </a:rPr>
+                              </m:ctrlPr>
+                            </m:sSubPr>
+                            <m:e>
+                              <m:r>
+                                <m:rPr>
+                                  <m:sty m:val="p"/>
+                                </m:rPr>
+                                <a:rPr lang="en-US" b="0" i="1" smtClean="0">
+                                  <a:latin typeface="Cambria Math" panose="02040503050406030204" pitchFamily="18" charset="0"/>
+                                </a:rPr>
+                                <m:t>F</m:t>
+                              </m:r>
+                            </m:e>
+                            <m:sub>
+                              <m:r>
+                                <m:rPr>
+                                  <m:sty m:val="p"/>
+                                </m:rPr>
+                                <a:rPr lang="en-US" b="0" i="1" smtClean="0">
+                                  <a:latin typeface="Cambria Math" panose="02040503050406030204" pitchFamily="18" charset="0"/>
+                                </a:rPr>
+                                <m:t>r</m:t>
+                              </m:r>
+                            </m:sub>
+                          </m:sSub>
+                        </m:e>
+                      </m:acc>
+                      <m:r>
+                        <a:rPr lang="en-US" b="0" i="1" smtClean="0">
+                          <a:latin typeface="Cambria Math" panose="02040503050406030204" pitchFamily="18" charset="0"/>
+                        </a:rPr>
+                        <m:t> </m:t>
+                      </m:r>
+                      <m:r>
+                        <m:rPr>
+                          <m:sty m:val="p"/>
+                        </m:rPr>
+                        <a:rPr lang="en-US" b="0" i="1" baseline="-25000" smtClean="0">
+                          <a:latin typeface="Cambria Math" panose="02040503050406030204" pitchFamily="18" charset="0"/>
+                        </a:rPr>
+                        <m:t>tip</m:t>
+                      </m:r>
+                      <m:r>
+                        <a:rPr lang="en-US" b="0" i="1" baseline="-25000" smtClean="0">
+                          <a:latin typeface="Cambria Math" panose="02040503050406030204" pitchFamily="18" charset="0"/>
+                        </a:rPr>
+                        <m:t>,</m:t>
+                      </m:r>
+                      <m:r>
+                        <m:rPr>
+                          <m:sty m:val="p"/>
+                        </m:rPr>
+                        <a:rPr lang="en-US" b="0" i="1" baseline="-25000" smtClean="0">
+                          <a:latin typeface="Cambria Math" panose="02040503050406030204" pitchFamily="18" charset="0"/>
+                        </a:rPr>
+                        <m:t>k</m:t>
+                      </m:r>
+                      <m:r>
+                        <a:rPr lang="en-US" b="0" i="1" smtClean="0">
+                          <a:latin typeface="Cambria Math" panose="02040503050406030204" pitchFamily="18" charset="0"/>
+                        </a:rPr>
+                        <m:t>=</m:t>
+                      </m:r>
+                      <m:f>
+                        <m:fPr>
+                          <m:ctrlPr>
+                            <a:rPr lang="en-US" i="1" smtClean="0">
+                              <a:latin typeface="Cambria Math" panose="02040503050406030204" pitchFamily="18" charset="0"/>
+                            </a:rPr>
+                          </m:ctrlPr>
+                        </m:fPr>
+                        <m:num>
+                          <m:sSup>
+                            <m:sSupPr>
+                              <m:ctrlPr>
+                                <a:rPr lang="en-US" i="1" smtClean="0">
+                                  <a:latin typeface="Cambria Math" panose="02040503050406030204" pitchFamily="18" charset="0"/>
+                                </a:rPr>
+                              </m:ctrlPr>
+                            </m:sSupPr>
+                            <m:e>
+                              <m:r>
+                                <m:rPr>
+                                  <m:sty m:val="p"/>
+                                </m:rPr>
+                                <a:rPr lang="en-US" b="0" i="1" smtClean="0">
+                                  <a:latin typeface="Cambria Math" panose="02040503050406030204" pitchFamily="18" charset="0"/>
+                                </a:rPr>
+                                <m:t>q</m:t>
+                              </m:r>
+                            </m:e>
+                            <m:sup>
+                              <m:r>
+                                <a:rPr lang="en-US" b="0" i="1" smtClean="0">
+                                  <a:latin typeface="Cambria Math" panose="02040503050406030204" pitchFamily="18" charset="0"/>
+                                </a:rPr>
+                                <m:t>2</m:t>
+                              </m:r>
+                            </m:sup>
+                          </m:sSup>
+                        </m:num>
+                        <m:den>
+                          <m:r>
+                            <a:rPr lang="en-US" b="0" i="1" smtClean="0">
+                              <a:latin typeface="Cambria Math" panose="02040503050406030204" pitchFamily="18" charset="0"/>
+                            </a:rPr>
+                            <m:t>4</m:t>
+                          </m:r>
+                          <m:r>
+                            <m:rPr>
+                              <m:sty m:val="p"/>
+                            </m:rPr>
+                            <a:rPr lang="en-US" b="0" i="1" smtClean="0">
+                              <a:latin typeface="Cambria Math" panose="02040503050406030204" pitchFamily="18" charset="0"/>
+                            </a:rPr>
+                            <m:t>π</m:t>
+                          </m:r>
+                          <m:sSub>
+                            <m:sSubPr>
+                              <m:ctrlPr>
+                                <a:rPr lang="en-US" b="0" i="1" smtClean="0">
+                                  <a:latin typeface="Cambria Math" panose="02040503050406030204" pitchFamily="18" charset="0"/>
+                                </a:rPr>
+                              </m:ctrlPr>
+                            </m:sSubPr>
+                            <m:e>
+                              <m:r>
+                                <m:rPr>
+                                  <m:sty m:val="p"/>
+                                </m:rPr>
+                                <a:rPr lang="en-US" b="0" i="1" smtClean="0">
+                                  <a:latin typeface="Cambria Math" panose="02040503050406030204" pitchFamily="18" charset="0"/>
+                                </a:rPr>
+                                <m:t>ϵ</m:t>
+                              </m:r>
+                            </m:e>
+                            <m:sub>
+                              <m:r>
+                                <a:rPr lang="en-US" b="0" i="1" smtClean="0">
+                                  <a:latin typeface="Cambria Math" panose="02040503050406030204" pitchFamily="18" charset="0"/>
+                                </a:rPr>
+                                <m:t>0</m:t>
+                              </m:r>
+                            </m:sub>
+                          </m:sSub>
+                        </m:den>
+                      </m:f>
+                      <m:nary>
+                        <m:naryPr>
+                          <m:chr m:val="∑"/>
+                          <m:supHide m:val="on"/>
+                          <m:ctrlPr>
+                            <a:rPr lang="en-US" i="1" smtClean="0">
+                              <a:latin typeface="Cambria Math" panose="02040503050406030204" pitchFamily="18" charset="0"/>
+                            </a:rPr>
+                          </m:ctrlPr>
+                        </m:naryPr>
+                        <m:sub>
+                          <m:r>
+                            <m:rPr>
+                              <m:sty m:val="p"/>
+                              <m:brk m:alnAt="7"/>
+                            </m:rPr>
+                            <a:rPr lang="en-US" b="0" i="1" smtClean="0">
+                              <a:latin typeface="Cambria Math" panose="02040503050406030204" pitchFamily="18" charset="0"/>
+                            </a:rPr>
+                            <m:t>i</m:t>
+                          </m:r>
+                          <m:r>
+                            <a:rPr lang="en-US" b="0" i="1" smtClean="0">
+                              <a:latin typeface="Cambria Math" panose="02040503050406030204" pitchFamily="18" charset="0"/>
+                              <a:ea typeface="Cambria Math" panose="02040503050406030204" pitchFamily="18" charset="0"/>
+                            </a:rPr>
+                            <m:t>≠</m:t>
+                          </m:r>
+                          <m:r>
+                            <m:rPr>
+                              <m:sty m:val="p"/>
+                            </m:rPr>
+                            <a:rPr lang="en-US" b="0" i="1" smtClean="0">
+                              <a:latin typeface="Cambria Math" panose="02040503050406030204" pitchFamily="18" charset="0"/>
+                              <a:ea typeface="Cambria Math" panose="02040503050406030204" pitchFamily="18" charset="0"/>
+                            </a:rPr>
+                            <m:t>k</m:t>
+                          </m:r>
+                        </m:sub>
+                        <m:sup/>
+                        <m:e>
+                          <m:f>
+                            <m:fPr>
+                              <m:ctrlPr>
+                                <a:rPr lang="en-US" i="1" smtClean="0">
+                                  <a:latin typeface="Cambria Math" panose="02040503050406030204" pitchFamily="18" charset="0"/>
+                                </a:rPr>
+                              </m:ctrlPr>
+                            </m:fPr>
+                            <m:num>
+                              <m:sSub>
+                                <m:sSubPr>
+                                  <m:ctrlPr>
+                                    <a:rPr lang="en-US" i="1" smtClean="0">
+                                      <a:latin typeface="Cambria Math" panose="02040503050406030204" pitchFamily="18" charset="0"/>
+                                    </a:rPr>
+                                  </m:ctrlPr>
+                                </m:sSubPr>
+                                <m:e>
+                                  <m:r>
+                                    <m:rPr>
+                                      <m:sty m:val="p"/>
+                                    </m:rPr>
+                                    <a:rPr lang="en-US" b="0" i="1" smtClean="0">
+                                      <a:latin typeface="Cambria Math" panose="02040503050406030204" pitchFamily="18" charset="0"/>
+                                    </a:rPr>
+                                    <m:t>x</m:t>
+                                  </m:r>
+                                </m:e>
+                                <m:sub>
+                                  <m:r>
+                                    <m:rPr>
+                                      <m:sty m:val="p"/>
+                                    </m:rPr>
+                                    <a:rPr lang="en-US" b="0" i="1" smtClean="0">
+                                      <a:latin typeface="Cambria Math" panose="02040503050406030204" pitchFamily="18" charset="0"/>
+                                    </a:rPr>
+                                    <m:t>k</m:t>
+                                  </m:r>
+                                </m:sub>
+                              </m:sSub>
+                              <m:r>
+                                <a:rPr lang="en-US" b="0" i="1" smtClean="0">
+                                  <a:latin typeface="Cambria Math" panose="02040503050406030204" pitchFamily="18" charset="0"/>
+                                </a:rPr>
+                                <m:t>(</m:t>
+                              </m:r>
+                              <m:r>
+                                <m:rPr>
+                                  <m:sty m:val="p"/>
+                                </m:rPr>
+                                <a:rPr lang="en-US" b="0" i="1" smtClean="0">
+                                  <a:latin typeface="Cambria Math" panose="02040503050406030204" pitchFamily="18" charset="0"/>
+                                </a:rPr>
+                                <m:t>L</m:t>
+                              </m:r>
+                              <m:r>
+                                <a:rPr lang="en-US" b="0" i="1" smtClean="0">
+                                  <a:latin typeface="Cambria Math" panose="02040503050406030204" pitchFamily="18" charset="0"/>
+                                </a:rPr>
+                                <m:t>) -</m:t>
+                              </m:r>
+                              <m:sSub>
+                                <m:sSubPr>
+                                  <m:ctrlPr>
+                                    <a:rPr lang="en-US" i="1">
+                                      <a:latin typeface="Cambria Math" panose="02040503050406030204" pitchFamily="18" charset="0"/>
+                                    </a:rPr>
+                                  </m:ctrlPr>
+                                </m:sSubPr>
+                                <m:e>
+                                  <m:r>
+                                    <a:rPr lang="en-US" b="0" i="1" smtClean="0">
+                                      <a:latin typeface="Cambria Math" panose="02040503050406030204" pitchFamily="18" charset="0"/>
+                                    </a:rPr>
+                                    <m:t> </m:t>
+                                  </m:r>
+                                  <m:r>
+                                    <m:rPr>
+                                      <m:sty m:val="p"/>
+                                    </m:rPr>
+                                    <a:rPr lang="en-US" i="1">
+                                      <a:latin typeface="Cambria Math" panose="02040503050406030204" pitchFamily="18" charset="0"/>
+                                    </a:rPr>
+                                    <m:t>x</m:t>
+                                  </m:r>
+                                </m:e>
+                                <m:sub>
+                                  <m:r>
+                                    <m:rPr>
+                                      <m:sty m:val="p"/>
+                                    </m:rPr>
+                                    <a:rPr lang="en-US" b="0" i="1" smtClean="0">
+                                      <a:latin typeface="Cambria Math" panose="02040503050406030204" pitchFamily="18" charset="0"/>
+                                    </a:rPr>
+                                    <m:t>i</m:t>
+                                  </m:r>
+                                </m:sub>
+                              </m:sSub>
+                              <m:r>
+                                <a:rPr lang="en-US" i="1">
+                                  <a:latin typeface="Cambria Math" panose="02040503050406030204" pitchFamily="18" charset="0"/>
+                                </a:rPr>
+                                <m:t>(</m:t>
+                              </m:r>
+                              <m:r>
+                                <m:rPr>
+                                  <m:sty m:val="p"/>
+                                </m:rPr>
+                                <a:rPr lang="en-US" i="1">
+                                  <a:latin typeface="Cambria Math" panose="02040503050406030204" pitchFamily="18" charset="0"/>
+                                </a:rPr>
+                                <m:t>L</m:t>
+                              </m:r>
+                              <m:r>
+                                <a:rPr lang="en-US" i="1">
+                                  <a:latin typeface="Cambria Math" panose="02040503050406030204" pitchFamily="18" charset="0"/>
+                                </a:rPr>
+                                <m:t>)</m:t>
+                              </m:r>
+                            </m:num>
+                            <m:den>
+                              <m:sSup>
+                                <m:sSupPr>
+                                  <m:ctrlPr>
+                                    <a:rPr lang="en-US" i="1" smtClean="0">
+                                      <a:latin typeface="Cambria Math" panose="02040503050406030204" pitchFamily="18" charset="0"/>
+                                    </a:rPr>
+                                  </m:ctrlPr>
+                                </m:sSupPr>
+                                <m:e>
+                                  <m:d>
+                                    <m:dPr>
+                                      <m:begChr m:val="‖"/>
+                                      <m:endChr m:val="‖"/>
+                                      <m:ctrlPr>
+                                        <a:rPr lang="en-US" i="1" smtClean="0">
+                                          <a:latin typeface="Cambria Math" panose="02040503050406030204" pitchFamily="18" charset="0"/>
+                                        </a:rPr>
+                                      </m:ctrlPr>
+                                    </m:dPr>
+                                    <m:e>
+                                      <m:sSub>
+                                        <m:sSubPr>
+                                          <m:ctrlPr>
+                                            <a:rPr lang="en-US" i="1">
+                                              <a:latin typeface="Cambria Math" panose="02040503050406030204" pitchFamily="18" charset="0"/>
+                                            </a:rPr>
+                                          </m:ctrlPr>
+                                        </m:sSubPr>
+                                        <m:e>
+                                          <m:r>
+                                            <m:rPr>
+                                              <m:sty m:val="p"/>
+                                            </m:rPr>
+                                            <a:rPr lang="en-US" i="1">
+                                              <a:latin typeface="Cambria Math" panose="02040503050406030204" pitchFamily="18" charset="0"/>
+                                            </a:rPr>
+                                            <m:t>x</m:t>
+                                          </m:r>
+                                        </m:e>
+                                        <m:sub>
+                                          <m:r>
+                                            <m:rPr>
+                                              <m:sty m:val="p"/>
+                                            </m:rPr>
+                                            <a:rPr lang="en-US" i="1">
+                                              <a:latin typeface="Cambria Math" panose="02040503050406030204" pitchFamily="18" charset="0"/>
+                                            </a:rPr>
+                                            <m:t>k</m:t>
+                                          </m:r>
+                                        </m:sub>
+                                      </m:sSub>
+                                      <m:r>
+                                        <a:rPr lang="en-US" i="1">
+                                          <a:latin typeface="Cambria Math" panose="02040503050406030204" pitchFamily="18" charset="0"/>
+                                        </a:rPr>
+                                        <m:t>(</m:t>
+                                      </m:r>
+                                      <m:r>
+                                        <m:rPr>
+                                          <m:sty m:val="p"/>
+                                        </m:rPr>
+                                        <a:rPr lang="en-US" i="1">
+                                          <a:latin typeface="Cambria Math" panose="02040503050406030204" pitchFamily="18" charset="0"/>
+                                        </a:rPr>
+                                        <m:t>L</m:t>
+                                      </m:r>
+                                      <m:r>
+                                        <a:rPr lang="en-US" i="1">
+                                          <a:latin typeface="Cambria Math" panose="02040503050406030204" pitchFamily="18" charset="0"/>
+                                        </a:rPr>
+                                        <m:t>) −</m:t>
+                                      </m:r>
+                                      <m:sSub>
+                                        <m:sSubPr>
+                                          <m:ctrlPr>
+                                            <a:rPr lang="en-US" i="1">
+                                              <a:latin typeface="Cambria Math" panose="02040503050406030204" pitchFamily="18" charset="0"/>
+                                            </a:rPr>
+                                          </m:ctrlPr>
+                                        </m:sSubPr>
+                                        <m:e>
+                                          <m:r>
+                                            <a:rPr lang="en-US" i="1">
+                                              <a:latin typeface="Cambria Math" panose="02040503050406030204" pitchFamily="18" charset="0"/>
+                                            </a:rPr>
+                                            <m:t> </m:t>
+                                          </m:r>
+                                          <m:r>
+                                            <m:rPr>
+                                              <m:sty m:val="p"/>
+                                            </m:rPr>
+                                            <a:rPr lang="en-US" i="1">
+                                              <a:latin typeface="Cambria Math" panose="02040503050406030204" pitchFamily="18" charset="0"/>
+                                            </a:rPr>
+                                            <m:t>x</m:t>
+                                          </m:r>
+                                        </m:e>
+                                        <m:sub>
+                                          <m:r>
+                                            <m:rPr>
+                                              <m:sty m:val="p"/>
+                                            </m:rPr>
+                                            <a:rPr lang="en-US" i="1">
+                                              <a:latin typeface="Cambria Math" panose="02040503050406030204" pitchFamily="18" charset="0"/>
+                                            </a:rPr>
+                                            <m:t>i</m:t>
+                                          </m:r>
+                                        </m:sub>
+                                      </m:sSub>
+                                      <m:r>
+                                        <a:rPr lang="en-US" i="1">
+                                          <a:latin typeface="Cambria Math" panose="02040503050406030204" pitchFamily="18" charset="0"/>
+                                        </a:rPr>
+                                        <m:t>(</m:t>
+                                      </m:r>
+                                      <m:r>
+                                        <m:rPr>
+                                          <m:sty m:val="p"/>
+                                        </m:rPr>
+                                        <a:rPr lang="en-US" i="1">
+                                          <a:latin typeface="Cambria Math" panose="02040503050406030204" pitchFamily="18" charset="0"/>
+                                        </a:rPr>
+                                        <m:t>L</m:t>
+                                      </m:r>
+                                      <m:r>
+                                        <a:rPr lang="en-US" i="1">
+                                          <a:latin typeface="Cambria Math" panose="02040503050406030204" pitchFamily="18" charset="0"/>
+                                        </a:rPr>
+                                        <m:t>)</m:t>
+                                      </m:r>
+                                    </m:e>
+                                  </m:d>
+                                </m:e>
+                                <m:sup>
+                                  <m:r>
+                                    <a:rPr lang="en-US" b="0" i="1" smtClean="0">
+                                      <a:latin typeface="Cambria Math" panose="02040503050406030204" pitchFamily="18" charset="0"/>
+                                    </a:rPr>
+                                    <m:t>3</m:t>
+                                  </m:r>
+                                </m:sup>
+                              </m:sSup>
+                            </m:den>
+                          </m:f>
+                        </m:e>
+                      </m:nary>
+                    </m:oMath>
+                  </m:oMathPara>
+                </a14:m>
+                <a:endParaRPr lang="en-US" dirty="0"/>
+              </a:p>
+            </p:txBody>
+          </p:sp>
+        </mc:Choice>
+        <mc:Fallback>
+          <p:sp>
+            <p:nvSpPr>
+              <p:cNvPr id="6" name="TextBox 5">
+                <a:extLst>
+                  <a:ext uri="{FF2B5EF4-FFF2-40B4-BE49-F238E27FC236}">
+                    <a16:creationId xmlns:a16="http://schemas.microsoft.com/office/drawing/2014/main" id="{12BBBF84-F22D-2E38-4D45-4B3908865412}"/>
+                  </a:ext>
+                </a:extLst>
+              </p:cNvPr>
+              <p:cNvSpPr txBox="1">
+                <a:spLocks noRot="1" noChangeAspect="1" noMove="1" noResize="1" noEditPoints="1" noAdjustHandles="1" noChangeArrowheads="1" noChangeShapeType="1" noTextEdit="1"/>
+              </p:cNvSpPr>
+              <p:nvPr/>
+            </p:nvSpPr>
+            <p:spPr>
+              <a:xfrm>
+                <a:off x="1105786" y="2524516"/>
+                <a:ext cx="3591689" cy="693844"/>
+              </a:xfrm>
+              <a:prstGeom prst="rect">
+                <a:avLst/>
+              </a:prstGeom>
+              <a:blipFill>
+                <a:blip r:embed="rId3"/>
+                <a:stretch>
+                  <a:fillRect l="-702" t="-135714" b="-191071"/>
+                </a:stretch>
+              </a:blipFill>
+            </p:spPr>
+            <p:txBody>
+              <a:bodyPr/>
+              <a:lstStyle/>
+              <a:p>
+                <a:r>
+                  <a:rPr lang="en-US">
+                    <a:noFill/>
+                  </a:rPr>
+                  <a:t> </a:t>
+                </a:r>
+              </a:p>
+            </p:txBody>
+          </p:sp>
+        </mc:Fallback>
+      </mc:AlternateContent>
+      <mc:AlternateContent xmlns:mc="http://schemas.openxmlformats.org/markup-compatibility/2006">
+        <mc:Choice xmlns:a14="http://schemas.microsoft.com/office/drawing/2010/main" Requires="a14">
+          <p:sp>
+            <p:nvSpPr>
+              <p:cNvPr id="7" name="TextBox 6">
+                <a:extLst>
+                  <a:ext uri="{FF2B5EF4-FFF2-40B4-BE49-F238E27FC236}">
+                    <a16:creationId xmlns:a16="http://schemas.microsoft.com/office/drawing/2014/main" id="{91C1BE7D-379A-B7BC-4B78-511D9CD231C8}"/>
+                  </a:ext>
+                </a:extLst>
+              </p:cNvPr>
+              <p:cNvSpPr txBox="1"/>
+              <p:nvPr/>
+            </p:nvSpPr>
+            <p:spPr>
+              <a:xfrm>
+                <a:off x="7159255" y="2524516"/>
+                <a:ext cx="4005519" cy="721351"/>
+              </a:xfrm>
+              <a:prstGeom prst="rect">
+                <a:avLst/>
+              </a:prstGeom>
+              <a:noFill/>
+            </p:spPr>
+            <p:txBody>
+              <a:bodyPr wrap="none" lIns="0" tIns="0" rIns="0" bIns="0" rtlCol="0">
+                <a:spAutoFit/>
+              </a:bodyPr>
+              <a:lstStyle/>
+              <a:p>
+                <a14:m>
+                  <m:oMathPara xmlns:m="http://schemas.openxmlformats.org/officeDocument/2006/math">
+                    <m:oMathParaPr>
+                      <m:jc m:val="centerGroup"/>
+                    </m:oMathParaPr>
+                    <m:oMath xmlns:m="http://schemas.openxmlformats.org/officeDocument/2006/math">
+                      <m:acc>
+                        <m:accPr>
+                          <m:chr m:val="⃗"/>
+                          <m:ctrlPr>
+                            <a:rPr lang="en-US" b="0" i="1" smtClean="0">
+                              <a:latin typeface="Cambria Math" panose="02040503050406030204" pitchFamily="18" charset="0"/>
+                            </a:rPr>
+                          </m:ctrlPr>
+                        </m:accPr>
+                        <m:e>
+                          <m:sSub>
+                            <m:sSubPr>
+                              <m:ctrlPr>
+                                <a:rPr lang="en-US" b="0" i="1" smtClean="0">
+                                  <a:latin typeface="Cambria Math" panose="02040503050406030204" pitchFamily="18" charset="0"/>
+                                </a:rPr>
+                              </m:ctrlPr>
+                            </m:sSubPr>
+                            <m:e>
+                              <m:r>
+                                <m:rPr>
+                                  <m:sty m:val="p"/>
+                                </m:rPr>
+                                <a:rPr lang="en-US" b="0" i="1" smtClean="0">
+                                  <a:latin typeface="Cambria Math" panose="02040503050406030204" pitchFamily="18" charset="0"/>
+                                </a:rPr>
+                                <m:t>f</m:t>
+                              </m:r>
+                            </m:e>
+                            <m:sub>
+                              <m:r>
+                                <m:rPr>
+                                  <m:sty m:val="p"/>
+                                </m:rPr>
+                                <a:rPr lang="en-US" b="0" i="1" smtClean="0">
+                                  <a:latin typeface="Cambria Math" panose="02040503050406030204" pitchFamily="18" charset="0"/>
+                                </a:rPr>
+                                <m:t>r</m:t>
+                              </m:r>
+                            </m:sub>
+                          </m:sSub>
+                        </m:e>
+                      </m:acc>
+                      <m:r>
+                        <a:rPr lang="en-US" b="0" i="1" smtClean="0">
+                          <a:latin typeface="Cambria Math" panose="02040503050406030204" pitchFamily="18" charset="0"/>
+                        </a:rPr>
+                        <m:t> </m:t>
+                      </m:r>
+                      <m:r>
+                        <a:rPr lang="en-US" b="0" i="1" baseline="-25000" smtClean="0">
+                          <a:latin typeface="Cambria Math" panose="02040503050406030204" pitchFamily="18" charset="0"/>
+                        </a:rPr>
+                        <m:t>,</m:t>
+                      </m:r>
+                      <m:r>
+                        <m:rPr>
+                          <m:sty m:val="p"/>
+                        </m:rPr>
+                        <a:rPr lang="en-US" b="0" i="1" baseline="-25000" smtClean="0">
+                          <a:latin typeface="Cambria Math" panose="02040503050406030204" pitchFamily="18" charset="0"/>
+                        </a:rPr>
+                        <m:t>k</m:t>
+                      </m:r>
+                      <m:r>
+                        <a:rPr lang="en-US" b="0" i="1" smtClean="0">
+                          <a:latin typeface="Cambria Math" panose="02040503050406030204" pitchFamily="18" charset="0"/>
+                        </a:rPr>
+                        <m:t>=</m:t>
+                      </m:r>
+                      <m:f>
+                        <m:fPr>
+                          <m:ctrlPr>
+                            <a:rPr lang="en-US" i="1" smtClean="0">
+                              <a:latin typeface="Cambria Math" panose="02040503050406030204" pitchFamily="18" charset="0"/>
+                            </a:rPr>
+                          </m:ctrlPr>
+                        </m:fPr>
+                        <m:num>
+                          <m:sSup>
+                            <m:sSupPr>
+                              <m:ctrlPr>
+                                <a:rPr lang="en-US" i="1" smtClean="0">
+                                  <a:latin typeface="Cambria Math" panose="02040503050406030204" pitchFamily="18" charset="0"/>
+                                </a:rPr>
+                              </m:ctrlPr>
+                            </m:sSupPr>
+                            <m:e>
+                              <m:r>
+                                <m:rPr>
+                                  <m:sty m:val="p"/>
+                                </m:rPr>
+                                <a:rPr lang="en-US" b="0" i="1" smtClean="0">
+                                  <a:latin typeface="Cambria Math" panose="02040503050406030204" pitchFamily="18" charset="0"/>
+                                </a:rPr>
+                                <m:t>λ</m:t>
+                              </m:r>
+                            </m:e>
+                            <m:sup>
+                              <m:r>
+                                <a:rPr lang="en-US" b="0" i="1" smtClean="0">
+                                  <a:latin typeface="Cambria Math" panose="02040503050406030204" pitchFamily="18" charset="0"/>
+                                </a:rPr>
+                                <m:t>2</m:t>
+                              </m:r>
+                            </m:sup>
+                          </m:sSup>
+                        </m:num>
+                        <m:den>
+                          <m:r>
+                            <a:rPr lang="en-US" b="0" i="1" smtClean="0">
+                              <a:latin typeface="Cambria Math" panose="02040503050406030204" pitchFamily="18" charset="0"/>
+                            </a:rPr>
+                            <m:t>4</m:t>
+                          </m:r>
+                          <m:r>
+                            <m:rPr>
+                              <m:sty m:val="p"/>
+                            </m:rPr>
+                            <a:rPr lang="en-US" b="0" i="1" smtClean="0">
+                              <a:latin typeface="Cambria Math" panose="02040503050406030204" pitchFamily="18" charset="0"/>
+                            </a:rPr>
+                            <m:t>π</m:t>
+                          </m:r>
+                          <m:sSub>
+                            <m:sSubPr>
+                              <m:ctrlPr>
+                                <a:rPr lang="en-US" b="0" i="1" smtClean="0">
+                                  <a:latin typeface="Cambria Math" panose="02040503050406030204" pitchFamily="18" charset="0"/>
+                                </a:rPr>
+                              </m:ctrlPr>
+                            </m:sSubPr>
+                            <m:e>
+                              <m:r>
+                                <m:rPr>
+                                  <m:sty m:val="p"/>
+                                </m:rPr>
+                                <a:rPr lang="en-US" b="0" i="1" smtClean="0">
+                                  <a:latin typeface="Cambria Math" panose="02040503050406030204" pitchFamily="18" charset="0"/>
+                                </a:rPr>
+                                <m:t>ϵ</m:t>
+                              </m:r>
+                            </m:e>
+                            <m:sub>
+                              <m:r>
+                                <a:rPr lang="en-US" b="0" i="1" smtClean="0">
+                                  <a:latin typeface="Cambria Math" panose="02040503050406030204" pitchFamily="18" charset="0"/>
+                                </a:rPr>
+                                <m:t>0</m:t>
+                              </m:r>
+                            </m:sub>
+                          </m:sSub>
+                        </m:den>
+                      </m:f>
+                      <m:nary>
+                        <m:naryPr>
+                          <m:chr m:val="∑"/>
+                          <m:supHide m:val="on"/>
+                          <m:ctrlPr>
+                            <a:rPr lang="en-US" i="1" smtClean="0">
+                              <a:latin typeface="Cambria Math" panose="02040503050406030204" pitchFamily="18" charset="0"/>
+                            </a:rPr>
+                          </m:ctrlPr>
+                        </m:naryPr>
+                        <m:sub>
+                          <m:r>
+                            <m:rPr>
+                              <m:sty m:val="p"/>
+                              <m:brk m:alnAt="7"/>
+                            </m:rPr>
+                            <a:rPr lang="en-US" b="0" i="1" smtClean="0">
+                              <a:latin typeface="Cambria Math" panose="02040503050406030204" pitchFamily="18" charset="0"/>
+                            </a:rPr>
+                            <m:t>i</m:t>
+                          </m:r>
+                          <m:r>
+                            <a:rPr lang="en-US" b="0" i="1" smtClean="0">
+                              <a:latin typeface="Cambria Math" panose="02040503050406030204" pitchFamily="18" charset="0"/>
+                              <a:ea typeface="Cambria Math" panose="02040503050406030204" pitchFamily="18" charset="0"/>
+                            </a:rPr>
+                            <m:t>≠</m:t>
+                          </m:r>
+                          <m:r>
+                            <m:rPr>
+                              <m:sty m:val="p"/>
+                            </m:rPr>
+                            <a:rPr lang="en-US" b="0" i="1" smtClean="0">
+                              <a:latin typeface="Cambria Math" panose="02040503050406030204" pitchFamily="18" charset="0"/>
+                              <a:ea typeface="Cambria Math" panose="02040503050406030204" pitchFamily="18" charset="0"/>
+                            </a:rPr>
+                            <m:t>k</m:t>
+                          </m:r>
+                        </m:sub>
+                        <m:sup/>
+                        <m:e>
+                          <m:nary>
+                            <m:naryPr>
+                              <m:ctrlPr>
+                                <a:rPr lang="en-US" i="1" smtClean="0">
+                                  <a:latin typeface="Cambria Math" panose="02040503050406030204" pitchFamily="18" charset="0"/>
+                                </a:rPr>
+                              </m:ctrlPr>
+                            </m:naryPr>
+                            <m:sub>
+                              <m:r>
+                                <m:rPr>
+                                  <m:brk m:alnAt="23"/>
+                                </m:rPr>
+                                <a:rPr lang="en-US" b="0" i="1" smtClean="0">
+                                  <a:latin typeface="Cambria Math" panose="02040503050406030204" pitchFamily="18" charset="0"/>
+                                </a:rPr>
+                                <m:t>0</m:t>
+                              </m:r>
+                            </m:sub>
+                            <m:sup>
+                              <m:r>
+                                <m:rPr>
+                                  <m:sty m:val="p"/>
+                                </m:rPr>
+                                <a:rPr lang="en-US" b="0" i="1" smtClean="0">
+                                  <a:latin typeface="Cambria Math" panose="02040503050406030204" pitchFamily="18" charset="0"/>
+                                </a:rPr>
+                                <m:t>L</m:t>
+                              </m:r>
+                            </m:sup>
+                            <m:e>
+                              <m:f>
+                                <m:fPr>
+                                  <m:ctrlPr>
+                                    <a:rPr lang="en-US" i="1">
+                                      <a:latin typeface="Cambria Math" panose="02040503050406030204" pitchFamily="18" charset="0"/>
+                                    </a:rPr>
+                                  </m:ctrlPr>
+                                </m:fPr>
+                                <m:num>
+                                  <m:sSub>
+                                    <m:sSubPr>
+                                      <m:ctrlPr>
+                                        <a:rPr lang="en-US" i="1">
+                                          <a:latin typeface="Cambria Math" panose="02040503050406030204" pitchFamily="18" charset="0"/>
+                                        </a:rPr>
+                                      </m:ctrlPr>
+                                    </m:sSubPr>
+                                    <m:e>
+                                      <m:r>
+                                        <m:rPr>
+                                          <m:sty m:val="p"/>
+                                        </m:rPr>
+                                        <a:rPr lang="en-US" i="1">
+                                          <a:latin typeface="Cambria Math" panose="02040503050406030204" pitchFamily="18" charset="0"/>
+                                        </a:rPr>
+                                        <m:t>x</m:t>
+                                      </m:r>
+                                    </m:e>
+                                    <m:sub>
+                                      <m:r>
+                                        <m:rPr>
+                                          <m:sty m:val="p"/>
+                                        </m:rPr>
+                                        <a:rPr lang="en-US" i="1">
+                                          <a:latin typeface="Cambria Math" panose="02040503050406030204" pitchFamily="18" charset="0"/>
+                                        </a:rPr>
+                                        <m:t>k</m:t>
+                                      </m:r>
+                                    </m:sub>
+                                  </m:sSub>
+                                  <m:r>
+                                    <a:rPr lang="en-US" i="1">
+                                      <a:latin typeface="Cambria Math" panose="02040503050406030204" pitchFamily="18" charset="0"/>
+                                    </a:rPr>
+                                    <m:t>(</m:t>
+                                  </m:r>
+                                  <m:r>
+                                    <m:rPr>
+                                      <m:sty m:val="p"/>
+                                    </m:rPr>
+                                    <a:rPr lang="en-US" b="0" i="1" smtClean="0">
+                                      <a:latin typeface="Cambria Math" panose="02040503050406030204" pitchFamily="18" charset="0"/>
+                                    </a:rPr>
+                                    <m:t>s</m:t>
+                                  </m:r>
+                                  <m:r>
+                                    <a:rPr lang="en-US" i="1">
+                                      <a:latin typeface="Cambria Math" panose="02040503050406030204" pitchFamily="18" charset="0"/>
+                                    </a:rPr>
+                                    <m:t>) −</m:t>
+                                  </m:r>
+                                  <m:sSub>
+                                    <m:sSubPr>
+                                      <m:ctrlPr>
+                                        <a:rPr lang="en-US" i="1">
+                                          <a:latin typeface="Cambria Math" panose="02040503050406030204" pitchFamily="18" charset="0"/>
+                                        </a:rPr>
+                                      </m:ctrlPr>
+                                    </m:sSubPr>
+                                    <m:e>
+                                      <m:r>
+                                        <a:rPr lang="en-US" i="1">
+                                          <a:latin typeface="Cambria Math" panose="02040503050406030204" pitchFamily="18" charset="0"/>
+                                        </a:rPr>
+                                        <m:t> </m:t>
+                                      </m:r>
+                                      <m:r>
+                                        <m:rPr>
+                                          <m:sty m:val="p"/>
+                                        </m:rPr>
+                                        <a:rPr lang="en-US" i="1">
+                                          <a:latin typeface="Cambria Math" panose="02040503050406030204" pitchFamily="18" charset="0"/>
+                                        </a:rPr>
+                                        <m:t>x</m:t>
+                                      </m:r>
+                                    </m:e>
+                                    <m:sub>
+                                      <m:r>
+                                        <m:rPr>
+                                          <m:sty m:val="p"/>
+                                        </m:rPr>
+                                        <a:rPr lang="en-US" i="1">
+                                          <a:latin typeface="Cambria Math" panose="02040503050406030204" pitchFamily="18" charset="0"/>
+                                        </a:rPr>
+                                        <m:t>i</m:t>
+                                      </m:r>
+                                    </m:sub>
+                                  </m:sSub>
+                                  <m:r>
+                                    <a:rPr lang="en-US" i="1">
+                                      <a:latin typeface="Cambria Math" panose="02040503050406030204" pitchFamily="18" charset="0"/>
+                                    </a:rPr>
+                                    <m:t>(</m:t>
+                                  </m:r>
+                                  <m:r>
+                                    <m:rPr>
+                                      <m:sty m:val="p"/>
+                                    </m:rPr>
+                                    <a:rPr lang="en-US" b="0" i="1" smtClean="0">
+                                      <a:latin typeface="Cambria Math" panose="02040503050406030204" pitchFamily="18" charset="0"/>
+                                    </a:rPr>
+                                    <m:t>s</m:t>
+                                  </m:r>
+                                  <m:r>
+                                    <a:rPr lang="en-US" b="0" i="1" smtClean="0">
+                                      <a:latin typeface="Cambria Math" panose="02040503050406030204" pitchFamily="18" charset="0"/>
+                                    </a:rPr>
+                                    <m:t>’)</m:t>
+                                  </m:r>
+                                </m:num>
+                                <m:den>
+                                  <m:sSup>
+                                    <m:sSupPr>
+                                      <m:ctrlPr>
+                                        <a:rPr lang="en-US" i="1">
+                                          <a:latin typeface="Cambria Math" panose="02040503050406030204" pitchFamily="18" charset="0"/>
+                                        </a:rPr>
+                                      </m:ctrlPr>
+                                    </m:sSupPr>
+                                    <m:e>
+                                      <m:d>
+                                        <m:dPr>
+                                          <m:begChr m:val="‖"/>
+                                          <m:endChr m:val="‖"/>
+                                          <m:ctrlPr>
+                                            <a:rPr lang="en-US" i="1">
+                                              <a:latin typeface="Cambria Math" panose="02040503050406030204" pitchFamily="18" charset="0"/>
+                                            </a:rPr>
+                                          </m:ctrlPr>
+                                        </m:dPr>
+                                        <m:e>
+                                          <m:sSub>
+                                            <m:sSubPr>
+                                              <m:ctrlPr>
+                                                <a:rPr lang="en-US" i="1">
+                                                  <a:latin typeface="Cambria Math" panose="02040503050406030204" pitchFamily="18" charset="0"/>
+                                                </a:rPr>
+                                              </m:ctrlPr>
+                                            </m:sSubPr>
+                                            <m:e>
+                                              <m:r>
+                                                <m:rPr>
+                                                  <m:sty m:val="p"/>
+                                                </m:rPr>
+                                                <a:rPr lang="en-US" i="1">
+                                                  <a:latin typeface="Cambria Math" panose="02040503050406030204" pitchFamily="18" charset="0"/>
+                                                </a:rPr>
+                                                <m:t>x</m:t>
+                                              </m:r>
+                                            </m:e>
+                                            <m:sub>
+                                              <m:r>
+                                                <m:rPr>
+                                                  <m:sty m:val="p"/>
+                                                </m:rPr>
+                                                <a:rPr lang="en-US" i="1">
+                                                  <a:latin typeface="Cambria Math" panose="02040503050406030204" pitchFamily="18" charset="0"/>
+                                                </a:rPr>
+                                                <m:t>k</m:t>
+                                              </m:r>
+                                            </m:sub>
+                                          </m:sSub>
+                                          <m:r>
+                                            <a:rPr lang="en-US" i="1">
+                                              <a:latin typeface="Cambria Math" panose="02040503050406030204" pitchFamily="18" charset="0"/>
+                                            </a:rPr>
+                                            <m:t>(</m:t>
+                                          </m:r>
+                                          <m:r>
+                                            <m:rPr>
+                                              <m:sty m:val="p"/>
+                                            </m:rPr>
+                                            <a:rPr lang="en-US" b="0" i="1" smtClean="0">
+                                              <a:latin typeface="Cambria Math" panose="02040503050406030204" pitchFamily="18" charset="0"/>
+                                            </a:rPr>
+                                            <m:t>s</m:t>
+                                          </m:r>
+                                          <m:r>
+                                            <a:rPr lang="en-US" i="1">
+                                              <a:latin typeface="Cambria Math" panose="02040503050406030204" pitchFamily="18" charset="0"/>
+                                            </a:rPr>
+                                            <m:t>) −</m:t>
+                                          </m:r>
+                                          <m:sSub>
+                                            <m:sSubPr>
+                                              <m:ctrlPr>
+                                                <a:rPr lang="en-US" i="1">
+                                                  <a:latin typeface="Cambria Math" panose="02040503050406030204" pitchFamily="18" charset="0"/>
+                                                </a:rPr>
+                                              </m:ctrlPr>
+                                            </m:sSubPr>
+                                            <m:e>
+                                              <m:r>
+                                                <a:rPr lang="en-US" i="1">
+                                                  <a:latin typeface="Cambria Math" panose="02040503050406030204" pitchFamily="18" charset="0"/>
+                                                </a:rPr>
+                                                <m:t> </m:t>
+                                              </m:r>
+                                              <m:r>
+                                                <m:rPr>
+                                                  <m:sty m:val="p"/>
+                                                </m:rPr>
+                                                <a:rPr lang="en-US" i="1">
+                                                  <a:latin typeface="Cambria Math" panose="02040503050406030204" pitchFamily="18" charset="0"/>
+                                                </a:rPr>
+                                                <m:t>x</m:t>
+                                              </m:r>
+                                            </m:e>
+                                            <m:sub>
+                                              <m:r>
+                                                <m:rPr>
+                                                  <m:sty m:val="p"/>
+                                                </m:rPr>
+                                                <a:rPr lang="en-US" i="1">
+                                                  <a:latin typeface="Cambria Math" panose="02040503050406030204" pitchFamily="18" charset="0"/>
+                                                </a:rPr>
+                                                <m:t>i</m:t>
+                                              </m:r>
+                                            </m:sub>
+                                          </m:sSub>
+                                          <m:r>
+                                            <a:rPr lang="en-US" i="1">
+                                              <a:latin typeface="Cambria Math" panose="02040503050406030204" pitchFamily="18" charset="0"/>
+                                            </a:rPr>
+                                            <m:t>(</m:t>
+                                          </m:r>
+                                          <m:r>
+                                            <m:rPr>
+                                              <m:sty m:val="p"/>
+                                            </m:rPr>
+                                            <a:rPr lang="en-US" b="0" i="1" smtClean="0">
+                                              <a:latin typeface="Cambria Math" panose="02040503050406030204" pitchFamily="18" charset="0"/>
+                                            </a:rPr>
+                                            <m:t>s</m:t>
+                                          </m:r>
+                                          <m:r>
+                                            <a:rPr lang="en-US" b="0" i="1" smtClean="0">
+                                              <a:latin typeface="Cambria Math" panose="02040503050406030204" pitchFamily="18" charset="0"/>
+                                            </a:rPr>
+                                            <m:t>’)</m:t>
+                                          </m:r>
+                                        </m:e>
+                                      </m:d>
+                                    </m:e>
+                                    <m:sup>
+                                      <m:r>
+                                        <a:rPr lang="en-US" i="1">
+                                          <a:latin typeface="Cambria Math" panose="02040503050406030204" pitchFamily="18" charset="0"/>
+                                        </a:rPr>
+                                        <m:t>3</m:t>
+                                      </m:r>
+                                    </m:sup>
+                                  </m:sSup>
+                                </m:den>
+                              </m:f>
+                              <m:r>
+                                <m:rPr>
+                                  <m:sty m:val="p"/>
+                                </m:rPr>
+                                <a:rPr lang="en-US" b="0" i="1" smtClean="0">
+                                  <a:latin typeface="Cambria Math" panose="02040503050406030204" pitchFamily="18" charset="0"/>
+                                </a:rPr>
+                                <m:t>ds</m:t>
+                              </m:r>
+                              <m:r>
+                                <a:rPr lang="en-US" b="0" i="1" smtClean="0">
+                                  <a:latin typeface="Cambria Math" panose="02040503050406030204" pitchFamily="18" charset="0"/>
+                                </a:rPr>
+                                <m:t>’</m:t>
+                              </m:r>
+                            </m:e>
+                          </m:nary>
+                        </m:e>
+                      </m:nary>
+                    </m:oMath>
+                  </m:oMathPara>
+                </a14:m>
+                <a:endParaRPr lang="en-US" dirty="0"/>
+              </a:p>
+            </p:txBody>
+          </p:sp>
+        </mc:Choice>
+        <mc:Fallback>
+          <p:sp>
+            <p:nvSpPr>
+              <p:cNvPr id="7" name="TextBox 6">
+                <a:extLst>
+                  <a:ext uri="{FF2B5EF4-FFF2-40B4-BE49-F238E27FC236}">
+                    <a16:creationId xmlns:a16="http://schemas.microsoft.com/office/drawing/2014/main" id="{91C1BE7D-379A-B7BC-4B78-511D9CD231C8}"/>
+                  </a:ext>
+                </a:extLst>
+              </p:cNvPr>
+              <p:cNvSpPr txBox="1">
+                <a:spLocks noRot="1" noChangeAspect="1" noMove="1" noResize="1" noEditPoints="1" noAdjustHandles="1" noChangeArrowheads="1" noChangeShapeType="1" noTextEdit="1"/>
+              </p:cNvSpPr>
+              <p:nvPr/>
+            </p:nvSpPr>
+            <p:spPr>
+              <a:xfrm>
+                <a:off x="7159255" y="2524516"/>
+                <a:ext cx="4005519" cy="721351"/>
+              </a:xfrm>
+              <a:prstGeom prst="rect">
+                <a:avLst/>
+              </a:prstGeom>
+              <a:blipFill>
+                <a:blip r:embed="rId4"/>
+                <a:stretch>
+                  <a:fillRect l="-633" t="-153448" r="-949" b="-220690"/>
+                </a:stretch>
+              </a:blipFill>
+            </p:spPr>
+            <p:txBody>
+              <a:bodyPr/>
+              <a:lstStyle/>
+              <a:p>
+                <a:r>
+                  <a:rPr lang="en-US">
+                    <a:noFill/>
+                  </a:rPr>
+                  <a:t> </a:t>
+                </a:r>
+              </a:p>
+            </p:txBody>
+          </p:sp>
+        </mc:Fallback>
+      </mc:AlternateContent>
+      <p:pic>
+        <p:nvPicPr>
+          <p:cNvPr id="8" name="Picture 7" descr="Coulomb repulsion between equal charges concentrated at two filament tips."/>
+          <p:cNvPicPr>
+            <a:picLocks noChangeAspect="1"/>
+          </p:cNvPicPr>
+          <p:nvPr/>
+        </p:nvPicPr>
+        <p:blipFill>
+          <a:blip r:embed="rId5"/>
+          <a:stretch>
+            <a:fillRect/>
+          </a:stretch>
+        </p:blipFill>
+        <p:spPr>
+          <a:xfrm>
+            <a:off x="1122129" y="3584448"/>
+            <a:ext cx="4165684" cy="2468880"/>
+          </a:xfrm>
+          <a:prstGeom prst="rect">
+            <a:avLst/>
+          </a:prstGeom>
+        </p:spPr>
+      </p:pic>
+      <p:pic>
+        <p:nvPicPr>
+          <p:cNvPr id="9" name="Picture 8" descr="Coulomb repulsion between charge elements uniformly distributed along two filaments."/>
+          <p:cNvPicPr>
+            <a:picLocks noChangeAspect="1"/>
+          </p:cNvPicPr>
+          <p:nvPr/>
+        </p:nvPicPr>
+        <p:blipFill>
+          <a:blip r:embed="rId6"/>
+          <a:stretch>
+            <a:fillRect/>
+          </a:stretch>
+        </p:blipFill>
+        <p:spPr>
+          <a:xfrm>
+            <a:off x="7704391" y="3584448"/>
+            <a:ext cx="2870073" cy="2468880"/>
           </a:xfrm>
           <a:prstGeom prst="rect">
             <a:avLst/>

</xml_diff>